<commit_message>
Vortrag 4: Reservefolien, ausgeglichene Sprecheraufteilung, Fragenkatalog
- Präsentation: Folie 7 an Sprecher/in 2, Sprecherangabe auf dem Fazit,
  4 Reservefolien für die 20-Minuten-Variante (gewichteter Mittelwert,
  Chi-Quadrat-Test, Drittvariable Fachbereich, Programmablauf)
- Notebook: Differenz 14.2 Prozentpunkte / Faktor 1.47 wie in Ausarbeitung und Folien
- Neu: Sprecherplan und mögliche Fragen der Lehrperson mit Antworten

Co-Authored-By: Claude Opus 5.5 <noreply@anthropic.com>
Claude-Session: https://claude.ai/code/session_013YcN7q2EjK91BTrikonwXA
</commit_message>
<xml_diff>
--- a/vortrag4/Vortrag4_Praesentation.pptx
+++ b/vortrag4/Vortrag4_Praesentation.pptx
@@ -17,6 +17,10 @@
     <p:sldId id="265" r:id="rId17"/>
     <p:sldId id="266" r:id="rId18"/>
     <p:sldId id="267" r:id="rId19"/>
+    <p:sldId id="268" r:id="rId20"/>
+    <p:sldId id="269" r:id="rId21"/>
+    <p:sldId id="270" r:id="rId22"/>
+    <p:sldId id="271" r:id="rId23"/>
   </p:sldIdLst>
   <p:sldSz cx="12192119" cy="6858000" type="screen4x3"/>
   <p:notesSz cx="6858000" cy="9144000"/>
@@ -513,7 +517,7 @@
           <a:lstStyle/>
           <a:p>
             <a:r>
-              <a:t>Begrüssung, Vorstellung der Gruppe. Ablauf: 1) Funktionen in Python, 2) die Daten und eine scheinbare Ungerechtigkeit, 3) der genaue Vergleich und stochastische Unabhängigkeit. Dauer ca. 15 Minuten.</a:t>
+              <a:t>Begrüssung, Vorstellung der Gruppe. Ablauf: 1) Funktionen in Python, 2) die Daten und eine scheinbare Ungerechtigkeit, 3) der genaue Vergleich und stochastische Unabhängigkeit. Dauer ca. 15 Minuten (3 × 5 Min.: Sprecher/in 1 Folien 1–4, Sprecher/in 2 Folien 5–7, Sprecher/in 3 Folien 8–11). Falls 20 Minuten verlangt sind: Reservefolien 13–16 nach Folie 9 bzw. 10 einschieben.</a:t>
             </a:r>
           </a:p>
         </p:txBody>
@@ -724,6 +728,286 @@
           <a:p>
             <a:r>
               <a:t>Dank, Fragen aus dem Publikum entgegennehmen.</a:t>
+            </a:r>
+          </a:p>
+        </p:txBody>
+      </p:sp>
+      <p:sp>
+        <p:nvSpPr>
+          <p:cNvPr id="4" name="Slide Number Placeholder 3"/>
+          <p:cNvSpPr>
+            <a:spLocks noGrp="1"/>
+          </p:cNvSpPr>
+          <p:nvPr>
+            <p:ph type="sldNum" idx="5" sz="quarter"/>
+          </p:nvPr>
+        </p:nvSpPr>
+        <p:spPr/>
+      </p:sp>
+    </p:spTree>
+  </p:cSld>
+  <p:clrMapOvr>
+    <a:masterClrMapping/>
+  </p:clrMapOvr>
+</p:notes>
+</file>
+
+<file path=ppt/notesSlides/notesSlide13.xml><?xml version="1.0" encoding="utf-8"?>
+<p:notes xmlns:a="http://schemas.openxmlformats.org/drawingml/2006/main" xmlns:p="http://schemas.openxmlformats.org/presentationml/2006/main" xmlns:r="http://schemas.openxmlformats.org/officeDocument/2006/relationships">
+  <p:cSld>
+    <p:spTree>
+      <p:nvGrpSpPr>
+        <p:cNvPr id="1" name=""/>
+        <p:cNvGrpSpPr/>
+        <p:nvPr/>
+      </p:nvGrpSpPr>
+      <p:grpSpPr>
+        <a:xfrm>
+          <a:off x="0" y="0"/>
+          <a:ext cx="0" cy="0"/>
+          <a:chOff x="0" y="0"/>
+          <a:chExt cx="0" cy="0"/>
+        </a:xfrm>
+      </p:grpSpPr>
+      <p:sp>
+        <p:nvSpPr>
+          <p:cNvPr id="2" name="Slide Image Placeholder 1"/>
+          <p:cNvSpPr>
+            <a:spLocks noGrp="1"/>
+          </p:cNvSpPr>
+          <p:nvPr>
+            <p:ph type="sldImg" idx="2"/>
+          </p:nvPr>
+        </p:nvSpPr>
+        <p:spPr/>
+      </p:sp>
+      <p:sp>
+        <p:nvSpPr>
+          <p:cNvPr id="3" name="Notes Placeholder 2"/>
+          <p:cNvSpPr>
+            <a:spLocks noGrp="1"/>
+          </p:cNvSpPr>
+          <p:nvPr>
+            <p:ph type="body" idx="3" sz="quarter"/>
+          </p:nvPr>
+        </p:nvSpPr>
+        <p:spPr/>
+        <p:txBody>
+          <a:bodyPr/>
+          <a:lstStyle/>
+          <a:p>
+            <a:r>
+              <a:t>Einsatz nach Folie 9. Jede Zeile: Anteil der Bewerbungen mal Quote ergibt den Beitrag des Fachbereichs zur Gesamtquote. Frauen: Die grossen Gewichte (C, D, E, F zusammen 92.8 %) liegen bei tiefen Quoten, darum ist die Summe klein. Männer: 51.5 % der Gewichte bei A und B mit hohen Quoten. Summe Männer 44.6 % statt 44.5 % ist nur ein Rundungseffekt von Tabelle 4.</a:t>
+            </a:r>
+          </a:p>
+        </p:txBody>
+      </p:sp>
+      <p:sp>
+        <p:nvSpPr>
+          <p:cNvPr id="4" name="Slide Number Placeholder 3"/>
+          <p:cNvSpPr>
+            <a:spLocks noGrp="1"/>
+          </p:cNvSpPr>
+          <p:nvPr>
+            <p:ph type="sldNum" idx="5" sz="quarter"/>
+          </p:nvPr>
+        </p:nvSpPr>
+        <p:spPr/>
+      </p:sp>
+    </p:spTree>
+  </p:cSld>
+  <p:clrMapOvr>
+    <a:masterClrMapping/>
+  </p:clrMapOvr>
+</p:notes>
+</file>
+
+<file path=ppt/notesSlides/notesSlide14.xml><?xml version="1.0" encoding="utf-8"?>
+<p:notes xmlns:a="http://schemas.openxmlformats.org/drawingml/2006/main" xmlns:p="http://schemas.openxmlformats.org/presentationml/2006/main" xmlns:r="http://schemas.openxmlformats.org/officeDocument/2006/relationships">
+  <p:cSld>
+    <p:spTree>
+      <p:nvGrpSpPr>
+        <p:cNvPr id="1" name=""/>
+        <p:cNvGrpSpPr/>
+        <p:nvPr/>
+      </p:nvGrpSpPr>
+      <p:grpSpPr>
+        <a:xfrm>
+          <a:off x="0" y="0"/>
+          <a:ext cx="0" cy="0"/>
+          <a:chOff x="0" y="0"/>
+          <a:chExt cx="0" cy="0"/>
+        </a:xfrm>
+      </p:grpSpPr>
+      <p:sp>
+        <p:nvSpPr>
+          <p:cNvPr id="2" name="Slide Image Placeholder 1"/>
+          <p:cNvSpPr>
+            <a:spLocks noGrp="1"/>
+          </p:cNvSpPr>
+          <p:nvPr>
+            <p:ph type="sldImg" idx="2"/>
+          </p:nvPr>
+        </p:nvSpPr>
+        <p:spPr/>
+      </p:sp>
+      <p:sp>
+        <p:nvSpPr>
+          <p:cNvPr id="3" name="Notes Placeholder 2"/>
+          <p:cNvSpPr>
+            <a:spLocks noGrp="1"/>
+          </p:cNvSpPr>
+          <p:nvPr>
+            <p:ph type="body" idx="3" sz="quarter"/>
+          </p:nvPr>
+        </p:nvSpPr>
+        <p:spPr/>
+        <p:txBody>
+          <a:bodyPr/>
+          <a:lstStyle/>
+          <a:p>
+            <a:r>
+              <a:t>Einsatz nach Folie 10. Nullhypothese: Zulassung und Geschlecht sind unabhängig. Dann erwarten wir in jeder Zelle n · P(Z) · P(W), z. B. für zugelassene Frauen 4 526 · 0.388 · 0.405 = 711.5. Beobachtet sind aber nur 557. Chi-Quadrat summiert die quadrierten, standardisierten Abweichungen über alle vier Zellen: 92.2. Bei 1 Freiheitsgrad liegt der kritische Wert für alpha = 5 % bei 3.84, also wird H0 klar verworfen (p &lt; 0.001). Im Code: scipy.stats.chi2_contingency(tafel, correction=False).</a:t>
+            </a:r>
+          </a:p>
+        </p:txBody>
+      </p:sp>
+      <p:sp>
+        <p:nvSpPr>
+          <p:cNvPr id="4" name="Slide Number Placeholder 3"/>
+          <p:cNvSpPr>
+            <a:spLocks noGrp="1"/>
+          </p:cNvSpPr>
+          <p:nvPr>
+            <p:ph type="sldNum" idx="5" sz="quarter"/>
+          </p:nvPr>
+        </p:nvSpPr>
+        <p:spPr/>
+      </p:sp>
+    </p:spTree>
+  </p:cSld>
+  <p:clrMapOvr>
+    <a:masterClrMapping/>
+  </p:clrMapOvr>
+</p:notes>
+</file>
+
+<file path=ppt/notesSlides/notesSlide15.xml><?xml version="1.0" encoding="utf-8"?>
+<p:notes xmlns:a="http://schemas.openxmlformats.org/drawingml/2006/main" xmlns:p="http://schemas.openxmlformats.org/presentationml/2006/main" xmlns:r="http://schemas.openxmlformats.org/officeDocument/2006/relationships">
+  <p:cSld>
+    <p:spTree>
+      <p:nvGrpSpPr>
+        <p:cNvPr id="1" name=""/>
+        <p:cNvGrpSpPr/>
+        <p:nvPr/>
+      </p:nvGrpSpPr>
+      <p:grpSpPr>
+        <a:xfrm>
+          <a:off x="0" y="0"/>
+          <a:ext cx="0" cy="0"/>
+          <a:chOff x="0" y="0"/>
+          <a:chExt cx="0" cy="0"/>
+        </a:xfrm>
+      </p:grpSpPr>
+      <p:sp>
+        <p:nvSpPr>
+          <p:cNvPr id="2" name="Slide Image Placeholder 1"/>
+          <p:cNvSpPr>
+            <a:spLocks noGrp="1"/>
+          </p:cNvSpPr>
+          <p:nvPr>
+            <p:ph type="sldImg" idx="2"/>
+          </p:nvPr>
+        </p:nvSpPr>
+        <p:spPr/>
+      </p:sp>
+      <p:sp>
+        <p:nvSpPr>
+          <p:cNvPr id="3" name="Notes Placeholder 2"/>
+          <p:cNvSpPr>
+            <a:spLocks noGrp="1"/>
+          </p:cNvSpPr>
+          <p:nvPr>
+            <p:ph type="body" idx="3" sz="quarter"/>
+          </p:nvPr>
+        </p:nvSpPr>
+        <p:spPr/>
+        <p:txBody>
+          <a:bodyPr/>
+          <a:lstStyle/>
+          <a:p>
+            <a:r>
+              <a:t>Einsatz nach Folie 10 oder bei der Frage nach Kausalität. Der Fachbereich hängt mit beiden Variablen stark zusammen: Geschlecht und Fachbereichswahl (Chi2 = 1068, df = 5) und Fachbereich und Zulassung (Chi2 = 779, df = 5). Der direkte Pfeil Geschlecht -&gt; Zulassung ist innerhalb der Fachbereiche kaum vorhanden (nur A, zugunsten der Frauen). Das ist die Struktur eines Confounders und die Ursache des Simpson-Paradoxons. Korrelation ist nicht Kausalität.</a:t>
+            </a:r>
+          </a:p>
+        </p:txBody>
+      </p:sp>
+      <p:sp>
+        <p:nvSpPr>
+          <p:cNvPr id="4" name="Slide Number Placeholder 3"/>
+          <p:cNvSpPr>
+            <a:spLocks noGrp="1"/>
+          </p:cNvSpPr>
+          <p:nvPr>
+            <p:ph type="sldNum" idx="5" sz="quarter"/>
+          </p:nvPr>
+        </p:nvSpPr>
+        <p:spPr/>
+      </p:sp>
+    </p:spTree>
+  </p:cSld>
+  <p:clrMapOvr>
+    <a:masterClrMapping/>
+  </p:clrMapOvr>
+</p:notes>
+</file>
+
+<file path=ppt/notesSlides/notesSlide16.xml><?xml version="1.0" encoding="utf-8"?>
+<p:notes xmlns:a="http://schemas.openxmlformats.org/drawingml/2006/main" xmlns:p="http://schemas.openxmlformats.org/presentationml/2006/main" xmlns:r="http://schemas.openxmlformats.org/officeDocument/2006/relationships">
+  <p:cSld>
+    <p:spTree>
+      <p:nvGrpSpPr>
+        <p:cNvPr id="1" name=""/>
+        <p:cNvGrpSpPr/>
+        <p:nvPr/>
+      </p:nvGrpSpPr>
+      <p:grpSpPr>
+        <a:xfrm>
+          <a:off x="0" y="0"/>
+          <a:ext cx="0" cy="0"/>
+          <a:chOff x="0" y="0"/>
+          <a:chExt cx="0" cy="0"/>
+        </a:xfrm>
+      </p:grpSpPr>
+      <p:sp>
+        <p:nvSpPr>
+          <p:cNvPr id="2" name="Slide Image Placeholder 1"/>
+          <p:cNvSpPr>
+            <a:spLocks noGrp="1"/>
+          </p:cNvSpPr>
+          <p:nvPr>
+            <p:ph type="sldImg" idx="2"/>
+          </p:nvPr>
+        </p:nvSpPr>
+        <p:spPr/>
+      </p:sp>
+      <p:sp>
+        <p:nvSpPr>
+          <p:cNvPr id="3" name="Notes Placeholder 2"/>
+          <p:cNvSpPr>
+            <a:spLocks noGrp="1"/>
+          </p:cNvSpPr>
+          <p:nvPr>
+            <p:ph type="body" idx="3" sz="quarter"/>
+          </p:nvPr>
+        </p:nvSpPr>
+        <p:spPr/>
+        <p:txBody>
+          <a:bodyPr/>
+          <a:lstStyle/>
+          <a:p>
+            <a:r>
+              <a:t>Einsatz nach Folie 5, falls nach dem Aufbau des Codes gefragt wird. Der Code läuft in fünf Schritten: Tabelle 4 als Text erfassen und mit einer Liste von Funktionen bereinigen; mit dem Satz der totalen Wahrscheinlichkeit plausibilisieren; Originalanzahlen in ein langes DataFrame laden und gegen Tabelle 4 prüfen; mit denselben Funktionen gesamt und je Fachbereich analysieren; Diagramme mit einheitlichen Farben als PNG speichern. Jeder Schritt ist eine eigene Notebook-Zelle.</a:t>
             </a:r>
           </a:p>
         </p:txBody>
@@ -5871,6 +6155,3148 @@
 </p:sld>
 </file>
 
+<file path=ppt/slides/slide13.xml><?xml version="1.0" encoding="utf-8"?>
+<p:sld xmlns:a="http://schemas.openxmlformats.org/drawingml/2006/main" xmlns:p="http://schemas.openxmlformats.org/presentationml/2006/main" xmlns:r="http://schemas.openxmlformats.org/officeDocument/2006/relationships">
+  <p:cSld>
+    <p:spTree>
+      <p:nvGrpSpPr>
+        <p:cNvPr id="1" name=""/>
+        <p:cNvGrpSpPr/>
+        <p:nvPr/>
+      </p:nvGrpSpPr>
+      <p:grpSpPr/>
+      <p:sp>
+        <p:nvSpPr>
+          <p:cNvPr id="2" name="Rectangle 1"/>
+          <p:cNvSpPr/>
+          <p:nvPr/>
+        </p:nvSpPr>
+        <p:spPr>
+          <a:xfrm>
+            <a:off x="0" y="0"/>
+            <a:ext cx="12192119" cy="125999"/>
+          </a:xfrm>
+          <a:prstGeom prst="rect">
+            <a:avLst/>
+          </a:prstGeom>
+          <a:solidFill>
+            <a:srgbClr val="1F3A5F"/>
+          </a:solidFill>
+          <a:ln>
+            <a:noFill/>
+          </a:ln>
+          <a:effectLst/>
+        </p:spPr>
+        <p:style>
+          <a:lnRef idx="1">
+            <a:schemeClr val="accent1"/>
+          </a:lnRef>
+          <a:fillRef idx="3">
+            <a:schemeClr val="accent1"/>
+          </a:fillRef>
+          <a:effectRef idx="2">
+            <a:schemeClr val="accent1"/>
+          </a:effectRef>
+          <a:fontRef idx="minor">
+            <a:schemeClr val="lt1"/>
+          </a:fontRef>
+        </p:style>
+        <p:txBody>
+          <a:bodyPr rtlCol="0" anchor="ctr"/>
+          <a:lstStyle/>
+          <a:p>
+            <a:pPr algn="ctr"/>
+          </a:p>
+        </p:txBody>
+      </p:sp>
+      <p:sp>
+        <p:nvSpPr>
+          <p:cNvPr id="3" name="TextBox 2"/>
+          <p:cNvSpPr txBox="1"/>
+          <p:nvPr/>
+        </p:nvSpPr>
+        <p:spPr>
+          <a:xfrm>
+            <a:off x="540000" y="324000"/>
+            <a:ext cx="11160000" cy="720000"/>
+          </a:xfrm>
+          <a:prstGeom prst="rect">
+            <a:avLst/>
+          </a:prstGeom>
+          <a:noFill/>
+        </p:spPr>
+        <p:txBody>
+          <a:bodyPr wrap="square">
+            <a:spAutoFit/>
+          </a:bodyPr>
+          <a:lstStyle/>
+          <a:p>
+            <a:pPr>
+              <a:spcAft>
+                <a:spcPts val="855"/>
+              </a:spcAft>
+            </a:pPr>
+            <a:r>
+              <a:rPr sz="3000" b="1">
+                <a:solidFill>
+                  <a:srgbClr val="1F3A5F"/>
+                </a:solidFill>
+                <a:latin typeface="Calibri"/>
+              </a:rPr>
+              <a:t>Reserve: Gesamtquote als gewichteter Mittelwert</a:t>
+            </a:r>
+          </a:p>
+        </p:txBody>
+      </p:sp>
+      <p:sp>
+        <p:nvSpPr>
+          <p:cNvPr id="4" name="TextBox 3"/>
+          <p:cNvSpPr txBox="1"/>
+          <p:nvPr/>
+        </p:nvSpPr>
+        <p:spPr>
+          <a:xfrm>
+            <a:off x="9360000" y="6372000"/>
+            <a:ext cx="2520000" cy="360000"/>
+          </a:xfrm>
+          <a:prstGeom prst="rect">
+            <a:avLst/>
+          </a:prstGeom>
+          <a:noFill/>
+        </p:spPr>
+        <p:txBody>
+          <a:bodyPr wrap="square">
+            <a:spAutoFit/>
+          </a:bodyPr>
+          <a:lstStyle/>
+          <a:p>
+            <a:pPr>
+              <a:spcAft>
+                <a:spcPts val="855"/>
+              </a:spcAft>
+            </a:pPr>
+            <a:r>
+              <a:rPr sz="1100" b="0">
+                <a:solidFill>
+                  <a:srgbClr val="52514E"/>
+                </a:solidFill>
+                <a:latin typeface="Calibri"/>
+              </a:rPr>
+              <a:t>Reserve (Sprecher/in 3)</a:t>
+            </a:r>
+          </a:p>
+        </p:txBody>
+      </p:sp>
+      <p:sp>
+        <p:nvSpPr>
+          <p:cNvPr id="5" name="TextBox 4"/>
+          <p:cNvSpPr txBox="1"/>
+          <p:nvPr/>
+        </p:nvSpPr>
+        <p:spPr>
+          <a:xfrm>
+            <a:off x="540000" y="1150000"/>
+            <a:ext cx="11160000" cy="500000"/>
+          </a:xfrm>
+          <a:prstGeom prst="rect">
+            <a:avLst/>
+          </a:prstGeom>
+          <a:noFill/>
+        </p:spPr>
+        <p:txBody>
+          <a:bodyPr wrap="square">
+            <a:spAutoFit/>
+          </a:bodyPr>
+          <a:lstStyle/>
+          <a:p>
+            <a:pPr>
+              <a:spcAft>
+                <a:spcPts val="855"/>
+              </a:spcAft>
+            </a:pPr>
+            <a:r>
+              <a:rPr sz="1800" b="1">
+                <a:solidFill>
+                  <a:srgbClr val="1F3A5F"/>
+                </a:solidFill>
+                <a:latin typeface="Calibri"/>
+              </a:rPr>
+              <a:t>P(Z | G) = Σᵢ P(Fᵢ | G) · P(Z | Fᵢ, G)   –   Beitrag je Fachbereich = Anteil × Quote</a:t>
+            </a:r>
+          </a:p>
+        </p:txBody>
+      </p:sp>
+      <p:graphicFrame>
+        <p:nvGraphicFramePr>
+          <p:cNvPr id="6" name="Table 5"/>
+          <p:cNvGraphicFramePr>
+            <a:graphicFrameLocks noGrp="1"/>
+          </p:cNvGraphicFramePr>
+          <p:nvPr/>
+        </p:nvGraphicFramePr>
+        <p:xfrm>
+          <a:off x="540000" y="1750000"/>
+          <a:ext cx="11100000" cy="3360000"/>
+        </p:xfrm>
+        <a:graphic>
+          <a:graphicData uri="http://schemas.openxmlformats.org/drawingml/2006/table">
+            <a:tbl>
+              <a:tblPr firstRow="1" bandRow="1">
+                <a:tableStyleId>{5C22544A-7EE6-4342-B048-85BDC9FD1C3A}</a:tableStyleId>
+              </a:tblPr>
+              <a:tblGrid>
+                <a:gridCol w="900000"/>
+                <a:gridCol w="1700000"/>
+                <a:gridCol w="1700000"/>
+                <a:gridCol w="1700000"/>
+                <a:gridCol w="1700000"/>
+                <a:gridCol w="1700000"/>
+                <a:gridCol w="1700000"/>
+              </a:tblGrid>
+              <a:tr h="420000">
+                <a:tc>
+                  <a:txBody>
+                    <a:bodyPr/>
+                    <a:lstStyle/>
+                    <a:p>
+                      <a:r>
+                        <a:rPr sz="1400" b="1"/>
+                        <a:t>FB</a:t>
+                      </a:r>
+                    </a:p>
+                  </a:txBody>
+                  <a:tcPr/>
+                </a:tc>
+                <a:tc>
+                  <a:txBody>
+                    <a:bodyPr/>
+                    <a:lstStyle/>
+                    <a:p>
+                      <a:r>
+                        <a:rPr sz="1400" b="1"/>
+                        <a:t>Anteil F</a:t>
+                      </a:r>
+                    </a:p>
+                  </a:txBody>
+                  <a:tcPr/>
+                </a:tc>
+                <a:tc>
+                  <a:txBody>
+                    <a:bodyPr/>
+                    <a:lstStyle/>
+                    <a:p>
+                      <a:r>
+                        <a:rPr sz="1400" b="1"/>
+                        <a:t>Quote F</a:t>
+                      </a:r>
+                    </a:p>
+                  </a:txBody>
+                  <a:tcPr/>
+                </a:tc>
+                <a:tc>
+                  <a:txBody>
+                    <a:bodyPr/>
+                    <a:lstStyle/>
+                    <a:p>
+                      <a:r>
+                        <a:rPr sz="1400" b="1"/>
+                        <a:t>Beitrag F</a:t>
+                      </a:r>
+                    </a:p>
+                  </a:txBody>
+                  <a:tcPr/>
+                </a:tc>
+                <a:tc>
+                  <a:txBody>
+                    <a:bodyPr/>
+                    <a:lstStyle/>
+                    <a:p>
+                      <a:r>
+                        <a:rPr sz="1400" b="1"/>
+                        <a:t>Anteil M</a:t>
+                      </a:r>
+                    </a:p>
+                  </a:txBody>
+                  <a:tcPr/>
+                </a:tc>
+                <a:tc>
+                  <a:txBody>
+                    <a:bodyPr/>
+                    <a:lstStyle/>
+                    <a:p>
+                      <a:r>
+                        <a:rPr sz="1400" b="1"/>
+                        <a:t>Quote M</a:t>
+                      </a:r>
+                    </a:p>
+                  </a:txBody>
+                  <a:tcPr/>
+                </a:tc>
+                <a:tc>
+                  <a:txBody>
+                    <a:bodyPr/>
+                    <a:lstStyle/>
+                    <a:p>
+                      <a:r>
+                        <a:rPr sz="1400" b="1"/>
+                        <a:t>Beitrag M</a:t>
+                      </a:r>
+                    </a:p>
+                  </a:txBody>
+                  <a:tcPr/>
+                </a:tc>
+              </a:tr>
+              <a:tr h="420000">
+                <a:tc>
+                  <a:txBody>
+                    <a:bodyPr/>
+                    <a:lstStyle/>
+                    <a:p>
+                      <a:r>
+                        <a:rPr sz="1400" b="0"/>
+                        <a:t>A</a:t>
+                      </a:r>
+                    </a:p>
+                  </a:txBody>
+                  <a:tcPr/>
+                </a:tc>
+                <a:tc>
+                  <a:txBody>
+                    <a:bodyPr/>
+                    <a:lstStyle/>
+                    <a:p>
+                      <a:r>
+                        <a:rPr sz="1400" b="0"/>
+                        <a:t>5.9 %</a:t>
+                      </a:r>
+                    </a:p>
+                  </a:txBody>
+                  <a:tcPr/>
+                </a:tc>
+                <a:tc>
+                  <a:txBody>
+                    <a:bodyPr/>
+                    <a:lstStyle/>
+                    <a:p>
+                      <a:r>
+                        <a:rPr sz="1400" b="0"/>
+                        <a:t>82.4 %</a:t>
+                      </a:r>
+                    </a:p>
+                  </a:txBody>
+                  <a:tcPr/>
+                </a:tc>
+                <a:tc>
+                  <a:txBody>
+                    <a:bodyPr/>
+                    <a:lstStyle/>
+                    <a:p>
+                      <a:r>
+                        <a:rPr sz="1400" b="0"/>
+                        <a:t>4.9 %</a:t>
+                      </a:r>
+                    </a:p>
+                  </a:txBody>
+                  <a:tcPr/>
+                </a:tc>
+                <a:tc>
+                  <a:txBody>
+                    <a:bodyPr/>
+                    <a:lstStyle/>
+                    <a:p>
+                      <a:r>
+                        <a:rPr sz="1400" b="0"/>
+                        <a:t>30.7 %</a:t>
+                      </a:r>
+                    </a:p>
+                  </a:txBody>
+                  <a:tcPr/>
+                </a:tc>
+                <a:tc>
+                  <a:txBody>
+                    <a:bodyPr/>
+                    <a:lstStyle/>
+                    <a:p>
+                      <a:r>
+                        <a:rPr sz="1400" b="0"/>
+                        <a:t>62.1 %</a:t>
+                      </a:r>
+                    </a:p>
+                  </a:txBody>
+                  <a:tcPr/>
+                </a:tc>
+                <a:tc>
+                  <a:txBody>
+                    <a:bodyPr/>
+                    <a:lstStyle/>
+                    <a:p>
+                      <a:r>
+                        <a:rPr sz="1400" b="0"/>
+                        <a:t>19.1 %</a:t>
+                      </a:r>
+                    </a:p>
+                  </a:txBody>
+                  <a:tcPr/>
+                </a:tc>
+              </a:tr>
+              <a:tr h="420000">
+                <a:tc>
+                  <a:txBody>
+                    <a:bodyPr/>
+                    <a:lstStyle/>
+                    <a:p>
+                      <a:r>
+                        <a:rPr sz="1400" b="0"/>
+                        <a:t>B</a:t>
+                      </a:r>
+                    </a:p>
+                  </a:txBody>
+                  <a:tcPr/>
+                </a:tc>
+                <a:tc>
+                  <a:txBody>
+                    <a:bodyPr/>
+                    <a:lstStyle/>
+                    <a:p>
+                      <a:r>
+                        <a:rPr sz="1400" b="0"/>
+                        <a:t>1.4 %</a:t>
+                      </a:r>
+                    </a:p>
+                  </a:txBody>
+                  <a:tcPr/>
+                </a:tc>
+                <a:tc>
+                  <a:txBody>
+                    <a:bodyPr/>
+                    <a:lstStyle/>
+                    <a:p>
+                      <a:r>
+                        <a:rPr sz="1400" b="0"/>
+                        <a:t>68.0 %</a:t>
+                      </a:r>
+                    </a:p>
+                  </a:txBody>
+                  <a:tcPr/>
+                </a:tc>
+                <a:tc>
+                  <a:txBody>
+                    <a:bodyPr/>
+                    <a:lstStyle/>
+                    <a:p>
+                      <a:r>
+                        <a:rPr sz="1400" b="0"/>
+                        <a:t>1.0 %</a:t>
+                      </a:r>
+                    </a:p>
+                  </a:txBody>
+                  <a:tcPr/>
+                </a:tc>
+                <a:tc>
+                  <a:txBody>
+                    <a:bodyPr/>
+                    <a:lstStyle/>
+                    <a:p>
+                      <a:r>
+                        <a:rPr sz="1400" b="0"/>
+                        <a:t>20.8 %</a:t>
+                      </a:r>
+                    </a:p>
+                  </a:txBody>
+                  <a:tcPr/>
+                </a:tc>
+                <a:tc>
+                  <a:txBody>
+                    <a:bodyPr/>
+                    <a:lstStyle/>
+                    <a:p>
+                      <a:r>
+                        <a:rPr sz="1400" b="0"/>
+                        <a:t>63.0 %</a:t>
+                      </a:r>
+                    </a:p>
+                  </a:txBody>
+                  <a:tcPr/>
+                </a:tc>
+                <a:tc>
+                  <a:txBody>
+                    <a:bodyPr/>
+                    <a:lstStyle/>
+                    <a:p>
+                      <a:r>
+                        <a:rPr sz="1400" b="0"/>
+                        <a:t>13.1 %</a:t>
+                      </a:r>
+                    </a:p>
+                  </a:txBody>
+                  <a:tcPr/>
+                </a:tc>
+              </a:tr>
+              <a:tr h="420000">
+                <a:tc>
+                  <a:txBody>
+                    <a:bodyPr/>
+                    <a:lstStyle/>
+                    <a:p>
+                      <a:r>
+                        <a:rPr sz="1400" b="0"/>
+                        <a:t>C</a:t>
+                      </a:r>
+                    </a:p>
+                  </a:txBody>
+                  <a:tcPr/>
+                </a:tc>
+                <a:tc>
+                  <a:txBody>
+                    <a:bodyPr/>
+                    <a:lstStyle/>
+                    <a:p>
+                      <a:r>
+                        <a:rPr sz="1400" b="0"/>
+                        <a:t>32.3 %</a:t>
+                      </a:r>
+                    </a:p>
+                  </a:txBody>
+                  <a:tcPr/>
+                </a:tc>
+                <a:tc>
+                  <a:txBody>
+                    <a:bodyPr/>
+                    <a:lstStyle/>
+                    <a:p>
+                      <a:r>
+                        <a:rPr sz="1400" b="0"/>
+                        <a:t>34.1 %</a:t>
+                      </a:r>
+                    </a:p>
+                  </a:txBody>
+                  <a:tcPr/>
+                </a:tc>
+                <a:tc>
+                  <a:txBody>
+                    <a:bodyPr/>
+                    <a:lstStyle/>
+                    <a:p>
+                      <a:r>
+                        <a:rPr sz="1400" b="0"/>
+                        <a:t>11.0 %</a:t>
+                      </a:r>
+                    </a:p>
+                  </a:txBody>
+                  <a:tcPr/>
+                </a:tc>
+                <a:tc>
+                  <a:txBody>
+                    <a:bodyPr/>
+                    <a:lstStyle/>
+                    <a:p>
+                      <a:r>
+                        <a:rPr sz="1400" b="0"/>
+                        <a:t>12.1 %</a:t>
+                      </a:r>
+                    </a:p>
+                  </a:txBody>
+                  <a:tcPr/>
+                </a:tc>
+                <a:tc>
+                  <a:txBody>
+                    <a:bodyPr/>
+                    <a:lstStyle/>
+                    <a:p>
+                      <a:r>
+                        <a:rPr sz="1400" b="0"/>
+                        <a:t>36.9 %</a:t>
+                      </a:r>
+                    </a:p>
+                  </a:txBody>
+                  <a:tcPr/>
+                </a:tc>
+                <a:tc>
+                  <a:txBody>
+                    <a:bodyPr/>
+                    <a:lstStyle/>
+                    <a:p>
+                      <a:r>
+                        <a:rPr sz="1400" b="0"/>
+                        <a:t>4.5 %</a:t>
+                      </a:r>
+                    </a:p>
+                  </a:txBody>
+                  <a:tcPr/>
+                </a:tc>
+              </a:tr>
+              <a:tr h="420000">
+                <a:tc>
+                  <a:txBody>
+                    <a:bodyPr/>
+                    <a:lstStyle/>
+                    <a:p>
+                      <a:r>
+                        <a:rPr sz="1400" b="0"/>
+                        <a:t>D</a:t>
+                      </a:r>
+                    </a:p>
+                  </a:txBody>
+                  <a:tcPr/>
+                </a:tc>
+                <a:tc>
+                  <a:txBody>
+                    <a:bodyPr/>
+                    <a:lstStyle/>
+                    <a:p>
+                      <a:r>
+                        <a:rPr sz="1400" b="0"/>
+                        <a:t>20.4 %</a:t>
+                      </a:r>
+                    </a:p>
+                  </a:txBody>
+                  <a:tcPr/>
+                </a:tc>
+                <a:tc>
+                  <a:txBody>
+                    <a:bodyPr/>
+                    <a:lstStyle/>
+                    <a:p>
+                      <a:r>
+                        <a:rPr sz="1400" b="0"/>
+                        <a:t>34.9 %</a:t>
+                      </a:r>
+                    </a:p>
+                  </a:txBody>
+                  <a:tcPr/>
+                </a:tc>
+                <a:tc>
+                  <a:txBody>
+                    <a:bodyPr/>
+                    <a:lstStyle/>
+                    <a:p>
+                      <a:r>
+                        <a:rPr sz="1400" b="0"/>
+                        <a:t>7.1 %</a:t>
+                      </a:r>
+                    </a:p>
+                  </a:txBody>
+                  <a:tcPr/>
+                </a:tc>
+                <a:tc>
+                  <a:txBody>
+                    <a:bodyPr/>
+                    <a:lstStyle/>
+                    <a:p>
+                      <a:r>
+                        <a:rPr sz="1400" b="0"/>
+                        <a:t>15.5 %</a:t>
+                      </a:r>
+                    </a:p>
+                  </a:txBody>
+                  <a:tcPr/>
+                </a:tc>
+                <a:tc>
+                  <a:txBody>
+                    <a:bodyPr/>
+                    <a:lstStyle/>
+                    <a:p>
+                      <a:r>
+                        <a:rPr sz="1400" b="0"/>
+                        <a:t>33.1 %</a:t>
+                      </a:r>
+                    </a:p>
+                  </a:txBody>
+                  <a:tcPr/>
+                </a:tc>
+                <a:tc>
+                  <a:txBody>
+                    <a:bodyPr/>
+                    <a:lstStyle/>
+                    <a:p>
+                      <a:r>
+                        <a:rPr sz="1400" b="0"/>
+                        <a:t>5.1 %</a:t>
+                      </a:r>
+                    </a:p>
+                  </a:txBody>
+                  <a:tcPr/>
+                </a:tc>
+              </a:tr>
+              <a:tr h="420000">
+                <a:tc>
+                  <a:txBody>
+                    <a:bodyPr/>
+                    <a:lstStyle/>
+                    <a:p>
+                      <a:r>
+                        <a:rPr sz="1400" b="0"/>
+                        <a:t>E</a:t>
+                      </a:r>
+                    </a:p>
+                  </a:txBody>
+                  <a:tcPr/>
+                </a:tc>
+                <a:tc>
+                  <a:txBody>
+                    <a:bodyPr/>
+                    <a:lstStyle/>
+                    <a:p>
+                      <a:r>
+                        <a:rPr sz="1400" b="0"/>
+                        <a:t>21.4 %</a:t>
+                      </a:r>
+                    </a:p>
+                  </a:txBody>
+                  <a:tcPr/>
+                </a:tc>
+                <a:tc>
+                  <a:txBody>
+                    <a:bodyPr/>
+                    <a:lstStyle/>
+                    <a:p>
+                      <a:r>
+                        <a:rPr sz="1400" b="0"/>
+                        <a:t>23.9 %</a:t>
+                      </a:r>
+                    </a:p>
+                  </a:txBody>
+                  <a:tcPr/>
+                </a:tc>
+                <a:tc>
+                  <a:txBody>
+                    <a:bodyPr/>
+                    <a:lstStyle/>
+                    <a:p>
+                      <a:r>
+                        <a:rPr sz="1400" b="0"/>
+                        <a:t>5.1 %</a:t>
+                      </a:r>
+                    </a:p>
+                  </a:txBody>
+                  <a:tcPr/>
+                </a:tc>
+                <a:tc>
+                  <a:txBody>
+                    <a:bodyPr/>
+                    <a:lstStyle/>
+                    <a:p>
+                      <a:r>
+                        <a:rPr sz="1400" b="0"/>
+                        <a:t>7.1 %</a:t>
+                      </a:r>
+                    </a:p>
+                  </a:txBody>
+                  <a:tcPr/>
+                </a:tc>
+                <a:tc>
+                  <a:txBody>
+                    <a:bodyPr/>
+                    <a:lstStyle/>
+                    <a:p>
+                      <a:r>
+                        <a:rPr sz="1400" b="0"/>
+                        <a:t>27.7 %</a:t>
+                      </a:r>
+                    </a:p>
+                  </a:txBody>
+                  <a:tcPr/>
+                </a:tc>
+                <a:tc>
+                  <a:txBody>
+                    <a:bodyPr/>
+                    <a:lstStyle/>
+                    <a:p>
+                      <a:r>
+                        <a:rPr sz="1400" b="0"/>
+                        <a:t>2.0 %</a:t>
+                      </a:r>
+                    </a:p>
+                  </a:txBody>
+                  <a:tcPr/>
+                </a:tc>
+              </a:tr>
+              <a:tr h="420000">
+                <a:tc>
+                  <a:txBody>
+                    <a:bodyPr/>
+                    <a:lstStyle/>
+                    <a:p>
+                      <a:r>
+                        <a:rPr sz="1400" b="0"/>
+                        <a:t>F</a:t>
+                      </a:r>
+                    </a:p>
+                  </a:txBody>
+                  <a:tcPr/>
+                </a:tc>
+                <a:tc>
+                  <a:txBody>
+                    <a:bodyPr/>
+                    <a:lstStyle/>
+                    <a:p>
+                      <a:r>
+                        <a:rPr sz="1400" b="0"/>
+                        <a:t>18.6 %</a:t>
+                      </a:r>
+                    </a:p>
+                  </a:txBody>
+                  <a:tcPr/>
+                </a:tc>
+                <a:tc>
+                  <a:txBody>
+                    <a:bodyPr/>
+                    <a:lstStyle/>
+                    <a:p>
+                      <a:r>
+                        <a:rPr sz="1400" b="0"/>
+                        <a:t>7.0 %</a:t>
+                      </a:r>
+                    </a:p>
+                  </a:txBody>
+                  <a:tcPr/>
+                </a:tc>
+                <a:tc>
+                  <a:txBody>
+                    <a:bodyPr/>
+                    <a:lstStyle/>
+                    <a:p>
+                      <a:r>
+                        <a:rPr sz="1400" b="0"/>
+                        <a:t>1.3 %</a:t>
+                      </a:r>
+                    </a:p>
+                  </a:txBody>
+                  <a:tcPr/>
+                </a:tc>
+                <a:tc>
+                  <a:txBody>
+                    <a:bodyPr/>
+                    <a:lstStyle/>
+                    <a:p>
+                      <a:r>
+                        <a:rPr sz="1400" b="0"/>
+                        <a:t>13.9 %</a:t>
+                      </a:r>
+                    </a:p>
+                  </a:txBody>
+                  <a:tcPr/>
+                </a:tc>
+                <a:tc>
+                  <a:txBody>
+                    <a:bodyPr/>
+                    <a:lstStyle/>
+                    <a:p>
+                      <a:r>
+                        <a:rPr sz="1400" b="0"/>
+                        <a:t>5.9 %</a:t>
+                      </a:r>
+                    </a:p>
+                  </a:txBody>
+                  <a:tcPr/>
+                </a:tc>
+                <a:tc>
+                  <a:txBody>
+                    <a:bodyPr/>
+                    <a:lstStyle/>
+                    <a:p>
+                      <a:r>
+                        <a:rPr sz="1400" b="0"/>
+                        <a:t>0.8 %</a:t>
+                      </a:r>
+                    </a:p>
+                  </a:txBody>
+                  <a:tcPr/>
+                </a:tc>
+              </a:tr>
+              <a:tr h="420000">
+                <a:tc>
+                  <a:txBody>
+                    <a:bodyPr/>
+                    <a:lstStyle/>
+                    <a:p>
+                      <a:r>
+                        <a:rPr sz="1400" b="1"/>
+                        <a:t>Σ</a:t>
+                      </a:r>
+                    </a:p>
+                  </a:txBody>
+                  <a:tcPr/>
+                </a:tc>
+                <a:tc>
+                  <a:txBody>
+                    <a:bodyPr/>
+                    <a:lstStyle/>
+                    <a:p>
+                      <a:r>
+                        <a:rPr sz="1400" b="1"/>
+                        <a:t>100 %</a:t>
+                      </a:r>
+                    </a:p>
+                  </a:txBody>
+                  <a:tcPr/>
+                </a:tc>
+                <a:tc>
+                  <a:txBody>
+                    <a:bodyPr/>
+                    <a:lstStyle/>
+                    <a:p/>
+                  </a:txBody>
+                  <a:tcPr/>
+                </a:tc>
+                <a:tc>
+                  <a:txBody>
+                    <a:bodyPr/>
+                    <a:lstStyle/>
+                    <a:p>
+                      <a:r>
+                        <a:rPr sz="1400" b="1"/>
+                        <a:t>30.4 %</a:t>
+                      </a:r>
+                    </a:p>
+                  </a:txBody>
+                  <a:tcPr/>
+                </a:tc>
+                <a:tc>
+                  <a:txBody>
+                    <a:bodyPr/>
+                    <a:lstStyle/>
+                    <a:p>
+                      <a:r>
+                        <a:rPr sz="1400" b="1"/>
+                        <a:t>100 %</a:t>
+                      </a:r>
+                    </a:p>
+                  </a:txBody>
+                  <a:tcPr/>
+                </a:tc>
+                <a:tc>
+                  <a:txBody>
+                    <a:bodyPr/>
+                    <a:lstStyle/>
+                    <a:p/>
+                  </a:txBody>
+                  <a:tcPr/>
+                </a:tc>
+                <a:tc>
+                  <a:txBody>
+                    <a:bodyPr/>
+                    <a:lstStyle/>
+                    <a:p>
+                      <a:r>
+                        <a:rPr sz="1400" b="1"/>
+                        <a:t>44.6 %</a:t>
+                      </a:r>
+                    </a:p>
+                  </a:txBody>
+                  <a:tcPr/>
+                </a:tc>
+              </a:tr>
+            </a:tbl>
+          </a:graphicData>
+        </a:graphic>
+      </p:graphicFrame>
+      <p:sp>
+        <p:nvSpPr>
+          <p:cNvPr id="7" name="TextBox 6"/>
+          <p:cNvSpPr txBox="1"/>
+          <p:nvPr/>
+        </p:nvSpPr>
+        <p:spPr>
+          <a:xfrm>
+            <a:off x="540000" y="5250000"/>
+            <a:ext cx="11160000" cy="700000"/>
+          </a:xfrm>
+          <a:prstGeom prst="rect">
+            <a:avLst/>
+          </a:prstGeom>
+          <a:noFill/>
+        </p:spPr>
+        <p:txBody>
+          <a:bodyPr wrap="square">
+            <a:spAutoFit/>
+          </a:bodyPr>
+          <a:lstStyle/>
+          <a:p>
+            <a:pPr>
+              <a:spcAft>
+                <a:spcPts val="855"/>
+              </a:spcAft>
+            </a:pPr>
+            <a:r>
+              <a:rPr sz="1600" b="0">
+                <a:solidFill>
+                  <a:srgbClr val="1F3A5F"/>
+                </a:solidFill>
+                <a:latin typeface="Calibri"/>
+              </a:rPr>
+              <a:t>Frauen haben ihre grossen Gewichte bei den tiefen Quoten (C–F), Männer bei den hohen (A, B). Deshalb ist die Summe der Frauen klein, obwohl ihre Quoten je Fachbereich meist höher sind.</a:t>
+            </a:r>
+          </a:p>
+        </p:txBody>
+      </p:sp>
+    </p:spTree>
+  </p:cSld>
+  <p:clrMapOvr>
+    <a:masterClrMapping/>
+  </p:clrMapOvr>
+</p:sld>
+</file>
+
+<file path=ppt/slides/slide14.xml><?xml version="1.0" encoding="utf-8"?>
+<p:sld xmlns:a="http://schemas.openxmlformats.org/drawingml/2006/main" xmlns:p="http://schemas.openxmlformats.org/presentationml/2006/main" xmlns:r="http://schemas.openxmlformats.org/officeDocument/2006/relationships">
+  <p:cSld>
+    <p:spTree>
+      <p:nvGrpSpPr>
+        <p:cNvPr id="1" name=""/>
+        <p:cNvGrpSpPr/>
+        <p:nvPr/>
+      </p:nvGrpSpPr>
+      <p:grpSpPr/>
+      <p:sp>
+        <p:nvSpPr>
+          <p:cNvPr id="2" name="Rectangle 1"/>
+          <p:cNvSpPr/>
+          <p:nvPr/>
+        </p:nvSpPr>
+        <p:spPr>
+          <a:xfrm>
+            <a:off x="0" y="0"/>
+            <a:ext cx="12192119" cy="125999"/>
+          </a:xfrm>
+          <a:prstGeom prst="rect">
+            <a:avLst/>
+          </a:prstGeom>
+          <a:solidFill>
+            <a:srgbClr val="1F3A5F"/>
+          </a:solidFill>
+          <a:ln>
+            <a:noFill/>
+          </a:ln>
+          <a:effectLst/>
+        </p:spPr>
+        <p:style>
+          <a:lnRef idx="1">
+            <a:schemeClr val="accent1"/>
+          </a:lnRef>
+          <a:fillRef idx="3">
+            <a:schemeClr val="accent1"/>
+          </a:fillRef>
+          <a:effectRef idx="2">
+            <a:schemeClr val="accent1"/>
+          </a:effectRef>
+          <a:fontRef idx="minor">
+            <a:schemeClr val="lt1"/>
+          </a:fontRef>
+        </p:style>
+        <p:txBody>
+          <a:bodyPr rtlCol="0" anchor="ctr"/>
+          <a:lstStyle/>
+          <a:p>
+            <a:pPr algn="ctr"/>
+          </a:p>
+        </p:txBody>
+      </p:sp>
+      <p:sp>
+        <p:nvSpPr>
+          <p:cNvPr id="3" name="TextBox 2"/>
+          <p:cNvSpPr txBox="1"/>
+          <p:nvPr/>
+        </p:nvSpPr>
+        <p:spPr>
+          <a:xfrm>
+            <a:off x="540000" y="324000"/>
+            <a:ext cx="11160000" cy="720000"/>
+          </a:xfrm>
+          <a:prstGeom prst="rect">
+            <a:avLst/>
+          </a:prstGeom>
+          <a:noFill/>
+        </p:spPr>
+        <p:txBody>
+          <a:bodyPr wrap="square">
+            <a:spAutoFit/>
+          </a:bodyPr>
+          <a:lstStyle/>
+          <a:p>
+            <a:pPr>
+              <a:spcAft>
+                <a:spcPts val="855"/>
+              </a:spcAft>
+            </a:pPr>
+            <a:r>
+              <a:rPr sz="3000" b="1">
+                <a:solidFill>
+                  <a:srgbClr val="1F3A5F"/>
+                </a:solidFill>
+                <a:latin typeface="Calibri"/>
+              </a:rPr>
+              <a:t>Reserve: So funktioniert der Chi-Quadrat-Test</a:t>
+            </a:r>
+          </a:p>
+        </p:txBody>
+      </p:sp>
+      <p:sp>
+        <p:nvSpPr>
+          <p:cNvPr id="4" name="TextBox 3"/>
+          <p:cNvSpPr txBox="1"/>
+          <p:nvPr/>
+        </p:nvSpPr>
+        <p:spPr>
+          <a:xfrm>
+            <a:off x="9360000" y="6372000"/>
+            <a:ext cx="2520000" cy="360000"/>
+          </a:xfrm>
+          <a:prstGeom prst="rect">
+            <a:avLst/>
+          </a:prstGeom>
+          <a:noFill/>
+        </p:spPr>
+        <p:txBody>
+          <a:bodyPr wrap="square">
+            <a:spAutoFit/>
+          </a:bodyPr>
+          <a:lstStyle/>
+          <a:p>
+            <a:pPr>
+              <a:spcAft>
+                <a:spcPts val="855"/>
+              </a:spcAft>
+            </a:pPr>
+            <a:r>
+              <a:rPr sz="1100" b="0">
+                <a:solidFill>
+                  <a:srgbClr val="52514E"/>
+                </a:solidFill>
+                <a:latin typeface="Calibri"/>
+              </a:rPr>
+              <a:t>Reserve (Sprecher/in 3)</a:t>
+            </a:r>
+          </a:p>
+        </p:txBody>
+      </p:sp>
+      <p:sp>
+        <p:nvSpPr>
+          <p:cNvPr id="5" name="TextBox 4"/>
+          <p:cNvSpPr txBox="1"/>
+          <p:nvPr/>
+        </p:nvSpPr>
+        <p:spPr>
+          <a:xfrm>
+            <a:off x="540000" y="1150000"/>
+            <a:ext cx="5300000" cy="4800000"/>
+          </a:xfrm>
+          <a:prstGeom prst="rect">
+            <a:avLst/>
+          </a:prstGeom>
+          <a:noFill/>
+        </p:spPr>
+        <p:txBody>
+          <a:bodyPr wrap="square">
+            <a:spAutoFit/>
+          </a:bodyPr>
+          <a:lstStyle/>
+          <a:p>
+            <a:pPr>
+              <a:spcAft>
+                <a:spcPts val="855"/>
+              </a:spcAft>
+            </a:pPr>
+            <a:r>
+              <a:rPr sz="1700" b="1">
+                <a:solidFill>
+                  <a:srgbClr val="52514E"/>
+                </a:solidFill>
+                <a:latin typeface="Calibri"/>
+              </a:rPr>
+              <a:t>H₀: Z und W sind unabhängig</a:t>
+            </a:r>
+          </a:p>
+          <a:p>
+            <a:pPr>
+              <a:spcAft>
+                <a:spcPts val="855"/>
+              </a:spcAft>
+            </a:pPr>
+            <a:r>
+              <a:rPr sz="1700" b="0">
+                <a:solidFill>
+                  <a:srgbClr val="52514E"/>
+                </a:solidFill>
+                <a:latin typeface="Calibri"/>
+              </a:rPr>
+              <a:t>•  Erwartete Häufigkeit je Zelle bei Unabhängigkeit: E = n · P(Z) · P(W)</a:t>
+            </a:r>
+          </a:p>
+          <a:p>
+            <a:pPr>
+              <a:spcAft>
+                <a:spcPts val="855"/>
+              </a:spcAft>
+            </a:pPr>
+            <a:r>
+              <a:rPr sz="1700" b="0">
+                <a:solidFill>
+                  <a:srgbClr val="52514E"/>
+                </a:solidFill>
+                <a:latin typeface="Calibri"/>
+              </a:rPr>
+              <a:t>•  Teststatistik: χ² = Σ (B − E)² / E</a:t>
+            </a:r>
+          </a:p>
+          <a:p>
+            <a:pPr>
+              <a:spcAft>
+                <a:spcPts val="855"/>
+              </a:spcAft>
+            </a:pPr>
+            <a:r>
+              <a:rPr sz="1700" b="0">
+                <a:solidFill>
+                  <a:srgbClr val="52514E"/>
+                </a:solidFill>
+                <a:latin typeface="Calibri"/>
+              </a:rPr>
+              <a:t>•  Freiheitsgrade: (2 − 1) · (2 − 1) = 1</a:t>
+            </a:r>
+          </a:p>
+          <a:p>
+            <a:pPr>
+              <a:spcAft>
+                <a:spcPts val="855"/>
+              </a:spcAft>
+            </a:pPr>
+            <a:r>
+              <a:rPr sz="1700" b="0">
+                <a:solidFill>
+                  <a:srgbClr val="52514E"/>
+                </a:solidFill>
+                <a:latin typeface="Calibri"/>
+              </a:rPr>
+              <a:t>•  Kritischer Wert (α = 5 %): 3.84</a:t>
+            </a:r>
+          </a:p>
+          <a:p>
+            <a:pPr>
+              <a:spcAft>
+                <a:spcPts val="855"/>
+              </a:spcAft>
+            </a:pPr>
+            <a:r>
+              <a:rPr sz="1700" b="1">
+                <a:solidFill>
+                  <a:srgbClr val="52514E"/>
+                </a:solidFill>
+                <a:latin typeface="Calibri"/>
+              </a:rPr>
+              <a:t>•  Ergebnis: χ² = 92.2, p &lt; 0.001  →  H₀ verwerfen</a:t>
+            </a:r>
+          </a:p>
+          <a:p>
+            <a:pPr>
+              <a:spcAft>
+                <a:spcPts val="855"/>
+              </a:spcAft>
+            </a:pPr>
+            <a:r>
+              <a:rPr sz="1700" b="0">
+                <a:solidFill>
+                  <a:srgbClr val="52514E"/>
+                </a:solidFill>
+                <a:latin typeface="Calibri"/>
+              </a:rPr>
+              <a:t>•  Python: chi2_contingency(tafel, correction=False)</a:t>
+            </a:r>
+          </a:p>
+        </p:txBody>
+      </p:sp>
+      <p:graphicFrame>
+        <p:nvGraphicFramePr>
+          <p:cNvPr id="6" name="Table 5"/>
+          <p:cNvGraphicFramePr>
+            <a:graphicFrameLocks noGrp="1"/>
+          </p:cNvGraphicFramePr>
+          <p:nvPr/>
+        </p:nvGraphicFramePr>
+        <p:xfrm>
+          <a:off x="6100000" y="1750000"/>
+          <a:ext cx="5650000" cy="2080000"/>
+        </p:xfrm>
+        <a:graphic>
+          <a:graphicData uri="http://schemas.openxmlformats.org/drawingml/2006/table">
+            <a:tbl>
+              <a:tblPr firstRow="1" bandRow="1">
+                <a:tableStyleId>{5C22544A-7EE6-4342-B048-85BDC9FD1C3A}</a:tableStyleId>
+              </a:tblPr>
+              <a:tblGrid>
+                <a:gridCol w="1900000"/>
+                <a:gridCol w="1450000"/>
+                <a:gridCol w="1450000"/>
+                <a:gridCol w="850000"/>
+              </a:tblGrid>
+              <a:tr h="520000">
+                <a:tc>
+                  <a:txBody>
+                    <a:bodyPr/>
+                    <a:lstStyle/>
+                    <a:p>
+                      <a:r>
+                        <a:rPr sz="1300" b="1"/>
+                        <a:t>beobachtet (erwartet)</a:t>
+                      </a:r>
+                    </a:p>
+                  </a:txBody>
+                  <a:tcPr/>
+                </a:tc>
+                <a:tc>
+                  <a:txBody>
+                    <a:bodyPr/>
+                    <a:lstStyle/>
+                    <a:p>
+                      <a:r>
+                        <a:rPr sz="1300" b="1"/>
+                        <a:t>zugelassen</a:t>
+                      </a:r>
+                    </a:p>
+                  </a:txBody>
+                  <a:tcPr/>
+                </a:tc>
+                <a:tc>
+                  <a:txBody>
+                    <a:bodyPr/>
+                    <a:lstStyle/>
+                    <a:p>
+                      <a:r>
+                        <a:rPr sz="1300" b="1"/>
+                        <a:t>abgelehnt</a:t>
+                      </a:r>
+                    </a:p>
+                  </a:txBody>
+                  <a:tcPr/>
+                </a:tc>
+                <a:tc>
+                  <a:txBody>
+                    <a:bodyPr/>
+                    <a:lstStyle/>
+                    <a:p>
+                      <a:r>
+                        <a:rPr sz="1300" b="1"/>
+                        <a:t>Total</a:t>
+                      </a:r>
+                    </a:p>
+                  </a:txBody>
+                  <a:tcPr/>
+                </a:tc>
+              </a:tr>
+              <a:tr h="520000">
+                <a:tc>
+                  <a:txBody>
+                    <a:bodyPr/>
+                    <a:lstStyle/>
+                    <a:p>
+                      <a:r>
+                        <a:rPr sz="1300" b="0"/>
+                        <a:t>Frauen</a:t>
+                      </a:r>
+                    </a:p>
+                  </a:txBody>
+                  <a:tcPr/>
+                </a:tc>
+                <a:tc>
+                  <a:txBody>
+                    <a:bodyPr/>
+                    <a:lstStyle/>
+                    <a:p>
+                      <a:r>
+                        <a:rPr sz="1300" b="0"/>
+                        <a:t>557 (711.5)</a:t>
+                      </a:r>
+                    </a:p>
+                  </a:txBody>
+                  <a:tcPr/>
+                </a:tc>
+                <a:tc>
+                  <a:txBody>
+                    <a:bodyPr/>
+                    <a:lstStyle/>
+                    <a:p>
+                      <a:r>
+                        <a:rPr sz="1300" b="0"/>
+                        <a:t>1 278 (1 123.5)</a:t>
+                      </a:r>
+                    </a:p>
+                  </a:txBody>
+                  <a:tcPr/>
+                </a:tc>
+                <a:tc>
+                  <a:txBody>
+                    <a:bodyPr/>
+                    <a:lstStyle/>
+                    <a:p>
+                      <a:r>
+                        <a:rPr sz="1300" b="0"/>
+                        <a:t>1 835</a:t>
+                      </a:r>
+                    </a:p>
+                  </a:txBody>
+                  <a:tcPr/>
+                </a:tc>
+              </a:tr>
+              <a:tr h="520000">
+                <a:tc>
+                  <a:txBody>
+                    <a:bodyPr/>
+                    <a:lstStyle/>
+                    <a:p>
+                      <a:r>
+                        <a:rPr sz="1300" b="0"/>
+                        <a:t>Männer</a:t>
+                      </a:r>
+                    </a:p>
+                  </a:txBody>
+                  <a:tcPr/>
+                </a:tc>
+                <a:tc>
+                  <a:txBody>
+                    <a:bodyPr/>
+                    <a:lstStyle/>
+                    <a:p>
+                      <a:r>
+                        <a:rPr sz="1300" b="0"/>
+                        <a:t>1 198 (1 043.5)</a:t>
+                      </a:r>
+                    </a:p>
+                  </a:txBody>
+                  <a:tcPr/>
+                </a:tc>
+                <a:tc>
+                  <a:txBody>
+                    <a:bodyPr/>
+                    <a:lstStyle/>
+                    <a:p>
+                      <a:r>
+                        <a:rPr sz="1300" b="0"/>
+                        <a:t>1 493 (1 647.5)</a:t>
+                      </a:r>
+                    </a:p>
+                  </a:txBody>
+                  <a:tcPr/>
+                </a:tc>
+                <a:tc>
+                  <a:txBody>
+                    <a:bodyPr/>
+                    <a:lstStyle/>
+                    <a:p>
+                      <a:r>
+                        <a:rPr sz="1300" b="0"/>
+                        <a:t>2 691</a:t>
+                      </a:r>
+                    </a:p>
+                  </a:txBody>
+                  <a:tcPr/>
+                </a:tc>
+              </a:tr>
+              <a:tr h="520000">
+                <a:tc>
+                  <a:txBody>
+                    <a:bodyPr/>
+                    <a:lstStyle/>
+                    <a:p>
+                      <a:r>
+                        <a:rPr sz="1300" b="1"/>
+                        <a:t>Total</a:t>
+                      </a:r>
+                    </a:p>
+                  </a:txBody>
+                  <a:tcPr/>
+                </a:tc>
+                <a:tc>
+                  <a:txBody>
+                    <a:bodyPr/>
+                    <a:lstStyle/>
+                    <a:p>
+                      <a:r>
+                        <a:rPr sz="1300" b="1"/>
+                        <a:t>1 755</a:t>
+                      </a:r>
+                    </a:p>
+                  </a:txBody>
+                  <a:tcPr/>
+                </a:tc>
+                <a:tc>
+                  <a:txBody>
+                    <a:bodyPr/>
+                    <a:lstStyle/>
+                    <a:p>
+                      <a:r>
+                        <a:rPr sz="1300" b="1"/>
+                        <a:t>2 771</a:t>
+                      </a:r>
+                    </a:p>
+                  </a:txBody>
+                  <a:tcPr/>
+                </a:tc>
+                <a:tc>
+                  <a:txBody>
+                    <a:bodyPr/>
+                    <a:lstStyle/>
+                    <a:p>
+                      <a:r>
+                        <a:rPr sz="1300" b="1"/>
+                        <a:t>4 526</a:t>
+                      </a:r>
+                    </a:p>
+                  </a:txBody>
+                  <a:tcPr/>
+                </a:tc>
+              </a:tr>
+            </a:tbl>
+          </a:graphicData>
+        </a:graphic>
+      </p:graphicFrame>
+      <p:sp>
+        <p:nvSpPr>
+          <p:cNvPr id="7" name="TextBox 6"/>
+          <p:cNvSpPr txBox="1"/>
+          <p:nvPr/>
+        </p:nvSpPr>
+        <p:spPr>
+          <a:xfrm>
+            <a:off x="6100000" y="4100000"/>
+            <a:ext cx="5650000" cy="1400000"/>
+          </a:xfrm>
+          <a:prstGeom prst="rect">
+            <a:avLst/>
+          </a:prstGeom>
+          <a:noFill/>
+        </p:spPr>
+        <p:txBody>
+          <a:bodyPr wrap="square">
+            <a:spAutoFit/>
+          </a:bodyPr>
+          <a:lstStyle/>
+          <a:p>
+            <a:pPr>
+              <a:spcAft>
+                <a:spcPts val="855"/>
+              </a:spcAft>
+            </a:pPr>
+            <a:r>
+              <a:rPr sz="1500" b="0">
+                <a:solidFill>
+                  <a:srgbClr val="1F3A5F"/>
+                </a:solidFill>
+                <a:latin typeface="Calibri"/>
+              </a:rPr>
+              <a:t>Bei Unabhängigkeit wären rund 712 Frauen zugelassen worden, tatsächlich waren es 557. Die Abweichung ist viel zu gross für Zufall.</a:t>
+            </a:r>
+          </a:p>
+        </p:txBody>
+      </p:sp>
+    </p:spTree>
+  </p:cSld>
+  <p:clrMapOvr>
+    <a:masterClrMapping/>
+  </p:clrMapOvr>
+</p:sld>
+</file>
+
+<file path=ppt/slides/slide15.xml><?xml version="1.0" encoding="utf-8"?>
+<p:sld xmlns:a="http://schemas.openxmlformats.org/drawingml/2006/main" xmlns:p="http://schemas.openxmlformats.org/presentationml/2006/main" xmlns:r="http://schemas.openxmlformats.org/officeDocument/2006/relationships">
+  <p:cSld>
+    <p:spTree>
+      <p:nvGrpSpPr>
+        <p:cNvPr id="1" name=""/>
+        <p:cNvGrpSpPr/>
+        <p:nvPr/>
+      </p:nvGrpSpPr>
+      <p:grpSpPr/>
+      <p:sp>
+        <p:nvSpPr>
+          <p:cNvPr id="2" name="Rectangle 1"/>
+          <p:cNvSpPr/>
+          <p:nvPr/>
+        </p:nvSpPr>
+        <p:spPr>
+          <a:xfrm>
+            <a:off x="0" y="0"/>
+            <a:ext cx="12192119" cy="125999"/>
+          </a:xfrm>
+          <a:prstGeom prst="rect">
+            <a:avLst/>
+          </a:prstGeom>
+          <a:solidFill>
+            <a:srgbClr val="1F3A5F"/>
+          </a:solidFill>
+          <a:ln>
+            <a:noFill/>
+          </a:ln>
+          <a:effectLst/>
+        </p:spPr>
+        <p:style>
+          <a:lnRef idx="1">
+            <a:schemeClr val="accent1"/>
+          </a:lnRef>
+          <a:fillRef idx="3">
+            <a:schemeClr val="accent1"/>
+          </a:fillRef>
+          <a:effectRef idx="2">
+            <a:schemeClr val="accent1"/>
+          </a:effectRef>
+          <a:fontRef idx="minor">
+            <a:schemeClr val="lt1"/>
+          </a:fontRef>
+        </p:style>
+        <p:txBody>
+          <a:bodyPr rtlCol="0" anchor="ctr"/>
+          <a:lstStyle/>
+          <a:p>
+            <a:pPr algn="ctr"/>
+          </a:p>
+        </p:txBody>
+      </p:sp>
+      <p:sp>
+        <p:nvSpPr>
+          <p:cNvPr id="3" name="TextBox 2"/>
+          <p:cNvSpPr txBox="1"/>
+          <p:nvPr/>
+        </p:nvSpPr>
+        <p:spPr>
+          <a:xfrm>
+            <a:off x="540000" y="324000"/>
+            <a:ext cx="11160000" cy="720000"/>
+          </a:xfrm>
+          <a:prstGeom prst="rect">
+            <a:avLst/>
+          </a:prstGeom>
+          <a:noFill/>
+        </p:spPr>
+        <p:txBody>
+          <a:bodyPr wrap="square">
+            <a:spAutoFit/>
+          </a:bodyPr>
+          <a:lstStyle/>
+          <a:p>
+            <a:pPr>
+              <a:spcAft>
+                <a:spcPts val="855"/>
+              </a:spcAft>
+            </a:pPr>
+            <a:r>
+              <a:rPr sz="3000" b="1">
+                <a:solidFill>
+                  <a:srgbClr val="1F3A5F"/>
+                </a:solidFill>
+                <a:latin typeface="Calibri"/>
+              </a:rPr>
+              <a:t>Reserve: Der Fachbereich als Drittvariable</a:t>
+            </a:r>
+          </a:p>
+        </p:txBody>
+      </p:sp>
+      <p:sp>
+        <p:nvSpPr>
+          <p:cNvPr id="4" name="TextBox 3"/>
+          <p:cNvSpPr txBox="1"/>
+          <p:nvPr/>
+        </p:nvSpPr>
+        <p:spPr>
+          <a:xfrm>
+            <a:off x="9360000" y="6372000"/>
+            <a:ext cx="2520000" cy="360000"/>
+          </a:xfrm>
+          <a:prstGeom prst="rect">
+            <a:avLst/>
+          </a:prstGeom>
+          <a:noFill/>
+        </p:spPr>
+        <p:txBody>
+          <a:bodyPr wrap="square">
+            <a:spAutoFit/>
+          </a:bodyPr>
+          <a:lstStyle/>
+          <a:p>
+            <a:pPr>
+              <a:spcAft>
+                <a:spcPts val="855"/>
+              </a:spcAft>
+            </a:pPr>
+            <a:r>
+              <a:rPr sz="1100" b="0">
+                <a:solidFill>
+                  <a:srgbClr val="52514E"/>
+                </a:solidFill>
+                <a:latin typeface="Calibri"/>
+              </a:rPr>
+              <a:t>Reserve (Sprecher/in 3)</a:t>
+            </a:r>
+          </a:p>
+        </p:txBody>
+      </p:sp>
+      <p:sp>
+        <p:nvSpPr>
+          <p:cNvPr id="5" name="Rounded Rectangle 4"/>
+          <p:cNvSpPr/>
+          <p:nvPr/>
+        </p:nvSpPr>
+        <p:spPr>
+          <a:xfrm>
+            <a:off x="4646000" y="1350000"/>
+            <a:ext cx="2900000" cy="900000"/>
+          </a:xfrm>
+          <a:prstGeom prst="roundRect">
+            <a:avLst/>
+          </a:prstGeom>
+          <a:solidFill>
+            <a:srgbClr val="1F3A5F"/>
+          </a:solidFill>
+          <a:ln>
+            <a:noFill/>
+          </a:ln>
+          <a:effectLst/>
+        </p:spPr>
+        <p:style>
+          <a:lnRef idx="1">
+            <a:schemeClr val="accent1"/>
+          </a:lnRef>
+          <a:fillRef idx="3">
+            <a:schemeClr val="accent1"/>
+          </a:fillRef>
+          <a:effectRef idx="2">
+            <a:schemeClr val="accent1"/>
+          </a:effectRef>
+          <a:fontRef idx="minor">
+            <a:schemeClr val="lt1"/>
+          </a:fontRef>
+        </p:style>
+        <p:txBody>
+          <a:bodyPr rtlCol="0" anchor="ctr"/>
+          <a:lstStyle/>
+          <a:p>
+            <a:pPr algn="ctr"/>
+            <a:r>
+              <a:rPr sz="2000" b="1">
+                <a:solidFill>
+                  <a:srgbClr val="FFFFFF"/>
+                </a:solidFill>
+                <a:latin typeface="Calibri"/>
+              </a:rPr>
+              <a:t>Fachbereich</a:t>
+            </a:r>
+          </a:p>
+        </p:txBody>
+      </p:sp>
+      <p:sp>
+        <p:nvSpPr>
+          <p:cNvPr id="6" name="Rounded Rectangle 5"/>
+          <p:cNvSpPr/>
+          <p:nvPr/>
+        </p:nvSpPr>
+        <p:spPr>
+          <a:xfrm>
+            <a:off x="900000" y="3950000"/>
+            <a:ext cx="2900000" cy="900000"/>
+          </a:xfrm>
+          <a:prstGeom prst="roundRect">
+            <a:avLst/>
+          </a:prstGeom>
+          <a:solidFill>
+            <a:srgbClr val="52514E"/>
+          </a:solidFill>
+          <a:ln>
+            <a:noFill/>
+          </a:ln>
+          <a:effectLst/>
+        </p:spPr>
+        <p:style>
+          <a:lnRef idx="1">
+            <a:schemeClr val="accent1"/>
+          </a:lnRef>
+          <a:fillRef idx="3">
+            <a:schemeClr val="accent1"/>
+          </a:fillRef>
+          <a:effectRef idx="2">
+            <a:schemeClr val="accent1"/>
+          </a:effectRef>
+          <a:fontRef idx="minor">
+            <a:schemeClr val="lt1"/>
+          </a:fontRef>
+        </p:style>
+        <p:txBody>
+          <a:bodyPr rtlCol="0" anchor="ctr"/>
+          <a:lstStyle/>
+          <a:p>
+            <a:pPr algn="ctr"/>
+            <a:r>
+              <a:rPr sz="2000" b="1">
+                <a:solidFill>
+                  <a:srgbClr val="FFFFFF"/>
+                </a:solidFill>
+                <a:latin typeface="Calibri"/>
+              </a:rPr>
+              <a:t>Geschlecht</a:t>
+            </a:r>
+          </a:p>
+        </p:txBody>
+      </p:sp>
+      <p:sp>
+        <p:nvSpPr>
+          <p:cNvPr id="7" name="Rounded Rectangle 6"/>
+          <p:cNvSpPr/>
+          <p:nvPr/>
+        </p:nvSpPr>
+        <p:spPr>
+          <a:xfrm>
+            <a:off x="8400000" y="3950000"/>
+            <a:ext cx="2900000" cy="900000"/>
+          </a:xfrm>
+          <a:prstGeom prst="roundRect">
+            <a:avLst/>
+          </a:prstGeom>
+          <a:solidFill>
+            <a:srgbClr val="52514E"/>
+          </a:solidFill>
+          <a:ln>
+            <a:noFill/>
+          </a:ln>
+          <a:effectLst/>
+        </p:spPr>
+        <p:style>
+          <a:lnRef idx="1">
+            <a:schemeClr val="accent1"/>
+          </a:lnRef>
+          <a:fillRef idx="3">
+            <a:schemeClr val="accent1"/>
+          </a:fillRef>
+          <a:effectRef idx="2">
+            <a:schemeClr val="accent1"/>
+          </a:effectRef>
+          <a:fontRef idx="minor">
+            <a:schemeClr val="lt1"/>
+          </a:fontRef>
+        </p:style>
+        <p:txBody>
+          <a:bodyPr rtlCol="0" anchor="ctr"/>
+          <a:lstStyle/>
+          <a:p>
+            <a:pPr algn="ctr"/>
+            <a:r>
+              <a:rPr sz="2000" b="1">
+                <a:solidFill>
+                  <a:srgbClr val="FFFFFF"/>
+                </a:solidFill>
+                <a:latin typeface="Calibri"/>
+              </a:rPr>
+              <a:t>Zulassung</a:t>
+            </a:r>
+          </a:p>
+        </p:txBody>
+      </p:sp>
+      <p:cxnSp>
+        <p:nvCxnSpPr>
+          <p:cNvPr id="8" name="Connector 7"/>
+          <p:cNvCxnSpPr/>
+          <p:nvPr/>
+        </p:nvCxnSpPr>
+        <p:spPr>
+          <a:xfrm flipV="1">
+            <a:off x="2350000" y="2250000"/>
+            <a:ext cx="2550000" cy="1700000"/>
+          </a:xfrm>
+          <a:prstGeom prst="line">
+            <a:avLst/>
+          </a:prstGeom>
+          <a:ln w="38100">
+            <a:solidFill>
+              <a:srgbClr val="1F3A5F"/>
+            </a:solidFill>
+            <a:tailEnd type="triangle" w="med" len="med"/>
+          </a:ln>
+        </p:spPr>
+        <p:style>
+          <a:lnRef idx="2">
+            <a:schemeClr val="accent1"/>
+          </a:lnRef>
+          <a:fillRef idx="0">
+            <a:schemeClr val="accent1"/>
+          </a:fillRef>
+          <a:effectRef idx="1">
+            <a:schemeClr val="accent1"/>
+          </a:effectRef>
+          <a:fontRef idx="minor">
+            <a:schemeClr val="tx1"/>
+          </a:fontRef>
+        </p:style>
+      </p:cxnSp>
+      <p:cxnSp>
+        <p:nvCxnSpPr>
+          <p:cNvPr id="9" name="Connector 8"/>
+          <p:cNvCxnSpPr/>
+          <p:nvPr/>
+        </p:nvCxnSpPr>
+        <p:spPr>
+          <a:xfrm>
+            <a:off x="7300000" y="2250000"/>
+            <a:ext cx="2550000" cy="1700000"/>
+          </a:xfrm>
+          <a:prstGeom prst="line">
+            <a:avLst/>
+          </a:prstGeom>
+          <a:ln w="38100">
+            <a:solidFill>
+              <a:srgbClr val="1F3A5F"/>
+            </a:solidFill>
+            <a:tailEnd type="triangle" w="med" len="med"/>
+          </a:ln>
+        </p:spPr>
+        <p:style>
+          <a:lnRef idx="2">
+            <a:schemeClr val="accent1"/>
+          </a:lnRef>
+          <a:fillRef idx="0">
+            <a:schemeClr val="accent1"/>
+          </a:fillRef>
+          <a:effectRef idx="1">
+            <a:schemeClr val="accent1"/>
+          </a:effectRef>
+          <a:fontRef idx="minor">
+            <a:schemeClr val="tx1"/>
+          </a:fontRef>
+        </p:style>
+      </p:cxnSp>
+      <p:cxnSp>
+        <p:nvCxnSpPr>
+          <p:cNvPr id="10" name="Connector 9"/>
+          <p:cNvCxnSpPr/>
+          <p:nvPr/>
+        </p:nvCxnSpPr>
+        <p:spPr>
+          <a:xfrm>
+            <a:off x="3800000" y="4400000"/>
+            <a:ext cx="4600000" cy="0"/>
+          </a:xfrm>
+          <a:prstGeom prst="line">
+            <a:avLst/>
+          </a:prstGeom>
+          <a:ln w="38100">
+            <a:solidFill>
+              <a:srgbClr val="52514E"/>
+            </a:solidFill>
+            <a:prstDash val="dash"/>
+            <a:tailEnd type="triangle" w="med" len="med"/>
+          </a:ln>
+        </p:spPr>
+        <p:style>
+          <a:lnRef idx="2">
+            <a:schemeClr val="accent1"/>
+          </a:lnRef>
+          <a:fillRef idx="0">
+            <a:schemeClr val="accent1"/>
+          </a:fillRef>
+          <a:effectRef idx="1">
+            <a:schemeClr val="accent1"/>
+          </a:effectRef>
+          <a:fontRef idx="minor">
+            <a:schemeClr val="tx1"/>
+          </a:fontRef>
+        </p:style>
+      </p:cxnSp>
+      <p:sp>
+        <p:nvSpPr>
+          <p:cNvPr id="11" name="TextBox 10"/>
+          <p:cNvSpPr txBox="1"/>
+          <p:nvPr/>
+        </p:nvSpPr>
+        <p:spPr>
+          <a:xfrm>
+            <a:off x="600000" y="2650000"/>
+            <a:ext cx="3500000" cy="800000"/>
+          </a:xfrm>
+          <a:prstGeom prst="rect">
+            <a:avLst/>
+          </a:prstGeom>
+          <a:noFill/>
+        </p:spPr>
+        <p:txBody>
+          <a:bodyPr wrap="square">
+            <a:spAutoFit/>
+          </a:bodyPr>
+          <a:lstStyle/>
+          <a:p>
+            <a:pPr>
+              <a:spcAft>
+                <a:spcPts val="200"/>
+              </a:spcAft>
+            </a:pPr>
+            <a:r>
+              <a:rPr sz="1500" b="1">
+                <a:solidFill>
+                  <a:srgbClr val="1F3A5F"/>
+                </a:solidFill>
+                <a:latin typeface="Calibri"/>
+              </a:rPr>
+              <a:t>Frauen wählen häufiger C–F</a:t>
+            </a:r>
+          </a:p>
+          <a:p>
+            <a:pPr>
+              <a:spcAft>
+                <a:spcPts val="200"/>
+              </a:spcAft>
+            </a:pPr>
+            <a:r>
+              <a:rPr sz="1500" b="0">
+                <a:solidFill>
+                  <a:srgbClr val="1F3A5F"/>
+                </a:solidFill>
+                <a:latin typeface="Calibri"/>
+              </a:rPr>
+              <a:t>χ² = 1 068.4, df = 5, p &lt; 0.001</a:t>
+            </a:r>
+          </a:p>
+        </p:txBody>
+      </p:sp>
+      <p:sp>
+        <p:nvSpPr>
+          <p:cNvPr id="12" name="TextBox 11"/>
+          <p:cNvSpPr txBox="1"/>
+          <p:nvPr/>
+        </p:nvSpPr>
+        <p:spPr>
+          <a:xfrm>
+            <a:off x="9300000" y="2450000"/>
+            <a:ext cx="2800000" cy="800000"/>
+          </a:xfrm>
+          <a:prstGeom prst="rect">
+            <a:avLst/>
+          </a:prstGeom>
+          <a:noFill/>
+        </p:spPr>
+        <p:txBody>
+          <a:bodyPr wrap="square">
+            <a:spAutoFit/>
+          </a:bodyPr>
+          <a:lstStyle/>
+          <a:p>
+            <a:pPr>
+              <a:spcAft>
+                <a:spcPts val="200"/>
+              </a:spcAft>
+            </a:pPr>
+            <a:r>
+              <a:rPr sz="1500" b="1">
+                <a:solidFill>
+                  <a:srgbClr val="1F3A5F"/>
+                </a:solidFill>
+                <a:latin typeface="Calibri"/>
+              </a:rPr>
+              <a:t>C–F lassen wenige zu</a:t>
+            </a:r>
+          </a:p>
+          <a:p>
+            <a:pPr>
+              <a:spcAft>
+                <a:spcPts val="200"/>
+              </a:spcAft>
+            </a:pPr>
+            <a:r>
+              <a:rPr sz="1500" b="0">
+                <a:solidFill>
+                  <a:srgbClr val="1F3A5F"/>
+                </a:solidFill>
+                <a:latin typeface="Calibri"/>
+              </a:rPr>
+              <a:t>χ² = 778.9, df = 5, p &lt; 0.001</a:t>
+            </a:r>
+          </a:p>
+        </p:txBody>
+      </p:sp>
+      <p:sp>
+        <p:nvSpPr>
+          <p:cNvPr id="13" name="TextBox 12"/>
+          <p:cNvSpPr txBox="1"/>
+          <p:nvPr/>
+        </p:nvSpPr>
+        <p:spPr>
+          <a:xfrm>
+            <a:off x="3900000" y="4500000"/>
+            <a:ext cx="4400000" cy="700000"/>
+          </a:xfrm>
+          <a:prstGeom prst="rect">
+            <a:avLst/>
+          </a:prstGeom>
+          <a:noFill/>
+        </p:spPr>
+        <p:txBody>
+          <a:bodyPr wrap="square">
+            <a:spAutoFit/>
+          </a:bodyPr>
+          <a:lstStyle/>
+          <a:p>
+            <a:pPr>
+              <a:spcAft>
+                <a:spcPts val="855"/>
+              </a:spcAft>
+            </a:pPr>
+            <a:r>
+              <a:rPr sz="1500" b="0">
+                <a:solidFill>
+                  <a:srgbClr val="52514E"/>
+                </a:solidFill>
+                <a:latin typeface="Calibri"/>
+              </a:rPr>
+              <a:t>direkter Effekt: je Fachbereich kaum vorhanden</a:t>
+            </a:r>
+          </a:p>
+        </p:txBody>
+      </p:sp>
+      <p:sp>
+        <p:nvSpPr>
+          <p:cNvPr id="14" name="TextBox 13"/>
+          <p:cNvSpPr txBox="1"/>
+          <p:nvPr/>
+        </p:nvSpPr>
+        <p:spPr>
+          <a:xfrm>
+            <a:off x="540000" y="5450000"/>
+            <a:ext cx="11160000" cy="700000"/>
+          </a:xfrm>
+          <a:prstGeom prst="rect">
+            <a:avLst/>
+          </a:prstGeom>
+          <a:noFill/>
+        </p:spPr>
+        <p:txBody>
+          <a:bodyPr wrap="square">
+            <a:spAutoFit/>
+          </a:bodyPr>
+          <a:lstStyle/>
+          <a:p>
+            <a:pPr>
+              <a:spcAft>
+                <a:spcPts val="855"/>
+              </a:spcAft>
+            </a:pPr>
+            <a:r>
+              <a:rPr sz="1700" b="1">
+                <a:solidFill>
+                  <a:srgbClr val="1F3A5F"/>
+                </a:solidFill>
+                <a:latin typeface="Calibri"/>
+              </a:rPr>
+              <a:t>Simpson-Paradoxon: Der Confounder «Fachbereich» erzeugt den aggregierten Zusammenhang. Korrelation ≠ Kausalität.</a:t>
+            </a:r>
+          </a:p>
+        </p:txBody>
+      </p:sp>
+    </p:spTree>
+  </p:cSld>
+  <p:clrMapOvr>
+    <a:masterClrMapping/>
+  </p:clrMapOvr>
+</p:sld>
+</file>
+
+<file path=ppt/slides/slide16.xml><?xml version="1.0" encoding="utf-8"?>
+<p:sld xmlns:a="http://schemas.openxmlformats.org/drawingml/2006/main" xmlns:p="http://schemas.openxmlformats.org/presentationml/2006/main" xmlns:r="http://schemas.openxmlformats.org/officeDocument/2006/relationships">
+  <p:cSld>
+    <p:spTree>
+      <p:nvGrpSpPr>
+        <p:cNvPr id="1" name=""/>
+        <p:cNvGrpSpPr/>
+        <p:nvPr/>
+      </p:nvGrpSpPr>
+      <p:grpSpPr/>
+      <p:sp>
+        <p:nvSpPr>
+          <p:cNvPr id="2" name="Rectangle 1"/>
+          <p:cNvSpPr/>
+          <p:nvPr/>
+        </p:nvSpPr>
+        <p:spPr>
+          <a:xfrm>
+            <a:off x="0" y="0"/>
+            <a:ext cx="12192119" cy="125999"/>
+          </a:xfrm>
+          <a:prstGeom prst="rect">
+            <a:avLst/>
+          </a:prstGeom>
+          <a:solidFill>
+            <a:srgbClr val="1F3A5F"/>
+          </a:solidFill>
+          <a:ln>
+            <a:noFill/>
+          </a:ln>
+          <a:effectLst/>
+        </p:spPr>
+        <p:style>
+          <a:lnRef idx="1">
+            <a:schemeClr val="accent1"/>
+          </a:lnRef>
+          <a:fillRef idx="3">
+            <a:schemeClr val="accent1"/>
+          </a:fillRef>
+          <a:effectRef idx="2">
+            <a:schemeClr val="accent1"/>
+          </a:effectRef>
+          <a:fontRef idx="minor">
+            <a:schemeClr val="lt1"/>
+          </a:fontRef>
+        </p:style>
+        <p:txBody>
+          <a:bodyPr rtlCol="0" anchor="ctr"/>
+          <a:lstStyle/>
+          <a:p>
+            <a:pPr algn="ctr"/>
+          </a:p>
+        </p:txBody>
+      </p:sp>
+      <p:sp>
+        <p:nvSpPr>
+          <p:cNvPr id="3" name="TextBox 2"/>
+          <p:cNvSpPr txBox="1"/>
+          <p:nvPr/>
+        </p:nvSpPr>
+        <p:spPr>
+          <a:xfrm>
+            <a:off x="540000" y="324000"/>
+            <a:ext cx="11160000" cy="720000"/>
+          </a:xfrm>
+          <a:prstGeom prst="rect">
+            <a:avLst/>
+          </a:prstGeom>
+          <a:noFill/>
+        </p:spPr>
+        <p:txBody>
+          <a:bodyPr wrap="square">
+            <a:spAutoFit/>
+          </a:bodyPr>
+          <a:lstStyle/>
+          <a:p>
+            <a:pPr>
+              <a:spcAft>
+                <a:spcPts val="855"/>
+              </a:spcAft>
+            </a:pPr>
+            <a:r>
+              <a:rPr sz="3000" b="1">
+                <a:solidFill>
+                  <a:srgbClr val="1F3A5F"/>
+                </a:solidFill>
+                <a:latin typeface="Calibri"/>
+              </a:rPr>
+              <a:t>Reserve: Ablauf des Programms</a:t>
+            </a:r>
+          </a:p>
+        </p:txBody>
+      </p:sp>
+      <p:sp>
+        <p:nvSpPr>
+          <p:cNvPr id="4" name="TextBox 3"/>
+          <p:cNvSpPr txBox="1"/>
+          <p:nvPr/>
+        </p:nvSpPr>
+        <p:spPr>
+          <a:xfrm>
+            <a:off x="9360000" y="6372000"/>
+            <a:ext cx="2520000" cy="360000"/>
+          </a:xfrm>
+          <a:prstGeom prst="rect">
+            <a:avLst/>
+          </a:prstGeom>
+          <a:noFill/>
+        </p:spPr>
+        <p:txBody>
+          <a:bodyPr wrap="square">
+            <a:spAutoFit/>
+          </a:bodyPr>
+          <a:lstStyle/>
+          <a:p>
+            <a:pPr>
+              <a:spcAft>
+                <a:spcPts val="855"/>
+              </a:spcAft>
+            </a:pPr>
+            <a:r>
+              <a:rPr sz="1100" b="0">
+                <a:solidFill>
+                  <a:srgbClr val="52514E"/>
+                </a:solidFill>
+                <a:latin typeface="Calibri"/>
+              </a:rPr>
+              <a:t>Reserve (Sprecher/in 2)</a:t>
+            </a:r>
+          </a:p>
+        </p:txBody>
+      </p:sp>
+      <p:sp>
+        <p:nvSpPr>
+          <p:cNvPr id="5" name="Rectangle 4"/>
+          <p:cNvSpPr/>
+          <p:nvPr/>
+        </p:nvSpPr>
+        <p:spPr>
+          <a:xfrm>
+            <a:off x="540000" y="1500000"/>
+            <a:ext cx="2000000" cy="560000"/>
+          </a:xfrm>
+          <a:prstGeom prst="rect">
+            <a:avLst/>
+          </a:prstGeom>
+          <a:solidFill>
+            <a:srgbClr val="1F3A5F"/>
+          </a:solidFill>
+          <a:ln>
+            <a:noFill/>
+          </a:ln>
+          <a:effectLst/>
+        </p:spPr>
+        <p:style>
+          <a:lnRef idx="1">
+            <a:schemeClr val="accent1"/>
+          </a:lnRef>
+          <a:fillRef idx="3">
+            <a:schemeClr val="accent1"/>
+          </a:fillRef>
+          <a:effectRef idx="2">
+            <a:schemeClr val="accent1"/>
+          </a:effectRef>
+          <a:fontRef idx="minor">
+            <a:schemeClr val="lt1"/>
+          </a:fontRef>
+        </p:style>
+        <p:txBody>
+          <a:bodyPr rtlCol="0" anchor="ctr"/>
+          <a:lstStyle/>
+          <a:p>
+            <a:pPr algn="ctr"/>
+            <a:r>
+              <a:rPr sz="1700" b="1">
+                <a:solidFill>
+                  <a:srgbClr val="FFFFFF"/>
+                </a:solidFill>
+                <a:latin typeface="Calibri"/>
+              </a:rPr>
+              <a:t>1  Erfassen</a:t>
+            </a:r>
+          </a:p>
+        </p:txBody>
+      </p:sp>
+      <p:sp>
+        <p:nvSpPr>
+          <p:cNvPr id="6" name="Rectangle 5"/>
+          <p:cNvSpPr/>
+          <p:nvPr/>
+        </p:nvSpPr>
+        <p:spPr>
+          <a:xfrm>
+            <a:off x="540000" y="2060000"/>
+            <a:ext cx="2000000" cy="1000000"/>
+          </a:xfrm>
+          <a:prstGeom prst="rect">
+            <a:avLst/>
+          </a:prstGeom>
+          <a:solidFill>
+            <a:srgbClr val="F2F2F2"/>
+          </a:solidFill>
+          <a:ln>
+            <a:noFill/>
+          </a:ln>
+          <a:effectLst/>
+        </p:spPr>
+        <p:style>
+          <a:lnRef idx="1">
+            <a:schemeClr val="accent1"/>
+          </a:lnRef>
+          <a:fillRef idx="3">
+            <a:schemeClr val="accent1"/>
+          </a:fillRef>
+          <a:effectRef idx="2">
+            <a:schemeClr val="accent1"/>
+          </a:effectRef>
+          <a:fontRef idx="minor">
+            <a:schemeClr val="lt1"/>
+          </a:fontRef>
+        </p:style>
+        <p:txBody>
+          <a:bodyPr rtlCol="0" anchor="t" wrap="square"/>
+          <a:lstStyle/>
+          <a:p>
+            <a:pPr algn="ctr"/>
+            <a:r>
+              <a:rPr sz="1300">
+                <a:solidFill>
+                  <a:srgbClr val="202020"/>
+                </a:solidFill>
+                <a:latin typeface="Calibri"/>
+              </a:rPr>
+              <a:t>Tabelle 4 als Strings,</a:t>
+            </a:r>
+          </a:p>
+          <a:p>
+            <a:pPr algn="ctr"/>
+            <a:r>
+              <a:rPr sz="1300">
+                <a:solidFill>
+                  <a:srgbClr val="202020"/>
+                </a:solidFill>
+                <a:latin typeface="Calibri"/>
+              </a:rPr>
+              <a:t>bereinige() mit Liste</a:t>
+            </a:r>
+          </a:p>
+          <a:p>
+            <a:pPr algn="ctr"/>
+            <a:r>
+              <a:rPr sz="1300">
+                <a:solidFill>
+                  <a:srgbClr val="202020"/>
+                </a:solidFill>
+                <a:latin typeface="Calibri"/>
+              </a:rPr>
+              <a:t>von Funktionen</a:t>
+            </a:r>
+          </a:p>
+        </p:txBody>
+      </p:sp>
+      <p:cxnSp>
+        <p:nvCxnSpPr>
+          <p:cNvPr id="7" name="Connector 6"/>
+          <p:cNvCxnSpPr/>
+          <p:nvPr/>
+        </p:nvCxnSpPr>
+        <p:spPr>
+          <a:xfrm>
+            <a:off x="2560000" y="1780000"/>
+            <a:ext cx="200000" cy="0"/>
+          </a:xfrm>
+          <a:prstGeom prst="line">
+            <a:avLst/>
+          </a:prstGeom>
+          <a:ln w="38100">
+            <a:solidFill>
+              <a:srgbClr val="52514E"/>
+            </a:solidFill>
+            <a:tailEnd type="triangle" w="med" len="med"/>
+          </a:ln>
+        </p:spPr>
+        <p:style>
+          <a:lnRef idx="2">
+            <a:schemeClr val="accent1"/>
+          </a:lnRef>
+          <a:fillRef idx="0">
+            <a:schemeClr val="accent1"/>
+          </a:fillRef>
+          <a:effectRef idx="1">
+            <a:schemeClr val="accent1"/>
+          </a:effectRef>
+          <a:fontRef idx="minor">
+            <a:schemeClr val="tx1"/>
+          </a:fontRef>
+        </p:style>
+      </p:cxnSp>
+      <p:sp>
+        <p:nvSpPr>
+          <p:cNvPr id="8" name="Rectangle 7"/>
+          <p:cNvSpPr/>
+          <p:nvPr/>
+        </p:nvSpPr>
+        <p:spPr>
+          <a:xfrm>
+            <a:off x="2780000" y="1500000"/>
+            <a:ext cx="2000000" cy="560000"/>
+          </a:xfrm>
+          <a:prstGeom prst="rect">
+            <a:avLst/>
+          </a:prstGeom>
+          <a:solidFill>
+            <a:srgbClr val="1F3A5F"/>
+          </a:solidFill>
+          <a:ln>
+            <a:noFill/>
+          </a:ln>
+          <a:effectLst/>
+        </p:spPr>
+        <p:style>
+          <a:lnRef idx="1">
+            <a:schemeClr val="accent1"/>
+          </a:lnRef>
+          <a:fillRef idx="3">
+            <a:schemeClr val="accent1"/>
+          </a:fillRef>
+          <a:effectRef idx="2">
+            <a:schemeClr val="accent1"/>
+          </a:effectRef>
+          <a:fontRef idx="minor">
+            <a:schemeClr val="lt1"/>
+          </a:fontRef>
+        </p:style>
+        <p:txBody>
+          <a:bodyPr rtlCol="0" anchor="ctr"/>
+          <a:lstStyle/>
+          <a:p>
+            <a:pPr algn="ctr"/>
+            <a:r>
+              <a:rPr sz="1700" b="1">
+                <a:solidFill>
+                  <a:srgbClr val="FFFFFF"/>
+                </a:solidFill>
+                <a:latin typeface="Calibri"/>
+              </a:rPr>
+              <a:t>2  Prüfen</a:t>
+            </a:r>
+          </a:p>
+        </p:txBody>
+      </p:sp>
+      <p:sp>
+        <p:nvSpPr>
+          <p:cNvPr id="9" name="Rectangle 8"/>
+          <p:cNvSpPr/>
+          <p:nvPr/>
+        </p:nvSpPr>
+        <p:spPr>
+          <a:xfrm>
+            <a:off x="2780000" y="2060000"/>
+            <a:ext cx="2000000" cy="1000000"/>
+          </a:xfrm>
+          <a:prstGeom prst="rect">
+            <a:avLst/>
+          </a:prstGeom>
+          <a:solidFill>
+            <a:srgbClr val="F2F2F2"/>
+          </a:solidFill>
+          <a:ln>
+            <a:noFill/>
+          </a:ln>
+          <a:effectLst/>
+        </p:spPr>
+        <p:style>
+          <a:lnRef idx="1">
+            <a:schemeClr val="accent1"/>
+          </a:lnRef>
+          <a:fillRef idx="3">
+            <a:schemeClr val="accent1"/>
+          </a:fillRef>
+          <a:effectRef idx="2">
+            <a:schemeClr val="accent1"/>
+          </a:effectRef>
+          <a:fontRef idx="minor">
+            <a:schemeClr val="lt1"/>
+          </a:fontRef>
+        </p:style>
+        <p:txBody>
+          <a:bodyPr rtlCol="0" anchor="t" wrap="square"/>
+          <a:lstStyle/>
+          <a:p>
+            <a:pPr algn="ctr"/>
+            <a:r>
+              <a:rPr sz="1300">
+                <a:solidFill>
+                  <a:srgbClr val="202020"/>
+                </a:solidFill>
+                <a:latin typeface="Calibri"/>
+              </a:rPr>
+              <a:t>gesamtquote():</a:t>
+            </a:r>
+          </a:p>
+          <a:p>
+            <a:pPr algn="ctr"/>
+            <a:r>
+              <a:rPr sz="1300">
+                <a:solidFill>
+                  <a:srgbClr val="202020"/>
+                </a:solidFill>
+                <a:latin typeface="Calibri"/>
+              </a:rPr>
+              <a:t>Satz der totalen</a:t>
+            </a:r>
+          </a:p>
+          <a:p>
+            <a:pPr algn="ctr"/>
+            <a:r>
+              <a:rPr sz="1300">
+                <a:solidFill>
+                  <a:srgbClr val="202020"/>
+                </a:solidFill>
+                <a:latin typeface="Calibri"/>
+              </a:rPr>
+              <a:t>Wahrscheinlichkeit</a:t>
+            </a:r>
+          </a:p>
+        </p:txBody>
+      </p:sp>
+      <p:cxnSp>
+        <p:nvCxnSpPr>
+          <p:cNvPr id="10" name="Connector 9"/>
+          <p:cNvCxnSpPr/>
+          <p:nvPr/>
+        </p:nvCxnSpPr>
+        <p:spPr>
+          <a:xfrm>
+            <a:off x="4800000" y="1780000"/>
+            <a:ext cx="200000" cy="0"/>
+          </a:xfrm>
+          <a:prstGeom prst="line">
+            <a:avLst/>
+          </a:prstGeom>
+          <a:ln w="38100">
+            <a:solidFill>
+              <a:srgbClr val="52514E"/>
+            </a:solidFill>
+            <a:tailEnd type="triangle" w="med" len="med"/>
+          </a:ln>
+        </p:spPr>
+        <p:style>
+          <a:lnRef idx="2">
+            <a:schemeClr val="accent1"/>
+          </a:lnRef>
+          <a:fillRef idx="0">
+            <a:schemeClr val="accent1"/>
+          </a:fillRef>
+          <a:effectRef idx="1">
+            <a:schemeClr val="accent1"/>
+          </a:effectRef>
+          <a:fontRef idx="minor">
+            <a:schemeClr val="tx1"/>
+          </a:fontRef>
+        </p:style>
+      </p:cxnSp>
+      <p:sp>
+        <p:nvSpPr>
+          <p:cNvPr id="11" name="Rectangle 10"/>
+          <p:cNvSpPr/>
+          <p:nvPr/>
+        </p:nvSpPr>
+        <p:spPr>
+          <a:xfrm>
+            <a:off x="5020000" y="1500000"/>
+            <a:ext cx="2000000" cy="560000"/>
+          </a:xfrm>
+          <a:prstGeom prst="rect">
+            <a:avLst/>
+          </a:prstGeom>
+          <a:solidFill>
+            <a:srgbClr val="1F3A5F"/>
+          </a:solidFill>
+          <a:ln>
+            <a:noFill/>
+          </a:ln>
+          <a:effectLst/>
+        </p:spPr>
+        <p:style>
+          <a:lnRef idx="1">
+            <a:schemeClr val="accent1"/>
+          </a:lnRef>
+          <a:fillRef idx="3">
+            <a:schemeClr val="accent1"/>
+          </a:fillRef>
+          <a:effectRef idx="2">
+            <a:schemeClr val="accent1"/>
+          </a:effectRef>
+          <a:fontRef idx="minor">
+            <a:schemeClr val="lt1"/>
+          </a:fontRef>
+        </p:style>
+        <p:txBody>
+          <a:bodyPr rtlCol="0" anchor="ctr"/>
+          <a:lstStyle/>
+          <a:p>
+            <a:pPr algn="ctr"/>
+            <a:r>
+              <a:rPr sz="1700" b="1">
+                <a:solidFill>
+                  <a:srgbClr val="FFFFFF"/>
+                </a:solidFill>
+                <a:latin typeface="Calibri"/>
+              </a:rPr>
+              <a:t>3  Anzahlen</a:t>
+            </a:r>
+          </a:p>
+        </p:txBody>
+      </p:sp>
+      <p:sp>
+        <p:nvSpPr>
+          <p:cNvPr id="12" name="Rectangle 11"/>
+          <p:cNvSpPr/>
+          <p:nvPr/>
+        </p:nvSpPr>
+        <p:spPr>
+          <a:xfrm>
+            <a:off x="5020000" y="2060000"/>
+            <a:ext cx="2000000" cy="1000000"/>
+          </a:xfrm>
+          <a:prstGeom prst="rect">
+            <a:avLst/>
+          </a:prstGeom>
+          <a:solidFill>
+            <a:srgbClr val="F2F2F2"/>
+          </a:solidFill>
+          <a:ln>
+            <a:noFill/>
+          </a:ln>
+          <a:effectLst/>
+        </p:spPr>
+        <p:style>
+          <a:lnRef idx="1">
+            <a:schemeClr val="accent1"/>
+          </a:lnRef>
+          <a:fillRef idx="3">
+            <a:schemeClr val="accent1"/>
+          </a:fillRef>
+          <a:effectRef idx="2">
+            <a:schemeClr val="accent1"/>
+          </a:effectRef>
+          <a:fontRef idx="minor">
+            <a:schemeClr val="lt1"/>
+          </a:fontRef>
+        </p:style>
+        <p:txBody>
+          <a:bodyPr rtlCol="0" anchor="t" wrap="square"/>
+          <a:lstStyle/>
+          <a:p>
+            <a:pPr algn="ctr"/>
+            <a:r>
+              <a:rPr sz="1300">
+                <a:solidFill>
+                  <a:srgbClr val="202020"/>
+                </a:solidFill>
+                <a:latin typeface="Calibri"/>
+              </a:rPr>
+              <a:t>Originaldaten als</a:t>
+            </a:r>
+          </a:p>
+          <a:p>
+            <a:pPr algn="ctr"/>
+            <a:r>
+              <a:rPr sz="1300">
+                <a:solidFill>
+                  <a:srgbClr val="202020"/>
+                </a:solidFill>
+                <a:latin typeface="Calibri"/>
+              </a:rPr>
+              <a:t>langes DataFrame,</a:t>
+            </a:r>
+          </a:p>
+          <a:p>
+            <a:pPr algn="ctr"/>
+            <a:r>
+              <a:rPr sz="1300">
+                <a:solidFill>
+                  <a:srgbClr val="202020"/>
+                </a:solidFill>
+                <a:latin typeface="Calibri"/>
+              </a:rPr>
+              <a:t>0 Abweichungen</a:t>
+            </a:r>
+          </a:p>
+        </p:txBody>
+      </p:sp>
+      <p:cxnSp>
+        <p:nvCxnSpPr>
+          <p:cNvPr id="13" name="Connector 12"/>
+          <p:cNvCxnSpPr/>
+          <p:nvPr/>
+        </p:nvCxnSpPr>
+        <p:spPr>
+          <a:xfrm>
+            <a:off x="7040000" y="1780000"/>
+            <a:ext cx="200000" cy="0"/>
+          </a:xfrm>
+          <a:prstGeom prst="line">
+            <a:avLst/>
+          </a:prstGeom>
+          <a:ln w="38100">
+            <a:solidFill>
+              <a:srgbClr val="52514E"/>
+            </a:solidFill>
+            <a:tailEnd type="triangle" w="med" len="med"/>
+          </a:ln>
+        </p:spPr>
+        <p:style>
+          <a:lnRef idx="2">
+            <a:schemeClr val="accent1"/>
+          </a:lnRef>
+          <a:fillRef idx="0">
+            <a:schemeClr val="accent1"/>
+          </a:fillRef>
+          <a:effectRef idx="1">
+            <a:schemeClr val="accent1"/>
+          </a:effectRef>
+          <a:fontRef idx="minor">
+            <a:schemeClr val="tx1"/>
+          </a:fontRef>
+        </p:style>
+      </p:cxnSp>
+      <p:sp>
+        <p:nvSpPr>
+          <p:cNvPr id="14" name="Rectangle 13"/>
+          <p:cNvSpPr/>
+          <p:nvPr/>
+        </p:nvSpPr>
+        <p:spPr>
+          <a:xfrm>
+            <a:off x="7260000" y="1500000"/>
+            <a:ext cx="2000000" cy="560000"/>
+          </a:xfrm>
+          <a:prstGeom prst="rect">
+            <a:avLst/>
+          </a:prstGeom>
+          <a:solidFill>
+            <a:srgbClr val="1F3A5F"/>
+          </a:solidFill>
+          <a:ln>
+            <a:noFill/>
+          </a:ln>
+          <a:effectLst/>
+        </p:spPr>
+        <p:style>
+          <a:lnRef idx="1">
+            <a:schemeClr val="accent1"/>
+          </a:lnRef>
+          <a:fillRef idx="3">
+            <a:schemeClr val="accent1"/>
+          </a:fillRef>
+          <a:effectRef idx="2">
+            <a:schemeClr val="accent1"/>
+          </a:effectRef>
+          <a:fontRef idx="minor">
+            <a:schemeClr val="lt1"/>
+          </a:fontRef>
+        </p:style>
+        <p:txBody>
+          <a:bodyPr rtlCol="0" anchor="ctr"/>
+          <a:lstStyle/>
+          <a:p>
+            <a:pPr algn="ctr"/>
+            <a:r>
+              <a:rPr sz="1700" b="1">
+                <a:solidFill>
+                  <a:srgbClr val="FFFFFF"/>
+                </a:solidFill>
+                <a:latin typeface="Calibri"/>
+              </a:rPr>
+              <a:t>4  Analysieren</a:t>
+            </a:r>
+          </a:p>
+        </p:txBody>
+      </p:sp>
+      <p:sp>
+        <p:nvSpPr>
+          <p:cNvPr id="15" name="Rectangle 14"/>
+          <p:cNvSpPr/>
+          <p:nvPr/>
+        </p:nvSpPr>
+        <p:spPr>
+          <a:xfrm>
+            <a:off x="7260000" y="2060000"/>
+            <a:ext cx="2000000" cy="1000000"/>
+          </a:xfrm>
+          <a:prstGeom prst="rect">
+            <a:avLst/>
+          </a:prstGeom>
+          <a:solidFill>
+            <a:srgbClr val="F2F2F2"/>
+          </a:solidFill>
+          <a:ln>
+            <a:noFill/>
+          </a:ln>
+          <a:effectLst/>
+        </p:spPr>
+        <p:style>
+          <a:lnRef idx="1">
+            <a:schemeClr val="accent1"/>
+          </a:lnRef>
+          <a:fillRef idx="3">
+            <a:schemeClr val="accent1"/>
+          </a:fillRef>
+          <a:effectRef idx="2">
+            <a:schemeClr val="accent1"/>
+          </a:effectRef>
+          <a:fontRef idx="minor">
+            <a:schemeClr val="lt1"/>
+          </a:fontRef>
+        </p:style>
+        <p:txBody>
+          <a:bodyPr rtlCol="0" anchor="t" wrap="square"/>
+          <a:lstStyle/>
+          <a:p>
+            <a:pPr algn="ctr"/>
+            <a:r>
+              <a:rPr sz="1300">
+                <a:solidFill>
+                  <a:srgbClr val="202020"/>
+                </a:solidFill>
+                <a:latin typeface="Calibri"/>
+              </a:rPr>
+              <a:t>vierfeldertafel(),</a:t>
+            </a:r>
+          </a:p>
+          <a:p>
+            <a:pPr algn="ctr"/>
+            <a:r>
+              <a:rPr sz="1300">
+                <a:solidFill>
+                  <a:srgbClr val="202020"/>
+                </a:solidFill>
+                <a:latin typeface="Calibri"/>
+              </a:rPr>
+              <a:t>pruefe_unabhaengigkeit()</a:t>
+            </a:r>
+          </a:p>
+          <a:p>
+            <a:pPr algn="ctr"/>
+            <a:r>
+              <a:rPr sz="1300">
+                <a:solidFill>
+                  <a:srgbClr val="202020"/>
+                </a:solidFill>
+                <a:latin typeface="Calibri"/>
+              </a:rPr>
+              <a:t>gesamt + je FB</a:t>
+            </a:r>
+          </a:p>
+        </p:txBody>
+      </p:sp>
+      <p:cxnSp>
+        <p:nvCxnSpPr>
+          <p:cNvPr id="16" name="Connector 15"/>
+          <p:cNvCxnSpPr/>
+          <p:nvPr/>
+        </p:nvCxnSpPr>
+        <p:spPr>
+          <a:xfrm>
+            <a:off x="9280000" y="1780000"/>
+            <a:ext cx="200000" cy="0"/>
+          </a:xfrm>
+          <a:prstGeom prst="line">
+            <a:avLst/>
+          </a:prstGeom>
+          <a:ln w="38100">
+            <a:solidFill>
+              <a:srgbClr val="52514E"/>
+            </a:solidFill>
+            <a:tailEnd type="triangle" w="med" len="med"/>
+          </a:ln>
+        </p:spPr>
+        <p:style>
+          <a:lnRef idx="2">
+            <a:schemeClr val="accent1"/>
+          </a:lnRef>
+          <a:fillRef idx="0">
+            <a:schemeClr val="accent1"/>
+          </a:fillRef>
+          <a:effectRef idx="1">
+            <a:schemeClr val="accent1"/>
+          </a:effectRef>
+          <a:fontRef idx="minor">
+            <a:schemeClr val="tx1"/>
+          </a:fontRef>
+        </p:style>
+      </p:cxnSp>
+      <p:sp>
+        <p:nvSpPr>
+          <p:cNvPr id="17" name="Rectangle 16"/>
+          <p:cNvSpPr/>
+          <p:nvPr/>
+        </p:nvSpPr>
+        <p:spPr>
+          <a:xfrm>
+            <a:off x="9500000" y="1500000"/>
+            <a:ext cx="2000000" cy="560000"/>
+          </a:xfrm>
+          <a:prstGeom prst="rect">
+            <a:avLst/>
+          </a:prstGeom>
+          <a:solidFill>
+            <a:srgbClr val="1F3A5F"/>
+          </a:solidFill>
+          <a:ln>
+            <a:noFill/>
+          </a:ln>
+          <a:effectLst/>
+        </p:spPr>
+        <p:style>
+          <a:lnRef idx="1">
+            <a:schemeClr val="accent1"/>
+          </a:lnRef>
+          <a:fillRef idx="3">
+            <a:schemeClr val="accent1"/>
+          </a:fillRef>
+          <a:effectRef idx="2">
+            <a:schemeClr val="accent1"/>
+          </a:effectRef>
+          <a:fontRef idx="minor">
+            <a:schemeClr val="lt1"/>
+          </a:fontRef>
+        </p:style>
+        <p:txBody>
+          <a:bodyPr rtlCol="0" anchor="ctr"/>
+          <a:lstStyle/>
+          <a:p>
+            <a:pPr algn="ctr"/>
+            <a:r>
+              <a:rPr sz="1700" b="1">
+                <a:solidFill>
+                  <a:srgbClr val="FFFFFF"/>
+                </a:solidFill>
+                <a:latin typeface="Calibri"/>
+              </a:rPr>
+              <a:t>5  Darstellen</a:t>
+            </a:r>
+          </a:p>
+        </p:txBody>
+      </p:sp>
+      <p:sp>
+        <p:nvSpPr>
+          <p:cNvPr id="18" name="Rectangle 17"/>
+          <p:cNvSpPr/>
+          <p:nvPr/>
+        </p:nvSpPr>
+        <p:spPr>
+          <a:xfrm>
+            <a:off x="9500000" y="2060000"/>
+            <a:ext cx="2000000" cy="1000000"/>
+          </a:xfrm>
+          <a:prstGeom prst="rect">
+            <a:avLst/>
+          </a:prstGeom>
+          <a:solidFill>
+            <a:srgbClr val="F2F2F2"/>
+          </a:solidFill>
+          <a:ln>
+            <a:noFill/>
+          </a:ln>
+          <a:effectLst/>
+        </p:spPr>
+        <p:style>
+          <a:lnRef idx="1">
+            <a:schemeClr val="accent1"/>
+          </a:lnRef>
+          <a:fillRef idx="3">
+            <a:schemeClr val="accent1"/>
+          </a:fillRef>
+          <a:effectRef idx="2">
+            <a:schemeClr val="accent1"/>
+          </a:effectRef>
+          <a:fontRef idx="minor">
+            <a:schemeClr val="lt1"/>
+          </a:fontRef>
+        </p:style>
+        <p:txBody>
+          <a:bodyPr rtlCol="0" anchor="t" wrap="square"/>
+          <a:lstStyle/>
+          <a:p>
+            <a:pPr algn="ctr"/>
+            <a:r>
+              <a:rPr sz="1300">
+                <a:solidFill>
+                  <a:srgbClr val="202020"/>
+                </a:solidFill>
+                <a:latin typeface="Calibri"/>
+              </a:rPr>
+              <a:t>matplotlib, Farbe je</a:t>
+            </a:r>
+          </a:p>
+          <a:p>
+            <a:pPr algn="ctr"/>
+            <a:r>
+              <a:rPr sz="1300">
+                <a:solidFill>
+                  <a:srgbClr val="202020"/>
+                </a:solidFill>
+                <a:latin typeface="Calibri"/>
+              </a:rPr>
+              <a:t>Geschlecht, PNG für</a:t>
+            </a:r>
+          </a:p>
+          <a:p>
+            <a:pPr algn="ctr"/>
+            <a:r>
+              <a:rPr sz="1300">
+                <a:solidFill>
+                  <a:srgbClr val="202020"/>
+                </a:solidFill>
+                <a:latin typeface="Calibri"/>
+              </a:rPr>
+              <a:t>Text und Folien</a:t>
+            </a:r>
+          </a:p>
+        </p:txBody>
+      </p:sp>
+      <p:sp>
+        <p:nvSpPr>
+          <p:cNvPr id="19" name="TextBox 18"/>
+          <p:cNvSpPr txBox="1"/>
+          <p:nvPr/>
+        </p:nvSpPr>
+        <p:spPr>
+          <a:xfrm>
+            <a:off x="540000" y="3500000"/>
+            <a:ext cx="11160000" cy="1800000"/>
+          </a:xfrm>
+          <a:prstGeom prst="rect">
+            <a:avLst/>
+          </a:prstGeom>
+          <a:noFill/>
+        </p:spPr>
+        <p:txBody>
+          <a:bodyPr wrap="square">
+            <a:spAutoFit/>
+          </a:bodyPr>
+          <a:lstStyle/>
+          <a:p>
+            <a:pPr>
+              <a:spcAft>
+                <a:spcPts val="855"/>
+              </a:spcAft>
+            </a:pPr>
+            <a:r>
+              <a:rPr sz="1700" b="0">
+                <a:solidFill>
+                  <a:srgbClr val="52514E"/>
+                </a:solidFill>
+                <a:latin typeface="Calibri"/>
+              </a:rPr>
+              <a:t>•  Prinzip: Jeder wiederholte Schritt ist eine Funktion, gleiche Funktion für gesamt und je Fachbereich</a:t>
+            </a:r>
+          </a:p>
+          <a:p>
+            <a:pPr>
+              <a:spcAft>
+                <a:spcPts val="855"/>
+              </a:spcAft>
+            </a:pPr>
+            <a:r>
+              <a:rPr sz="1700" b="0">
+                <a:solidFill>
+                  <a:srgbClr val="52514E"/>
+                </a:solidFill>
+                <a:latin typeface="Calibri"/>
+              </a:rPr>
+              <a:t>•  Daten werden nur als Argumente übergeben (kein global), Ergebnisse mit return zurückgegeben</a:t>
+            </a:r>
+          </a:p>
+          <a:p>
+            <a:pPr>
+              <a:spcAft>
+                <a:spcPts val="855"/>
+              </a:spcAft>
+            </a:pPr>
+            <a:r>
+              <a:rPr sz="1700" b="0">
+                <a:solidFill>
+                  <a:srgbClr val="52514E"/>
+                </a:solidFill>
+                <a:latin typeface="Calibri"/>
+              </a:rPr>
+              <a:t>•  Fehler in der Datenerfassung werden durch try/except und zwei Gegenproben sofort sichtbar</a:t>
+            </a:r>
+          </a:p>
+        </p:txBody>
+      </p:sp>
+    </p:spTree>
+  </p:cSld>
+  <p:clrMapOvr>
+    <a:masterClrMapping/>
+  </p:clrMapOvr>
+</p:sld>
+</file>
+
 <file path=ppt/slides/slide2.xml><?xml version="1.0" encoding="utf-8"?>
 <p:sld xmlns:a="http://schemas.openxmlformats.org/drawingml/2006/main" xmlns:p="http://schemas.openxmlformats.org/presentationml/2006/main" xmlns:r="http://schemas.openxmlformats.org/officeDocument/2006/relationships">
   <p:cSld>
@@ -7658,7 +11084,7 @@
                 </a:solidFill>
                 <a:latin typeface="Calibri"/>
               </a:rPr>
-              <a:t>Sprecher/in 3</a:t>
+              <a:t>Sprecher/in 2</a:t>
             </a:r>
           </a:p>
         </p:txBody>

</xml_diff>

<commit_message>
Vortrag 4: ausformulierter Sprechtext
- Neu: Vortrag4_Sprechtext.md mit Sprechtext für alle 21 Folien, nach Sprecher/in gegliedert
- Derselbe Text in den Notizen der Präsentation (Referentenansicht)

Co-Authored-By: Claude Opus 5.5 <noreply@anthropic.com>
Claude-Session: https://claude.ai/code/session_013YcN7q2EjK91BTrikonwXA
</commit_message>
<xml_diff>
--- a/vortrag4/Vortrag4_Praesentation.pptx
+++ b/vortrag4/Vortrag4_Praesentation.pptx
@@ -1832,10 +1832,14 @@
           <a:lstStyle/>
           <a:p>
             <a:r>
-              <a:rPr lang="en-US" dirty="0"/>
-              <a:t>[Sprecher/in 1] Begrüssung, Vorstellung der Gruppe. Ablauf: 1) Funktionen in Python, 2) die Daten und eine scheinbare Ungerechtigkeit, 3) der genaue Vergleich und stochastische Unabhängigkeit. Dauer ca. 15 Minuten (3 × 5 Min.: Sprecher/in 1 Folien 1–5, Sprecher/in 2 Folien 6–10, Sprecher/in 3 Folien 11–15). Falls 20 Minuten verlangt sind: Reservefolien 18–21 an den dort notierten Stellen einschieben. Rechts schon der Teaser: Männer 44.5 %, Frauen 30.4 %.</a:t>
-            </a:r>
-            <a:endParaRPr lang="en-US" dirty="0"/>
+              <a:t>[Sprecher/in 1] Guten Tag zusammen. Wir sind Leorat Krasniqi, Teoman-Doganay Lam und Filip Lazic, und unser Vortrag heisst «Das Berkeley-Paradoxon». Rechts sehen Sie schon die zwei Zahlen, um die sich heute alles dreht: 1973 wurden an der UC Berkeley 44.5 Prozent der Männer zugelassen, aber nur 30.4 Prozent der Frauen. Wir zeigen Ihnen in drei Teilen, was hinter diesen Zahlen steckt: zuerst Funktionen in Python, dann die Darstellung der scheinbaren Ungerechtigkeit und zum Schluss den genauen Vergleich mit dem Konzept der stochastischen Unabhängigkeit.</a:t>
+            </a:r>
+          </a:p>
+          <a:p/>
+          <a:p>
+            <a:r>
+              <a:t>Zeitplan: ca. 15 Minuten (3 × 5 Min.): Sprecher/in 1 Folien 1–5, Sprecher/in 2 Folien 6–10, Sprecher/in 3 Folien 11–15. Bei 20 Minuten Reservefolien 18–21 einschieben.</a:t>
+            </a:r>
           </a:p>
         </p:txBody>
       </p:sp>
@@ -1920,10 +1924,8 @@
           <a:lstStyle/>
           <a:p>
             <a:r>
-              <a:rPr lang="en-US" dirty="0"/>
-              <a:t>[Sprecher/in 2] Wendepunkt: In 4 von 6 Fachbereichen haben Frauen die höhere Quote, in A sogar +20.3 Prozentpunkte. Nur in C und E leicht tiefer (−2.8, −3.8). Danach Übergabe an Sprecher/in 3.</a:t>
-            </a:r>
-            <a:endParaRPr lang="en-US" dirty="0"/>
+              <a:t>[Sprecher/in 2] Und hier kippt das Bild. In vier von sechs Fachbereichen haben Frauen die höhere Zulassungsquote, nämlich in A, B, D und F. In Fachbereich A sogar um 20.3 Prozentpunkte. Nur in C und E liegen die Männer leicht vorne, mit 2.8 und 3.8 Prozentpunkten. Diese Unterschiede sind klein, der Unterschied in A dagegen ist gross, und zwar zugunsten der Frauen. Übrigens zeichnet dieses Diagramm dieselbe Funktion wie das Diagramm zur Verteilung der Bewerbungen auf der nächsten Folie, nur mit anderen Spalten. In den Fachbereichen, die über die Zulassung entscheiden, sehen wir also keinen Nachteil für Frauen. Wie passt das zur Gesamtquote? Das erklärt [Name Sprecher/in 3].</a:t>
+            </a:r>
           </a:p>
         </p:txBody>
       </p:sp>
@@ -2008,10 +2010,8 @@
           <a:lstStyle/>
           <a:p>
             <a:r>
-              <a:rPr lang="en-US" dirty="0"/>
-              <a:t>[Sprecher/in 3] 51.5 % der Männer bewarben sich in A oder B (Quote ca. 64 %), aber nur 7.2 % der Frauen. 92.8 % der Frauen bewarben sich in C bis F mit Quoten von 6 bis 35 %. Das Diagramm zeigt die Anteile je Fachbereich.</a:t>
-            </a:r>
-            <a:endParaRPr lang="en-US" dirty="0"/>
+              <a:t>[Sprecher/in 3] Danke. Die Antwort liegt darin, wo sich Frauen und Männer beworben haben. 51.5 Prozent der Männer bewarben sich in A oder B, also in Fachbereichen, in denen rund 64 Prozent zugelassen werden. Von den Frauen waren es nur 7.2 Prozent. Allein in Fachbereich A bewarben sich 825 Männer, aber nur 108 Frauen. 92.8 Prozent der Frauen bewarben sich in C bis F, wo die Quoten nur zwischen 6 und 35 Prozent liegen. Im Diagramm sehen Sie das: Bei A und B dominieren die blauen Balken der Männer, bei C bis F die roten Balken der Frauen.</a:t>
+            </a:r>
           </a:p>
         </p:txBody>
       </p:sp>
@@ -2096,10 +2096,8 @@
           <a:lstStyle/>
           <a:p>
             <a:r>
-              <a:rPr lang="en-US" dirty="0"/>
-              <a:t>[Sprecher/in 3] Pro Fachbereich: Frauenanteil unter den Bewerbungen gegen die Zulassungsquote. Je höher der Frauenanteil, desto tiefer die Zulassungsquote des Fachbereichs: Korrelation r = −0.79. Die Punktfläche entspricht der Anzahl Bewerbungen.</a:t>
-            </a:r>
-            <a:endParaRPr lang="en-US" dirty="0"/>
+              <a:t>[Sprecher/in 3] Hier fassen wir das pro Fachbereich zusammen: auf der x-Achse der Frauenanteil unter den Bewerbungen, auf der y-Achse die Zulassungsquote des Fachbereichs. Die Punktfläche entspricht der Anzahl Bewerbungen. Das Muster ist deutlich: Je höher der Frauenanteil, desto tiefer die Zulassungsquote. Die Korrelation beträgt r gleich minus 0.79. Frauen haben sich also häufiger in Fachbereichen beworben, die stark umkämpft sind.</a:t>
+            </a:r>
           </a:p>
         </p:txBody>
       </p:sp>
@@ -2184,10 +2182,8 @@
           <a:lstStyle/>
           <a:p>
             <a:r>
-              <a:rPr lang="en-US" dirty="0"/>
-              <a:t>[Sprecher/in 3] Gesamtquote = gewichteter Mittelwert. Frauen haben hohe Gewichte bei tiefen Quoten. Gleiche Gewichte für beide (Verteilung aller Bewerbungen): Frauen 43.0 %, Männer 38.7 %. Der Unterschied kehrt sich um. Technisch: dieselbe Funktion gesamtquote, nur andere Gewichte.</a:t>
-            </a:r>
-            <a:endParaRPr lang="en-US" dirty="0"/>
+              <a:t>[Sprecher/in 3] Warum führt das zur tieferen Gesamtquote? Wegen des Satzes der totalen Wahrscheinlichkeit. Die Gesamtquote eines Geschlechts ist ein gewichteter Mittelwert der Quoten in den Fachbereichen, und die Gewichte sind die Anteile der Bewerbungen. Für die Frauen heisst das: 5.9 Prozent mal 82.4 Prozent plus 1.4 Prozent mal 68 Prozent und so weiter, das ergibt 30.4 Prozent. Frauen haben ihre grossen Gewichte bei den tiefen Quoten, Männer bei den hohen. Was passiert, wenn wir für beide Geschlechter dieselben Gewichte einsetzen, nämlich die Verteilung aller Bewerbungen? Dann liegt die Quote der Frauen bei 43.0 Prozent und die der Männer bei 38.7 Prozent. Der Unterschied kehrt sich um. Im Code ist das derselbe Aufruf der Funktion gesamtquote, nur mit anderen Gewichten.</a:t>
+            </a:r>
           </a:p>
         </p:txBody>
       </p:sp>
@@ -2272,10 +2268,8 @@
           <a:lstStyle/>
           <a:p>
             <a:r>
-              <a:rPr lang="en-US" dirty="0"/>
-              <a:t>[Sprecher/in 3] Definition aus Teil 3: P(A|B) = P(A) bzw. P(A∩B) = P(A)P(B). Gesamt: 0.1231 statt 0.1572, also abhängig, Chi2 = 92.2, p &lt; 0.001. Je Fachbereich: B bis F unabhängig (p &gt; 0.3), nur A abhängig, aber zugunsten der Frauen. Bedingte Unabhängigkeit gegeben Fachbereich; der Fachbereich ist der Confounder.</a:t>
-            </a:r>
-            <a:endParaRPr lang="en-US" dirty="0"/>
+              <a:t>[Sprecher/in 3] Jetzt zur stochastischen Unabhängigkeit. Zwei Ereignisse sind unabhängig, wenn P von Z geschnitten W gleich P von Z mal P von W ist, oder gleichwertig: wenn P von Z gegeben W gleich P von Z ist. Z heisst «zugelassen», W heisst «Bewerbung einer Frau». Insgesamt beobachten wir 0.1231, bei Unabhängigkeit müssten es 0.1572 sein. Der Chi-Quadrat-Test bestätigt das mit einem Wert von 92.2 und einem p-Wert unter 0.001. Insgesamt sind Zulassung und Geschlecht also abhängig. Innerhalb der Fachbereiche B bis F liegen die Werte aber sehr nahe beieinander, alle p-Werte sind grösser als 0.3. Dort können wir die Unabhängigkeit nicht verwerfen. Nur in Fachbereich A gibt es eine Abhängigkeit, und zwar zugunsten der Frauen. Man spricht von bedingter Unabhängigkeit gegeben den Fachbereich. Der Fachbereich ist die Drittvariable, auch Confounder genannt.</a:t>
+            </a:r>
           </a:p>
         </p:txBody>
       </p:sp>
@@ -2360,10 +2354,8 @@
           <a:lstStyle/>
           <a:p>
             <a:r>
-              <a:rPr lang="en-US" dirty="0"/>
-              <a:t>[Sprecher/in 3] Die Zusammenfassung verbirgt die Drittvariable Fachbereich: Simpson-Paradoxon. Aggregiert abhängig, je Fachbereich kein Nachteil für Frauen. Ursache: Frauen bewarben sich häufiger in umkämpften Fachbereichen. Grenzen: Beobachtungsdaten eines Jahres, offene Frage, warum Frauen sich in selektivere Fachbereiche bewarben. Programmtechnisch: Funktionen machen die Analyse wiederverwendbar.</a:t>
-            </a:r>
-            <a:endParaRPr lang="en-US" dirty="0"/>
+              <a:t>[Sprecher/in 3] Zum Fazit. Die Drittvariable Fachbereich kehrt den Zusammenhang um, das ist das Simpson-Paradoxon. Aggregiert sind Zulassung und Geschlecht abhängig, 30.4 gegen 44.5 Prozent. Je Fachbereich gibt es keinen Nachteil für Frauen. Die Ursache ist, dass sich Frauen häufiger in stark umkämpften Fachbereichen beworben haben. Wir müssen aber auch die Grenzen nennen: Es sind Beobachtungsdaten eines einzigen Jahres, und warum Frauen diese Fachbereiche gewählt haben, können die Daten nicht beantworten. Programmtechnisch hat sich gezeigt: Mit denselben Funktionen konnten wir die Gesamtanalyse, alle sechs Fachbereiche und die Standardisierung rechnen. Unsere wichtigste Lehre: Aggregierte Quoten darf man erst dann als Ursache deuten, wenn man relevante Drittvariablen berücksichtigt hat.</a:t>
+            </a:r>
           </a:p>
         </p:txBody>
       </p:sp>
@@ -2448,10 +2440,8 @@
           <a:lstStyle/>
           <a:p>
             <a:r>
-              <a:rPr lang="en-US" dirty="0"/>
-              <a:t>[alle] Dank, Fragen aus dem Publikum entgegennehmen. Für Rückfragen stehen die Reservefolien 18–21 bereit.</a:t>
-            </a:r>
-            <a:endParaRPr lang="en-US" dirty="0"/>
+              <a:t>[alle] Vielen Dank für Ihre Aufmerksamkeit. Rechts sehen Sie unsere Quellen. Wir freuen uns auf Ihre Fragen.</a:t>
+            </a:r>
           </a:p>
         </p:txBody>
       </p:sp>
@@ -2536,10 +2526,8 @@
           <a:lstStyle/>
           <a:p>
             <a:r>
-              <a:rPr lang="en-US" dirty="0"/>
-              <a:t>Trennfolie für die Reservefolien. Bei 20 Minuten: Folie 21 nach Folie 7, Folie 18 nach Folie 13, Folien 19 und 20 nach Folie 14 einschieben.</a:t>
-            </a:r>
-            <a:endParaRPr lang="en-US" dirty="0"/>
+              <a:t>Trennfolie, wird nicht vorgetragen. Bei 20 Minuten: Folie 21 nach Folie 7, Folie 18 nach Folie 13, Folien 19 und 20 nach Folie 14 einschieben.</a:t>
+            </a:r>
           </a:p>
         </p:txBody>
       </p:sp>
@@ -2624,10 +2612,8 @@
           <a:lstStyle/>
           <a:p>
             <a:r>
-              <a:rPr lang="en-US" dirty="0"/>
-              <a:t>[Sprecher/in 3] Einsatz nach Folie 13. Jede Zeile: Anteil der Bewerbungen mal Quote ergibt den Beitrag des Fachbereichs zur Gesamtquote. Frauen: Die grossen Gewichte (C, D, E, F zusammen 92.8 %) liegen bei tiefen Quoten, darum ist die Summe klein. Männer: 51.5 % der Gewichte bei A und B mit hohen Quoten. Summe Männer 44.6 % statt 44.5 % ist nur ein Rundungseffekt von Tabelle 4.</a:t>
-            </a:r>
-            <a:endParaRPr lang="en-US" dirty="0"/>
+              <a:t>[Sprecher/in 3] Einsatz nach Folie 13. Diese Tabelle rechnet die Gesamtquote vor. In jeder Zeile multiplizieren wir den Anteil der Bewerbungen mit der Zulassungsquote. Das ergibt den Beitrag des Fachbereichs. Bei den Frauen liegen die grossen Gewichte bei C bis F, zusammen 92.8 Prozent, und dort sind die Quoten tief. Darum ergibt die Summe nur 30.4 Prozent. Bei den Männern liegen 51.5 Prozent der Gewichte bei A und B mit hohen Quoten, die Summe ergibt 44.6 Prozent. Dass es nicht genau 44.5 sind, ist nur ein Rundungseffekt von Tabelle 4.</a:t>
+            </a:r>
           </a:p>
         </p:txBody>
       </p:sp>
@@ -2712,10 +2698,8 @@
           <a:lstStyle/>
           <a:p>
             <a:r>
-              <a:rPr lang="en-US" dirty="0"/>
-              <a:t>[Sprecher/in 3] Einsatz nach Folie 14. Nullhypothese: Zulassung und Geschlecht sind unabhängig. Dann erwarten wir in jeder Zelle n · P(Z) · P(W), z. B. für zugelassene Frauen 4 526 · 0.388 · 0.405 = 711.5. Beobachtet sind aber nur 557. Chi-Quadrat summiert die quadrierten, standardisierten Abweichungen über alle vier Zellen: 92.2. Bei 1 Freiheitsgrad liegt der kritische Wert für alpha = 5 % bei 3.84, also wird H0 klar verworfen (p &lt; 0.001). Im Code: scipy.stats.chi2_contingency(tafel, correction=False).</a:t>
-            </a:r>
-            <a:endParaRPr lang="en-US" dirty="0"/>
+              <a:t>[Sprecher/in 3] Einsatz nach Folie 14. So funktioniert der Chi-Quadrat-Test. Die Nullhypothese lautet: Zulassung und Geschlecht sind unabhängig. Dann erwarten wir in jeder Zelle n mal P von Z mal P von W. Für zugelassene Frauen wären das 711.5, beobachtet sind aber nur 557. Die Teststatistik summiert über alle vier Zellen die quadrierte Abweichung geteilt durch den erwarteten Wert. Das ergibt 92.2. Bei einem Freiheitsgrad liegt der kritische Wert für 5 Prozent bei 3.84. Wir verwerfen die Nullhypothese also klar. Im Code genügt ein einziger Aufruf: chi2_contingency.</a:t>
+            </a:r>
           </a:p>
         </p:txBody>
       </p:sp>
@@ -2800,10 +2784,8 @@
           <a:lstStyle/>
           <a:p>
             <a:r>
-              <a:rPr lang="en-US" dirty="0"/>
-              <a:t>[Sprecher/in 1] 1973 befürchtete die UC Berkeley eine Klage: aggregiert wurden deutlich weniger Frauen zugelassen. Grundlage sind 4 526 Bewerbungen in sechs Fachbereichen (Tabelle 4). Unsere drei Aufgaben: (a) Funktionen in Python, (b) Darstellung der scheinbaren Ungerechtigkeit, (c) Vergleich der Verteilungen und stochastische Unabhängigkeit.</a:t>
-            </a:r>
-            <a:endParaRPr lang="en-US" dirty="0"/>
+              <a:t>[Sprecher/in 1] Zur Ausgangslage: Im Herbst 1973 bewarben sich 4 526 Personen für ein Graduate-Studium in den sechs grössten Fachbereichen der Universität, die wir A bis F nennen. Weil insgesamt deutlich weniger Frauen zugelassen wurden, befürchtete die Universität eine Klage wegen Diskriminierung. Tabelle 4 unserer Aufgabe zeigt für jeden Fachbereich die Zulassungsquote von Frauen und Männern und wie sich die Bewerbungen auf die Fachbereiche verteilen. Unsere Aufgabe hat drei Teile: (a) Funktionen in Python erklären, (b) die Ungerechtigkeit so darstellen, dass man sie auf einen Blick sieht, und (c) die Verteilungen vergleichen und dabei die stochastische Unabhängigkeit prüfen. Die zentrale Frage lautet also: Wurden Frauen bei der Zulassung tatsächlich benachteiligt?</a:t>
+            </a:r>
           </a:p>
         </p:txBody>
       </p:sp>
@@ -2888,10 +2870,8 @@
           <a:lstStyle/>
           <a:p>
             <a:r>
-              <a:rPr lang="en-US" dirty="0"/>
-              <a:t>[Sprecher/in 3] Einsatz nach Folie 14 oder bei der Frage nach Kausalität. Der Fachbereich hängt mit beiden Variablen stark zusammen: Geschlecht und Fachbereichswahl (Chi2 = 1068, df = 5) und Fachbereich und Zulassung (Chi2 = 779, df = 5). Der direkte Pfeil Geschlecht -&gt; Zulassung ist innerhalb der Fachbereiche kaum vorhanden (nur A, zugunsten der Frauen). Das ist die Struktur eines Confounders und die Ursache des Simpson-Paradoxons. Korrelation ist nicht Kausalität.</a:t>
-            </a:r>
-            <a:endParaRPr lang="en-US" dirty="0"/>
+              <a:t>[Sprecher/in 3] Einsatz nach Folie 14 oder bei der Frage nach Kausalität. Hier sieht man die Struktur des Problems. Das Geschlecht hängt stark mit der Wahl des Fachbereichs zusammen, Chi-Quadrat 1 068.4. Und der Fachbereich hängt stark mit der Zulassung zusammen, Chi-Quadrat 778.9. Der direkte Effekt des Geschlechts auf die Zulassung ist innerhalb der Fachbereiche kaum vorhanden. Der Fachbereich ist also der Confounder, der den Zusammenhang insgesamt erzeugt. Korrelation ist nicht Kausalität.</a:t>
+            </a:r>
           </a:p>
         </p:txBody>
       </p:sp>
@@ -2976,10 +2956,8 @@
           <a:lstStyle/>
           <a:p>
             <a:r>
-              <a:rPr lang="en-US" dirty="0"/>
-              <a:t>[Sprecher/in 2] Einsatz nach Folie 7, falls nach dem Aufbau des Codes gefragt wird. Der Code läuft in fünf Schritten: Tabelle 4 als Text erfassen und mit einer Liste von Funktionen bereinigen; mit dem Satz der totalen Wahrscheinlichkeit plausibilisieren; Originalanzahlen in ein langes DataFrame laden und gegen Tabelle 4 prüfen; mit denselben Funktionen gesamt und je Fachbereich analysieren; Diagramme mit einheitlichen Farben als PNG speichern. Jeder Schritt ist eine eigene Notebook-Zelle.</a:t>
-            </a:r>
-            <a:endParaRPr lang="en-US" dirty="0"/>
+              <a:t>[Sprecher/in 2] Einsatz nach Folie 7, falls nach dem Aufbau des Codes gefragt wird. Hier sieht man den Ablauf unseres Programms in fünf Schritten. Erstens erfassen wir Tabelle 4 als Text und bereinigen sie mit einer Liste von Funktionen. Zweitens prüfen wir sie mit dem Satz der totalen Wahrscheinlichkeit. Drittens laden wir die Originalanzahlen in ein langes DataFrame und prüfen sie gegen Tabelle 4. Viertens analysieren wir mit denselben Funktionen gesamt und je Fachbereich. Fünftens zeichnen wir die Diagramme mit einer festen Farbe pro Geschlecht. Dahinter stehen drei Prinzipien: Jeder wiederholte Schritt ist eine Funktion, wir verwenden kein global, und Fehler werden durch try/except und zwei Gegenproben sofort sichtbar.</a:t>
+            </a:r>
           </a:p>
         </p:txBody>
       </p:sp>
@@ -3064,10 +3042,8 @@
           <a:lstStyle/>
           <a:p>
             <a:r>
-              <a:rPr lang="en-US" dirty="0"/>
-              <a:t>[Sprecher/in 1] Überleitung: Bevor wir die Daten analysieren, zeigen wir das Werkzeug, mit dem wir den Code organisieren: Funktionen.</a:t>
-            </a:r>
-            <a:endParaRPr lang="en-US" dirty="0"/>
+              <a:t>[Sprecher/in 1] Wir beginnen mit Teil (a). Bevor wir die Daten analysieren, zeigen wir das Werkzeug, mit dem wir unseren ganzen Code organisiert haben: Funktionen.</a:t>
+            </a:r>
           </a:p>
         </p:txBody>
       </p:sp>
@@ -3152,10 +3128,8 @@
           <a:lstStyle/>
           <a:p>
             <a:r>
-              <a:rPr lang="en-US" dirty="0"/>
-              <a:t>[Sprecher/in 1] Faustregel McKinney: Code, den man mehr als einmal braucht, gehört in eine Funktion. def/return, Positions- vs. Keyword-Argumente (Keyword nach Position, Reihenfolge egal). Lokaler Namensraum wird beim Aufruf erzeugt und danach zerstört; global möglichst vermeiden. Mehrere Rückgabewerte sind eigentlich ein Tupel; Alternative Dictionary. Rechts: unsere Anwendung.</a:t>
-            </a:r>
-            <a:endParaRPr lang="en-US" dirty="0"/>
+              <a:t>[Sprecher/in 1] McKinney nennt eine einfache Faustregel: Code, den man mehr als einmal braucht, gehört in eine Funktion. Eine Funktion wird mit def deklariert und gibt ihr Ergebnis mit return zurück. Fehlt das return, gibt Python automatisch None zurück. Man unterscheidet Positionsargumente, die über ihre Reihenfolge zugeordnet werden, und Keyword-Argumente, die einen Namen und oft einen Standardwert haben. Keyword-Argumente müssen nach den Positionsargumenten stehen, untereinander ist ihre Reihenfolge aber egal. Rechts sehen Sie unsere Funktion vierfeldertafel: Ohne Angabe gilt fachbereich gleich None, dann wird die Tafel über alle Bewerbungen gebildet. Mit fachbereich gleich A nur für Fachbereich A. Variablen in einer Funktion leben in einem lokalen Namensraum, der beim Aufruf entsteht und danach wieder verschwindet. Globale Variablen vermeiden wir bewusst. Und eine Funktion kann scheinbar mehrere Werte zurückgeben. Tatsächlich ist es ein Tupel, das wir beim Aufruf entpacken, wie unten bei kennzahlen: quote, anteil gleich kennzahlen von 89, 19 und 1 835.</a:t>
+            </a:r>
           </a:p>
         </p:txBody>
       </p:sp>
@@ -3240,10 +3214,8 @@
           <a:lstStyle/>
           <a:p>
             <a:r>
-              <a:rPr lang="en-US" dirty="0"/>
-              <a:t>[Sprecher/in 1] Funktionen lassen sich in Listen speichern und als Argument übergeben (Muster clean_strings aus McKinney). Lambda: anonyme Einzeiler, ideal als Argument. partial: Currying. yield: Generator mit Lazy Evaluation. try/except: nur erwartete Fehler (ValueError) abfangen. Danach Übergabe an Sprecher/in 2.</a:t>
-            </a:r>
-            <a:endParaRPr lang="en-US" dirty="0"/>
+              <a:t>[Sprecher/in 1] Vier weitere Konzepte aus Abschnitt 3.2. Erstens: Funktionen sind Objekte. Wir speichern unsere Bereinigungsschritte in einer Liste und wenden sie nacheinander auf jeden Wert aus Tabelle 4 an. So wird aus dem Text «82.4%» die Zahl 0.824. Der Vorteil: Kommt ein weiterer Bereinigungsschritt dazu, fügen wir ihn nur in die Liste ein, die Funktion selbst bleibt gleich. Zweitens: Lambda-Funktionen sind anonyme Einzeiler, ideal, wenn man eine Funktion als Argument übergibt. Mit partial legen wir ein Argument fest, das nennt man Currying: pruefe_streng ist derselbe Test, nur mit einem Signifikanzniveau von 1 Prozent. Drittens: Ein Generator liefert mit yield die Ergebnisse erst dann, wenn sie angefordert werden, bei uns Fachbereich für Fachbereich. Viertens: Bei der Ausnahmebehandlung fangen wir nur den erwarteten Fehler ab, den ValueError bei einem Tippfehler in der Tabelle. Andere Fehler sollen sichtbar bleiben. Damit übergebe ich an [Name Sprecher/in 2].</a:t>
+            </a:r>
           </a:p>
         </p:txBody>
       </p:sp>
@@ -3328,10 +3300,8 @@
           <a:lstStyle/>
           <a:p>
             <a:r>
-              <a:rPr lang="en-US" dirty="0"/>
-              <a:t>[Sprecher/in 2] Übernahme. Zuerst: Wie haben wir die Umsetzung geplant? Danach: Wie sieht die Ungerechtigkeit auf einen Blick aus?</a:t>
-            </a:r>
-            <a:endParaRPr lang="en-US" dirty="0"/>
+              <a:t>[Sprecher/in 2] Danke. Ich übernehme Teil (b). Ein Schwerpunkt der Aufgabe liegt auf den Vorüberlegungen zur programmtechnischen Umsetzung. Deshalb zeige ich zuerst, wie wir die Umsetzung geplant haben, und danach, wie die Ungerechtigkeit auf einen Blick aussieht.</a:t>
+            </a:r>
           </a:p>
         </p:txBody>
       </p:sp>
@@ -3416,10 +3386,8 @@
           <a:lstStyle/>
           <a:p>
             <a:r>
-              <a:rPr lang="en-US" dirty="0"/>
-              <a:t>[Sprecher/in 2] Tabelle 4 hat nur Prozente. Für P(W) und Chi-Quadrat brauchen wir Anzahlen: aus Originaldatensatz, Code prüft Übereinstimmung mit Tabelle 4 (0 Abweichungen). Plausibilisierung: Satz der totalen Wahrscheinlichkeit reproduziert die Totalzeile. Langes DataFrame, wiederholte Schritte als Funktionen. Libraries: pandas, numpy, matplotlib, scipy; alle in Anaconda.</a:t>
-            </a:r>
-            <a:endParaRPr lang="en-US" dirty="0"/>
+              <a:t>[Sprecher/in 2] Vor dem Programmieren haben wir vier Fragen geklärt. Erstens die Daten: Tabelle 4 enthält nur Prozente. Für Wahrscheinlichkeiten wie P(W) und für den Chi-Quadrat-Test brauchen wir aber Anzahlen. Diese übernehmen wir aus dem Originaldatensatz von Bickel und Kollegen aus dem Jahr 1975. Unser Code prüft, dass diese Anzahlen alle Werte aus Tabelle 4 reproduzieren, und findet null Abweichungen. Zweitens die Kontrolle: Mit dem Satz der totalen Wahrscheinlichkeit rechnen wir aus den Fachbereichen die Zeile «Total» nach. Drittens die Struktur: ein langes DataFrame mit einer Zeile pro Fachbereich, Geschlecht und Entscheid. Daraus bauen wir jede Kreuztabelle mit pivot_table. Viertens: Alles, was wir mehrmals brauchen, wird eine Funktion, für die Gesamtbetrachtung und für jeden der sechs Fachbereiche. Unten die Libraries: pandas für Tabellen, numpy zum Rechnen, matplotlib für die Grafiken und scipy.stats für den Chi-Quadrat-Test. pandas ist der Standard für Tabellendaten, McKinney ist übrigens selbst der Autor. Mit matplotlib haben wir volle Kontrolle über Farben und Beschriftungen und können die Grafiken für Ausarbeitung und Folien exportieren. Und scipy liefert einen geprüften Chi-Quadrat-Test, statt dass wir die Formel selbst programmieren und Fehler riskieren. Alle vier Libraries sind in Anaconda enthalten, es braucht also keine zusätzliche Installation.</a:t>
+            </a:r>
           </a:p>
         </p:txBody>
       </p:sp>
@@ -3504,10 +3472,8 @@
           <a:lstStyle/>
           <a:p>
             <a:r>
-              <a:rPr lang="en-US" dirty="0"/>
-              <a:t>[Sprecher/in 2] Ein einziger Vergleich genügt: Gesamtquote. Balken mit Nullachse, Werte direkt beschriftet. Männer 44.5 %, Frauen 30.4 %: 14.2 Prozentpunkte Differenz. Bei der Quote der Männer wären 817 statt 557 Frauen zugelassen worden. Also Diskriminierung? Das klären wir in Teil (c).</a:t>
-            </a:r>
-            <a:endParaRPr lang="en-US" dirty="0"/>
+              <a:t>[Sprecher/in 2] Damit ein Betrachter die Ungerechtigkeit schnell erkennt, reicht ein einziger Vergleich: die Gesamtquote. Wir verwenden ein Balkendiagramm mit Nullachse, weil man Längen am genauesten vergleichen kann, und beschriften die Werte direkt. Wir zeigen bewusst nur zwei Balken, jede weitere Information würde von der Kernaussage ablenken. Die Farben bleiben in allen Diagrammen gleich, Rot für Frauen und Blau für Männer, so muss man nie die Legende suchen. Männer wurden zu 44.5 Prozent zugelassen, Frauen nur zu 30.4 Prozent. Das ist eine Differenz von 14.2 Prozentpunkten, die Quote der Männer ist rund 1.47-mal so hoch. Anders gesagt: Mit der Quote der Männer wären 817 statt 557 Frauen zugelassen worden. Also Diskriminierung? Genau das prüfen wir in Teil (c).</a:t>
+            </a:r>
           </a:p>
         </p:txBody>
       </p:sp>
@@ -3592,10 +3558,8 @@
           <a:lstStyle/>
           <a:p>
             <a:r>
-              <a:rPr lang="en-US" dirty="0"/>
-              <a:t>[Sprecher/in 2] Überleitung zu Teil (c): Jetzt schauen wir genauer hin, Fachbereich für Fachbereich.</a:t>
-            </a:r>
-            <a:endParaRPr lang="en-US" dirty="0"/>
+              <a:t>[Sprecher/in 2] Damit kommen wir zu Teil (c). Die Gesamtquote fasst alle sechs Fachbereiche zusammen. Jetzt schauen wir genauer hin, Fachbereich für Fachbereich.</a:t>
+            </a:r>
           </a:p>
         </p:txBody>
       </p:sp>

</xml_diff>

<commit_message>
Vortrag 4: Namen im Sprechtext, in den Notizen und im Sprecherplan
Reihenfolge wie in der Gruppenliste: Leorat Krasniqi (Folien 1–5),
Teoman-Doganay Lam (6–10), Filip Lazic (11–15).

Co-Authored-By: Claude Opus 5.5 <noreply@anthropic.com>
Claude-Session: https://claude.ai/code/session_013YcN7q2EjK91BTrikonwXA
</commit_message>
<xml_diff>
--- a/vortrag4/Vortrag4_Praesentation.pptx
+++ b/vortrag4/Vortrag4_Praesentation.pptx
@@ -1832,13 +1832,13 @@
           <a:lstStyle/>
           <a:p>
             <a:r>
-              <a:t>[Sprecher/in 1] Guten Tag zusammen. Wir sind Leorat Krasniqi, Teoman-Doganay Lam und Filip Lazic, und unser Vortrag heisst «Das Berkeley-Paradoxon». Rechts sehen Sie schon die zwei Zahlen, um die sich heute alles dreht: 1973 wurden an der UC Berkeley 44.5 Prozent der Männer zugelassen, aber nur 30.4 Prozent der Frauen. Wir zeigen Ihnen in drei Teilen, was hinter diesen Zahlen steckt: zuerst Funktionen in Python, dann die Darstellung der scheinbaren Ungerechtigkeit und zum Schluss den genauen Vergleich mit dem Konzept der stochastischen Unabhängigkeit.</a:t>
+              <a:t>[Leorat Krasniqi (Sprecher/in 1)] Guten Tag zusammen. Wir sind Leorat Krasniqi, Teoman-Doganay Lam und Filip Lazic, und unser Vortrag heisst «Das Berkeley-Paradoxon». Rechts sehen Sie schon die zwei Zahlen, um die sich heute alles dreht: 1973 wurden an der UC Berkeley 44.5 Prozent der Männer zugelassen, aber nur 30.4 Prozent der Frauen. Wir zeigen Ihnen in drei Teilen, was hinter diesen Zahlen steckt: zuerst Funktionen in Python, dann die Darstellung der scheinbaren Ungerechtigkeit und zum Schluss den genauen Vergleich mit dem Konzept der stochastischen Unabhängigkeit.</a:t>
             </a:r>
           </a:p>
           <a:p/>
           <a:p>
             <a:r>
-              <a:t>Zeitplan: ca. 15 Minuten (3 × 5 Min.): Sprecher/in 1 Folien 1–5, Sprecher/in 2 Folien 6–10, Sprecher/in 3 Folien 11–15. Bei 20 Minuten Reservefolien 18–21 einschieben.</a:t>
+              <a:t>Zeitplan: ca. 15 Minuten (3 × 5 Min.): Leorat Folien 1–5, Teoman Folien 6–10, Filip Folien 11–15. Bei 20 Minuten Reservefolien 18–21 einschieben.</a:t>
             </a:r>
           </a:p>
         </p:txBody>
@@ -1924,7 +1924,7 @@
           <a:lstStyle/>
           <a:p>
             <a:r>
-              <a:t>[Sprecher/in 2] Und hier kippt das Bild. In vier von sechs Fachbereichen haben Frauen die höhere Zulassungsquote, nämlich in A, B, D und F. In Fachbereich A sogar um 20.3 Prozentpunkte. Nur in C und E liegen die Männer leicht vorne, mit 2.8 und 3.8 Prozentpunkten. Diese Unterschiede sind klein, der Unterschied in A dagegen ist gross, und zwar zugunsten der Frauen. Übrigens zeichnet dieses Diagramm dieselbe Funktion wie das Diagramm zur Verteilung der Bewerbungen auf der nächsten Folie, nur mit anderen Spalten. In den Fachbereichen, die über die Zulassung entscheiden, sehen wir also keinen Nachteil für Frauen. Wie passt das zur Gesamtquote? Das erklärt [Name Sprecher/in 3].</a:t>
+              <a:t>[Teoman-Doganay Lam (Sprecher/in 2)] Und hier kippt das Bild. In vier von sechs Fachbereichen haben Frauen die höhere Zulassungsquote, nämlich in A, B, D und F. In Fachbereich A sogar um 20.3 Prozentpunkte. Nur in C und E liegen die Männer leicht vorne, mit 2.8 und 3.8 Prozentpunkten. Diese Unterschiede sind klein, der Unterschied in A dagegen ist gross, und zwar zugunsten der Frauen. Übrigens zeichnet dieses Diagramm dieselbe Funktion wie das Diagramm zur Verteilung der Bewerbungen auf der nächsten Folie, nur mit anderen Spalten. In den Fachbereichen, die über die Zulassung entscheiden, sehen wir also keinen Nachteil für Frauen. Wie passt das zur Gesamtquote? Das erklärt Filip.</a:t>
             </a:r>
           </a:p>
         </p:txBody>
@@ -2010,7 +2010,7 @@
           <a:lstStyle/>
           <a:p>
             <a:r>
-              <a:t>[Sprecher/in 3] Danke. Die Antwort liegt darin, wo sich Frauen und Männer beworben haben. 51.5 Prozent der Männer bewarben sich in A oder B, also in Fachbereichen, in denen rund 64 Prozent zugelassen werden. Von den Frauen waren es nur 7.2 Prozent. Allein in Fachbereich A bewarben sich 825 Männer, aber nur 108 Frauen. 92.8 Prozent der Frauen bewarben sich in C bis F, wo die Quoten nur zwischen 6 und 35 Prozent liegen. Im Diagramm sehen Sie das: Bei A und B dominieren die blauen Balken der Männer, bei C bis F die roten Balken der Frauen.</a:t>
+              <a:t>[Filip Lazic (Sprecher/in 3)] Danke. Die Antwort liegt darin, wo sich Frauen und Männer beworben haben. 51.5 Prozent der Männer bewarben sich in A oder B, also in Fachbereichen, in denen rund 64 Prozent zugelassen werden. Von den Frauen waren es nur 7.2 Prozent. Allein in Fachbereich A bewarben sich 825 Männer, aber nur 108 Frauen. 92.8 Prozent der Frauen bewarben sich in C bis F, wo die Quoten nur zwischen 6 und 35 Prozent liegen. Im Diagramm sehen Sie das: Bei A und B dominieren die blauen Balken der Männer, bei C bis F die roten Balken der Frauen.</a:t>
             </a:r>
           </a:p>
         </p:txBody>
@@ -2096,7 +2096,7 @@
           <a:lstStyle/>
           <a:p>
             <a:r>
-              <a:t>[Sprecher/in 3] Hier fassen wir das pro Fachbereich zusammen: auf der x-Achse der Frauenanteil unter den Bewerbungen, auf der y-Achse die Zulassungsquote des Fachbereichs. Die Punktfläche entspricht der Anzahl Bewerbungen. Das Muster ist deutlich: Je höher der Frauenanteil, desto tiefer die Zulassungsquote. Die Korrelation beträgt r gleich minus 0.79. Frauen haben sich also häufiger in Fachbereichen beworben, die stark umkämpft sind.</a:t>
+              <a:t>[Filip Lazic (Sprecher/in 3)] Hier fassen wir das pro Fachbereich zusammen: auf der x-Achse der Frauenanteil unter den Bewerbungen, auf der y-Achse die Zulassungsquote des Fachbereichs. Die Punktfläche entspricht der Anzahl Bewerbungen. Das Muster ist deutlich: Je höher der Frauenanteil, desto tiefer die Zulassungsquote. Die Korrelation beträgt r gleich minus 0.79. Frauen haben sich also häufiger in Fachbereichen beworben, die stark umkämpft sind.</a:t>
             </a:r>
           </a:p>
         </p:txBody>
@@ -2182,7 +2182,7 @@
           <a:lstStyle/>
           <a:p>
             <a:r>
-              <a:t>[Sprecher/in 3] Warum führt das zur tieferen Gesamtquote? Wegen des Satzes der totalen Wahrscheinlichkeit. Die Gesamtquote eines Geschlechts ist ein gewichteter Mittelwert der Quoten in den Fachbereichen, und die Gewichte sind die Anteile der Bewerbungen. Für die Frauen heisst das: 5.9 Prozent mal 82.4 Prozent plus 1.4 Prozent mal 68 Prozent und so weiter, das ergibt 30.4 Prozent. Frauen haben ihre grossen Gewichte bei den tiefen Quoten, Männer bei den hohen. Was passiert, wenn wir für beide Geschlechter dieselben Gewichte einsetzen, nämlich die Verteilung aller Bewerbungen? Dann liegt die Quote der Frauen bei 43.0 Prozent und die der Männer bei 38.7 Prozent. Der Unterschied kehrt sich um. Im Code ist das derselbe Aufruf der Funktion gesamtquote, nur mit anderen Gewichten.</a:t>
+              <a:t>[Filip Lazic (Sprecher/in 3)] Warum führt das zur tieferen Gesamtquote? Wegen des Satzes der totalen Wahrscheinlichkeit. Die Gesamtquote eines Geschlechts ist ein gewichteter Mittelwert der Quoten in den Fachbereichen, und die Gewichte sind die Anteile der Bewerbungen. Für die Frauen heisst das: 5.9 Prozent mal 82.4 Prozent plus 1.4 Prozent mal 68 Prozent und so weiter, das ergibt 30.4 Prozent. Frauen haben ihre grossen Gewichte bei den tiefen Quoten, Männer bei den hohen. Was passiert, wenn wir für beide Geschlechter dieselben Gewichte einsetzen, nämlich die Verteilung aller Bewerbungen? Dann liegt die Quote der Frauen bei 43.0 Prozent und die der Männer bei 38.7 Prozent. Der Unterschied kehrt sich um. Im Code ist das derselbe Aufruf der Funktion gesamtquote, nur mit anderen Gewichten.</a:t>
             </a:r>
           </a:p>
         </p:txBody>
@@ -2268,7 +2268,7 @@
           <a:lstStyle/>
           <a:p>
             <a:r>
-              <a:t>[Sprecher/in 3] Jetzt zur stochastischen Unabhängigkeit. Zwei Ereignisse sind unabhängig, wenn P von Z geschnitten W gleich P von Z mal P von W ist, oder gleichwertig: wenn P von Z gegeben W gleich P von Z ist. Z heisst «zugelassen», W heisst «Bewerbung einer Frau». Insgesamt beobachten wir 0.1231, bei Unabhängigkeit müssten es 0.1572 sein. Der Chi-Quadrat-Test bestätigt das mit einem Wert von 92.2 und einem p-Wert unter 0.001. Insgesamt sind Zulassung und Geschlecht also abhängig. Innerhalb der Fachbereiche B bis F liegen die Werte aber sehr nahe beieinander, alle p-Werte sind grösser als 0.3. Dort können wir die Unabhängigkeit nicht verwerfen. Nur in Fachbereich A gibt es eine Abhängigkeit, und zwar zugunsten der Frauen. Man spricht von bedingter Unabhängigkeit gegeben den Fachbereich. Der Fachbereich ist die Drittvariable, auch Confounder genannt.</a:t>
+              <a:t>[Filip Lazic (Sprecher/in 3)] Jetzt zur stochastischen Unabhängigkeit. Zwei Ereignisse sind unabhängig, wenn P von Z geschnitten W gleich P von Z mal P von W ist, oder gleichwertig: wenn P von Z gegeben W gleich P von Z ist. Z heisst «zugelassen», W heisst «Bewerbung einer Frau». Insgesamt beobachten wir 0.1231, bei Unabhängigkeit müssten es 0.1572 sein. Der Chi-Quadrat-Test bestätigt das mit einem Wert von 92.2 und einem p-Wert unter 0.001. Insgesamt sind Zulassung und Geschlecht also abhängig. Innerhalb der Fachbereiche B bis F liegen die Werte aber sehr nahe beieinander, alle p-Werte sind grösser als 0.3. Dort können wir die Unabhängigkeit nicht verwerfen. Nur in Fachbereich A gibt es eine Abhängigkeit, und zwar zugunsten der Frauen. Man spricht von bedingter Unabhängigkeit gegeben den Fachbereich. Der Fachbereich ist die Drittvariable, auch Confounder genannt.</a:t>
             </a:r>
           </a:p>
         </p:txBody>
@@ -2354,7 +2354,7 @@
           <a:lstStyle/>
           <a:p>
             <a:r>
-              <a:t>[Sprecher/in 3] Zum Fazit. Die Drittvariable Fachbereich kehrt den Zusammenhang um, das ist das Simpson-Paradoxon. Aggregiert sind Zulassung und Geschlecht abhängig, 30.4 gegen 44.5 Prozent. Je Fachbereich gibt es keinen Nachteil für Frauen. Die Ursache ist, dass sich Frauen häufiger in stark umkämpften Fachbereichen beworben haben. Wir müssen aber auch die Grenzen nennen: Es sind Beobachtungsdaten eines einzigen Jahres, und warum Frauen diese Fachbereiche gewählt haben, können die Daten nicht beantworten. Programmtechnisch hat sich gezeigt: Mit denselben Funktionen konnten wir die Gesamtanalyse, alle sechs Fachbereiche und die Standardisierung rechnen. Unsere wichtigste Lehre: Aggregierte Quoten darf man erst dann als Ursache deuten, wenn man relevante Drittvariablen berücksichtigt hat.</a:t>
+              <a:t>[Filip Lazic (Sprecher/in 3)] Zum Fazit. Die Drittvariable Fachbereich kehrt den Zusammenhang um, das ist das Simpson-Paradoxon. Aggregiert sind Zulassung und Geschlecht abhängig, 30.4 gegen 44.5 Prozent. Je Fachbereich gibt es keinen Nachteil für Frauen. Die Ursache ist, dass sich Frauen häufiger in stark umkämpften Fachbereichen beworben haben. Wir müssen aber auch die Grenzen nennen: Es sind Beobachtungsdaten eines einzigen Jahres, und warum Frauen diese Fachbereiche gewählt haben, können die Daten nicht beantworten. Programmtechnisch hat sich gezeigt: Mit denselben Funktionen konnten wir die Gesamtanalyse, alle sechs Fachbereiche und die Standardisierung rechnen. Unsere wichtigste Lehre: Aggregierte Quoten darf man erst dann als Ursache deuten, wenn man relevante Drittvariablen berücksichtigt hat.</a:t>
             </a:r>
           </a:p>
         </p:txBody>
@@ -2612,7 +2612,7 @@
           <a:lstStyle/>
           <a:p>
             <a:r>
-              <a:t>[Sprecher/in 3] Einsatz nach Folie 13. Diese Tabelle rechnet die Gesamtquote vor. In jeder Zeile multiplizieren wir den Anteil der Bewerbungen mit der Zulassungsquote. Das ergibt den Beitrag des Fachbereichs. Bei den Frauen liegen die grossen Gewichte bei C bis F, zusammen 92.8 Prozent, und dort sind die Quoten tief. Darum ergibt die Summe nur 30.4 Prozent. Bei den Männern liegen 51.5 Prozent der Gewichte bei A und B mit hohen Quoten, die Summe ergibt 44.6 Prozent. Dass es nicht genau 44.5 sind, ist nur ein Rundungseffekt von Tabelle 4.</a:t>
+              <a:t>[Filip Lazic (Sprecher/in 3)] Einsatz nach Folie 13. Diese Tabelle rechnet die Gesamtquote vor. In jeder Zeile multiplizieren wir den Anteil der Bewerbungen mit der Zulassungsquote. Das ergibt den Beitrag des Fachbereichs. Bei den Frauen liegen die grossen Gewichte bei C bis F, zusammen 92.8 Prozent, und dort sind die Quoten tief. Darum ergibt die Summe nur 30.4 Prozent. Bei den Männern liegen 51.5 Prozent der Gewichte bei A und B mit hohen Quoten, die Summe ergibt 44.6 Prozent. Dass es nicht genau 44.5 sind, ist nur ein Rundungseffekt von Tabelle 4.</a:t>
             </a:r>
           </a:p>
         </p:txBody>
@@ -2698,7 +2698,7 @@
           <a:lstStyle/>
           <a:p>
             <a:r>
-              <a:t>[Sprecher/in 3] Einsatz nach Folie 14. So funktioniert der Chi-Quadrat-Test. Die Nullhypothese lautet: Zulassung und Geschlecht sind unabhängig. Dann erwarten wir in jeder Zelle n mal P von Z mal P von W. Für zugelassene Frauen wären das 711.5, beobachtet sind aber nur 557. Die Teststatistik summiert über alle vier Zellen die quadrierte Abweichung geteilt durch den erwarteten Wert. Das ergibt 92.2. Bei einem Freiheitsgrad liegt der kritische Wert für 5 Prozent bei 3.84. Wir verwerfen die Nullhypothese also klar. Im Code genügt ein einziger Aufruf: chi2_contingency.</a:t>
+              <a:t>[Filip Lazic (Sprecher/in 3)] Einsatz nach Folie 14. So funktioniert der Chi-Quadrat-Test. Die Nullhypothese lautet: Zulassung und Geschlecht sind unabhängig. Dann erwarten wir in jeder Zelle n mal P von Z mal P von W. Für zugelassene Frauen wären das 711.5, beobachtet sind aber nur 557. Die Teststatistik summiert über alle vier Zellen die quadrierte Abweichung geteilt durch den erwarteten Wert. Das ergibt 92.2. Bei einem Freiheitsgrad liegt der kritische Wert für 5 Prozent bei 3.84. Wir verwerfen die Nullhypothese also klar. Im Code genügt ein einziger Aufruf: chi2_contingency.</a:t>
             </a:r>
           </a:p>
         </p:txBody>
@@ -2784,7 +2784,7 @@
           <a:lstStyle/>
           <a:p>
             <a:r>
-              <a:t>[Sprecher/in 1] Zur Ausgangslage: Im Herbst 1973 bewarben sich 4 526 Personen für ein Graduate-Studium in den sechs grössten Fachbereichen der Universität, die wir A bis F nennen. Weil insgesamt deutlich weniger Frauen zugelassen wurden, befürchtete die Universität eine Klage wegen Diskriminierung. Tabelle 4 unserer Aufgabe zeigt für jeden Fachbereich die Zulassungsquote von Frauen und Männern und wie sich die Bewerbungen auf die Fachbereiche verteilen. Unsere Aufgabe hat drei Teile: (a) Funktionen in Python erklären, (b) die Ungerechtigkeit so darstellen, dass man sie auf einen Blick sieht, und (c) die Verteilungen vergleichen und dabei die stochastische Unabhängigkeit prüfen. Die zentrale Frage lautet also: Wurden Frauen bei der Zulassung tatsächlich benachteiligt?</a:t>
+              <a:t>[Leorat Krasniqi (Sprecher/in 1)] Zur Ausgangslage: Im Herbst 1973 bewarben sich 4 526 Personen für ein Graduate-Studium in den sechs grössten Fachbereichen der Universität, die wir A bis F nennen. Weil insgesamt deutlich weniger Frauen zugelassen wurden, befürchtete die Universität eine Klage wegen Diskriminierung. Tabelle 4 unserer Aufgabe zeigt für jeden Fachbereich die Zulassungsquote von Frauen und Männern und wie sich die Bewerbungen auf die Fachbereiche verteilen. Unsere Aufgabe hat drei Teile: (a) Funktionen in Python erklären, (b) die Ungerechtigkeit so darstellen, dass man sie auf einen Blick sieht, und (c) die Verteilungen vergleichen und dabei die stochastische Unabhängigkeit prüfen. Die zentrale Frage lautet also: Wurden Frauen bei der Zulassung tatsächlich benachteiligt?</a:t>
             </a:r>
           </a:p>
         </p:txBody>
@@ -2870,7 +2870,7 @@
           <a:lstStyle/>
           <a:p>
             <a:r>
-              <a:t>[Sprecher/in 3] Einsatz nach Folie 14 oder bei der Frage nach Kausalität. Hier sieht man die Struktur des Problems. Das Geschlecht hängt stark mit der Wahl des Fachbereichs zusammen, Chi-Quadrat 1 068.4. Und der Fachbereich hängt stark mit der Zulassung zusammen, Chi-Quadrat 778.9. Der direkte Effekt des Geschlechts auf die Zulassung ist innerhalb der Fachbereiche kaum vorhanden. Der Fachbereich ist also der Confounder, der den Zusammenhang insgesamt erzeugt. Korrelation ist nicht Kausalität.</a:t>
+              <a:t>[Filip Lazic (Sprecher/in 3)] Einsatz nach Folie 14 oder bei der Frage nach Kausalität. Hier sieht man die Struktur des Problems. Das Geschlecht hängt stark mit der Wahl des Fachbereichs zusammen, Chi-Quadrat 1 068.4. Und der Fachbereich hängt stark mit der Zulassung zusammen, Chi-Quadrat 778.9. Der direkte Effekt des Geschlechts auf die Zulassung ist innerhalb der Fachbereiche kaum vorhanden. Der Fachbereich ist also der Confounder, der den Zusammenhang insgesamt erzeugt. Korrelation ist nicht Kausalität.</a:t>
             </a:r>
           </a:p>
         </p:txBody>
@@ -2956,7 +2956,7 @@
           <a:lstStyle/>
           <a:p>
             <a:r>
-              <a:t>[Sprecher/in 2] Einsatz nach Folie 7, falls nach dem Aufbau des Codes gefragt wird. Hier sieht man den Ablauf unseres Programms in fünf Schritten. Erstens erfassen wir Tabelle 4 als Text und bereinigen sie mit einer Liste von Funktionen. Zweitens prüfen wir sie mit dem Satz der totalen Wahrscheinlichkeit. Drittens laden wir die Originalanzahlen in ein langes DataFrame und prüfen sie gegen Tabelle 4. Viertens analysieren wir mit denselben Funktionen gesamt und je Fachbereich. Fünftens zeichnen wir die Diagramme mit einer festen Farbe pro Geschlecht. Dahinter stehen drei Prinzipien: Jeder wiederholte Schritt ist eine Funktion, wir verwenden kein global, und Fehler werden durch try/except und zwei Gegenproben sofort sichtbar.</a:t>
+              <a:t>[Teoman-Doganay Lam (Sprecher/in 2)] Einsatz nach Folie 7, falls nach dem Aufbau des Codes gefragt wird. Hier sieht man den Ablauf unseres Programms in fünf Schritten. Erstens erfassen wir Tabelle 4 als Text und bereinigen sie mit einer Liste von Funktionen. Zweitens prüfen wir sie mit dem Satz der totalen Wahrscheinlichkeit. Drittens laden wir die Originalanzahlen in ein langes DataFrame und prüfen sie gegen Tabelle 4. Viertens analysieren wir mit denselben Funktionen gesamt und je Fachbereich. Fünftens zeichnen wir die Diagramme mit einer festen Farbe pro Geschlecht. Dahinter stehen drei Prinzipien: Jeder wiederholte Schritt ist eine Funktion, wir verwenden kein global, und Fehler werden durch try/except und zwei Gegenproben sofort sichtbar.</a:t>
             </a:r>
           </a:p>
         </p:txBody>
@@ -3042,7 +3042,7 @@
           <a:lstStyle/>
           <a:p>
             <a:r>
-              <a:t>[Sprecher/in 1] Wir beginnen mit Teil (a). Bevor wir die Daten analysieren, zeigen wir das Werkzeug, mit dem wir unseren ganzen Code organisiert haben: Funktionen.</a:t>
+              <a:t>[Leorat Krasniqi (Sprecher/in 1)] Wir beginnen mit Teil (a). Bevor wir die Daten analysieren, zeigen wir das Werkzeug, mit dem wir unseren ganzen Code organisiert haben: Funktionen.</a:t>
             </a:r>
           </a:p>
         </p:txBody>
@@ -3128,7 +3128,7 @@
           <a:lstStyle/>
           <a:p>
             <a:r>
-              <a:t>[Sprecher/in 1] McKinney nennt eine einfache Faustregel: Code, den man mehr als einmal braucht, gehört in eine Funktion. Eine Funktion wird mit def deklariert und gibt ihr Ergebnis mit return zurück. Fehlt das return, gibt Python automatisch None zurück. Man unterscheidet Positionsargumente, die über ihre Reihenfolge zugeordnet werden, und Keyword-Argumente, die einen Namen und oft einen Standardwert haben. Keyword-Argumente müssen nach den Positionsargumenten stehen, untereinander ist ihre Reihenfolge aber egal. Rechts sehen Sie unsere Funktion vierfeldertafel: Ohne Angabe gilt fachbereich gleich None, dann wird die Tafel über alle Bewerbungen gebildet. Mit fachbereich gleich A nur für Fachbereich A. Variablen in einer Funktion leben in einem lokalen Namensraum, der beim Aufruf entsteht und danach wieder verschwindet. Globale Variablen vermeiden wir bewusst. Und eine Funktion kann scheinbar mehrere Werte zurückgeben. Tatsächlich ist es ein Tupel, das wir beim Aufruf entpacken, wie unten bei kennzahlen: quote, anteil gleich kennzahlen von 89, 19 und 1 835.</a:t>
+              <a:t>[Leorat Krasniqi (Sprecher/in 1)] McKinney nennt eine einfache Faustregel: Code, den man mehr als einmal braucht, gehört in eine Funktion. Eine Funktion wird mit def deklariert und gibt ihr Ergebnis mit return zurück. Fehlt das return, gibt Python automatisch None zurück. Man unterscheidet Positionsargumente, die über ihre Reihenfolge zugeordnet werden, und Keyword-Argumente, die einen Namen und oft einen Standardwert haben. Keyword-Argumente müssen nach den Positionsargumenten stehen, untereinander ist ihre Reihenfolge aber egal. Rechts sehen Sie unsere Funktion vierfeldertafel: Ohne Angabe gilt fachbereich gleich None, dann wird die Tafel über alle Bewerbungen gebildet. Mit fachbereich gleich A nur für Fachbereich A. Variablen in einer Funktion leben in einem lokalen Namensraum, der beim Aufruf entsteht und danach wieder verschwindet. Globale Variablen vermeiden wir bewusst. Und eine Funktion kann scheinbar mehrere Werte zurückgeben. Tatsächlich ist es ein Tupel, das wir beim Aufruf entpacken, wie unten bei kennzahlen: quote, anteil gleich kennzahlen von 89, 19 und 1 835.</a:t>
             </a:r>
           </a:p>
         </p:txBody>
@@ -3214,7 +3214,7 @@
           <a:lstStyle/>
           <a:p>
             <a:r>
-              <a:t>[Sprecher/in 1] Vier weitere Konzepte aus Abschnitt 3.2. Erstens: Funktionen sind Objekte. Wir speichern unsere Bereinigungsschritte in einer Liste und wenden sie nacheinander auf jeden Wert aus Tabelle 4 an. So wird aus dem Text «82.4%» die Zahl 0.824. Der Vorteil: Kommt ein weiterer Bereinigungsschritt dazu, fügen wir ihn nur in die Liste ein, die Funktion selbst bleibt gleich. Zweitens: Lambda-Funktionen sind anonyme Einzeiler, ideal, wenn man eine Funktion als Argument übergibt. Mit partial legen wir ein Argument fest, das nennt man Currying: pruefe_streng ist derselbe Test, nur mit einem Signifikanzniveau von 1 Prozent. Drittens: Ein Generator liefert mit yield die Ergebnisse erst dann, wenn sie angefordert werden, bei uns Fachbereich für Fachbereich. Viertens: Bei der Ausnahmebehandlung fangen wir nur den erwarteten Fehler ab, den ValueError bei einem Tippfehler in der Tabelle. Andere Fehler sollen sichtbar bleiben. Damit übergebe ich an [Name Sprecher/in 2].</a:t>
+              <a:t>[Leorat Krasniqi (Sprecher/in 1)] Vier weitere Konzepte aus Abschnitt 3.2. Erstens: Funktionen sind Objekte. Wir speichern unsere Bereinigungsschritte in einer Liste und wenden sie nacheinander auf jeden Wert aus Tabelle 4 an. So wird aus dem Text «82.4%» die Zahl 0.824. Der Vorteil: Kommt ein weiterer Bereinigungsschritt dazu, fügen wir ihn nur in die Liste ein, die Funktion selbst bleibt gleich. Zweitens: Lambda-Funktionen sind anonyme Einzeiler, ideal, wenn man eine Funktion als Argument übergibt. Mit partial legen wir ein Argument fest, das nennt man Currying: pruefe_streng ist derselbe Test, nur mit einem Signifikanzniveau von 1 Prozent. Drittens: Ein Generator liefert mit yield die Ergebnisse erst dann, wenn sie angefordert werden, bei uns Fachbereich für Fachbereich. Viertens: Bei der Ausnahmebehandlung fangen wir nur den erwarteten Fehler ab, den ValueError bei einem Tippfehler in der Tabelle. Andere Fehler sollen sichtbar bleiben. Damit übergebe ich an Teoman.</a:t>
             </a:r>
           </a:p>
         </p:txBody>
@@ -3300,7 +3300,7 @@
           <a:lstStyle/>
           <a:p>
             <a:r>
-              <a:t>[Sprecher/in 2] Danke. Ich übernehme Teil (b). Ein Schwerpunkt der Aufgabe liegt auf den Vorüberlegungen zur programmtechnischen Umsetzung. Deshalb zeige ich zuerst, wie wir die Umsetzung geplant haben, und danach, wie die Ungerechtigkeit auf einen Blick aussieht.</a:t>
+              <a:t>[Teoman-Doganay Lam (Sprecher/in 2)] Danke. Ich übernehme Teil (b). Ein Schwerpunkt der Aufgabe liegt auf den Vorüberlegungen zur programmtechnischen Umsetzung. Deshalb zeige ich zuerst, wie wir die Umsetzung geplant haben, und danach, wie die Ungerechtigkeit auf einen Blick aussieht.</a:t>
             </a:r>
           </a:p>
         </p:txBody>
@@ -3386,7 +3386,7 @@
           <a:lstStyle/>
           <a:p>
             <a:r>
-              <a:t>[Sprecher/in 2] Vor dem Programmieren haben wir vier Fragen geklärt. Erstens die Daten: Tabelle 4 enthält nur Prozente. Für Wahrscheinlichkeiten wie P(W) und für den Chi-Quadrat-Test brauchen wir aber Anzahlen. Diese übernehmen wir aus dem Originaldatensatz von Bickel und Kollegen aus dem Jahr 1975. Unser Code prüft, dass diese Anzahlen alle Werte aus Tabelle 4 reproduzieren, und findet null Abweichungen. Zweitens die Kontrolle: Mit dem Satz der totalen Wahrscheinlichkeit rechnen wir aus den Fachbereichen die Zeile «Total» nach. Drittens die Struktur: ein langes DataFrame mit einer Zeile pro Fachbereich, Geschlecht und Entscheid. Daraus bauen wir jede Kreuztabelle mit pivot_table. Viertens: Alles, was wir mehrmals brauchen, wird eine Funktion, für die Gesamtbetrachtung und für jeden der sechs Fachbereiche. Unten die Libraries: pandas für Tabellen, numpy zum Rechnen, matplotlib für die Grafiken und scipy.stats für den Chi-Quadrat-Test. pandas ist der Standard für Tabellendaten, McKinney ist übrigens selbst der Autor. Mit matplotlib haben wir volle Kontrolle über Farben und Beschriftungen und können die Grafiken für Ausarbeitung und Folien exportieren. Und scipy liefert einen geprüften Chi-Quadrat-Test, statt dass wir die Formel selbst programmieren und Fehler riskieren. Alle vier Libraries sind in Anaconda enthalten, es braucht also keine zusätzliche Installation.</a:t>
+              <a:t>[Teoman-Doganay Lam (Sprecher/in 2)] Vor dem Programmieren haben wir vier Fragen geklärt. Erstens die Daten: Tabelle 4 enthält nur Prozente. Für Wahrscheinlichkeiten wie P(W) und für den Chi-Quadrat-Test brauchen wir aber Anzahlen. Diese übernehmen wir aus dem Originaldatensatz von Bickel und Kollegen aus dem Jahr 1975. Unser Code prüft, dass diese Anzahlen alle Werte aus Tabelle 4 reproduzieren, und findet null Abweichungen. Zweitens die Kontrolle: Mit dem Satz der totalen Wahrscheinlichkeit rechnen wir aus den Fachbereichen die Zeile «Total» nach. Drittens die Struktur: ein langes DataFrame mit einer Zeile pro Fachbereich, Geschlecht und Entscheid. Daraus bauen wir jede Kreuztabelle mit pivot_table. Viertens: Alles, was wir mehrmals brauchen, wird eine Funktion, für die Gesamtbetrachtung und für jeden der sechs Fachbereiche. Unten die Libraries: pandas für Tabellen, numpy zum Rechnen, matplotlib für die Grafiken und scipy.stats für den Chi-Quadrat-Test. pandas ist der Standard für Tabellendaten, McKinney ist übrigens selbst der Autor. Mit matplotlib haben wir volle Kontrolle über Farben und Beschriftungen und können die Grafiken für Ausarbeitung und Folien exportieren. Und scipy liefert einen geprüften Chi-Quadrat-Test, statt dass wir die Formel selbst programmieren und Fehler riskieren. Alle vier Libraries sind in Anaconda enthalten, es braucht also keine zusätzliche Installation.</a:t>
             </a:r>
           </a:p>
         </p:txBody>
@@ -3472,7 +3472,7 @@
           <a:lstStyle/>
           <a:p>
             <a:r>
-              <a:t>[Sprecher/in 2] Damit ein Betrachter die Ungerechtigkeit schnell erkennt, reicht ein einziger Vergleich: die Gesamtquote. Wir verwenden ein Balkendiagramm mit Nullachse, weil man Längen am genauesten vergleichen kann, und beschriften die Werte direkt. Wir zeigen bewusst nur zwei Balken, jede weitere Information würde von der Kernaussage ablenken. Die Farben bleiben in allen Diagrammen gleich, Rot für Frauen und Blau für Männer, so muss man nie die Legende suchen. Männer wurden zu 44.5 Prozent zugelassen, Frauen nur zu 30.4 Prozent. Das ist eine Differenz von 14.2 Prozentpunkten, die Quote der Männer ist rund 1.47-mal so hoch. Anders gesagt: Mit der Quote der Männer wären 817 statt 557 Frauen zugelassen worden. Also Diskriminierung? Genau das prüfen wir in Teil (c).</a:t>
+              <a:t>[Teoman-Doganay Lam (Sprecher/in 2)] Damit ein Betrachter die Ungerechtigkeit schnell erkennt, reicht ein einziger Vergleich: die Gesamtquote. Wir verwenden ein Balkendiagramm mit Nullachse, weil man Längen am genauesten vergleichen kann, und beschriften die Werte direkt. Wir zeigen bewusst nur zwei Balken, jede weitere Information würde von der Kernaussage ablenken. Die Farben bleiben in allen Diagrammen gleich, Rot für Frauen und Blau für Männer, so muss man nie die Legende suchen. Männer wurden zu 44.5 Prozent zugelassen, Frauen nur zu 30.4 Prozent. Das ist eine Differenz von 14.2 Prozentpunkten, die Quote der Männer ist rund 1.47-mal so hoch. Anders gesagt: Mit der Quote der Männer wären 817 statt 557 Frauen zugelassen worden. Also Diskriminierung? Genau das prüfen wir in Teil (c).</a:t>
             </a:r>
           </a:p>
         </p:txBody>
@@ -3558,7 +3558,7 @@
           <a:lstStyle/>
           <a:p>
             <a:r>
-              <a:t>[Sprecher/in 2] Damit kommen wir zu Teil (c). Die Gesamtquote fasst alle sechs Fachbereiche zusammen. Jetzt schauen wir genauer hin, Fachbereich für Fachbereich.</a:t>
+              <a:t>[Teoman-Doganay Lam (Sprecher/in 2)] Damit kommen wir zu Teil (c). Die Gesamtquote fasst alle sechs Fachbereiche zusammen. Jetzt schauen wir genauer hin, Fachbereich für Fachbereich.</a:t>
             </a:r>
           </a:p>
         </p:txBody>

</xml_diff>

<commit_message>
Vortrag 4: fix 15 Minuten, Reservefolien nur für Rückfragen
20-Minuten-Variante aus Sprecherplan, Sprechtext, Notizen, Reserve-Trennfolie und README entfernt.

Co-Authored-By: Claude Opus 5.5 <noreply@anthropic.com>
Claude-Session: https://claude.ai/code/session_013YcN7q2EjK91BTrikonwXA
</commit_message>
<xml_diff>
--- a/vortrag4/Vortrag4_Praesentation.pptx
+++ b/vortrag4/Vortrag4_Praesentation.pptx
@@ -1838,7 +1838,7 @@
           <a:p/>
           <a:p>
             <a:r>
-              <a:t>Zeitplan: ca. 15 Minuten (3 × 5 Min.): Leorat Folien 1–5, Teoman Folien 6–10, Filip Folien 11–15. Bei 20 Minuten Reservefolien 18–21 einschieben.</a:t>
+              <a:t>Zeitplan: ca. 15 Minuten (3 × 5 Min.): Leorat Folien 1–5, Teoman Folien 6–10, Filip Folien 11–15. Folie 16: Fragen. Reservefolien 18–21 nur bei Rückfragen zeigen.</a:t>
             </a:r>
           </a:p>
         </p:txBody>
@@ -2526,7 +2526,7 @@
           <a:lstStyle/>
           <a:p>
             <a:r>
-              <a:t>Trennfolie, wird nicht vorgetragen. Bei 20 Minuten: Folie 21 nach Folie 7, Folie 18 nach Folie 13, Folien 19 und 20 nach Folie 14 einschieben.</a:t>
+              <a:t>Trennfolie, wird nicht vorgetragen. Die Folien 18–21 sind nur für Rückfragen: 18 zu Folie 13, 19 und 20 zu Folie 14, 21 zu Folie 7.</a:t>
             </a:r>
           </a:p>
         </p:txBody>
@@ -2612,7 +2612,7 @@
           <a:lstStyle/>
           <a:p>
             <a:r>
-              <a:t>[Filip Lazic (Sprecher/in 3)] Einsatz nach Folie 13. Diese Tabelle rechnet die Gesamtquote vor. In jeder Zeile multiplizieren wir den Anteil der Bewerbungen mit der Zulassungsquote. Das ergibt den Beitrag des Fachbereichs. Bei den Frauen liegen die grossen Gewichte bei C bis F, zusammen 92.8 Prozent, und dort sind die Quoten tief. Darum ergibt die Summe nur 30.4 Prozent. Bei den Männern liegen 51.5 Prozent der Gewichte bei A und B mit hohen Quoten, die Summe ergibt 44.6 Prozent. Dass es nicht genau 44.5 sind, ist nur ein Rundungseffekt von Tabelle 4.</a:t>
+              <a:t>[Filip Lazic (Sprecher/in 3)] Nur bei Rückfrage zu Folie 13. Diese Tabelle rechnet die Gesamtquote vor. In jeder Zeile multiplizieren wir den Anteil der Bewerbungen mit der Zulassungsquote. Das ergibt den Beitrag des Fachbereichs. Bei den Frauen liegen die grossen Gewichte bei C bis F, zusammen 92.8 Prozent, und dort sind die Quoten tief. Darum ergibt die Summe nur 30.4 Prozent. Bei den Männern liegen 51.5 Prozent der Gewichte bei A und B mit hohen Quoten, die Summe ergibt 44.6 Prozent. Dass es nicht genau 44.5 sind, ist nur ein Rundungseffekt von Tabelle 4.</a:t>
             </a:r>
           </a:p>
         </p:txBody>
@@ -2698,7 +2698,7 @@
           <a:lstStyle/>
           <a:p>
             <a:r>
-              <a:t>[Filip Lazic (Sprecher/in 3)] Einsatz nach Folie 14. So funktioniert der Chi-Quadrat-Test. Die Nullhypothese lautet: Zulassung und Geschlecht sind unabhängig. Dann erwarten wir in jeder Zelle n mal P von Z mal P von W. Für zugelassene Frauen wären das 711.5, beobachtet sind aber nur 557. Die Teststatistik summiert über alle vier Zellen die quadrierte Abweichung geteilt durch den erwarteten Wert. Das ergibt 92.2. Bei einem Freiheitsgrad liegt der kritische Wert für 5 Prozent bei 3.84. Wir verwerfen die Nullhypothese also klar. Im Code genügt ein einziger Aufruf: chi2_contingency.</a:t>
+              <a:t>[Filip Lazic (Sprecher/in 3)] Nur bei Rückfrage zu Folie 14. So funktioniert der Chi-Quadrat-Test. Die Nullhypothese lautet: Zulassung und Geschlecht sind unabhängig. Dann erwarten wir in jeder Zelle n mal P von Z mal P von W. Für zugelassene Frauen wären das 711.5, beobachtet sind aber nur 557. Die Teststatistik summiert über alle vier Zellen die quadrierte Abweichung geteilt durch den erwarteten Wert. Das ergibt 92.2. Bei einem Freiheitsgrad liegt der kritische Wert für 5 Prozent bei 3.84. Wir verwerfen die Nullhypothese also klar. Im Code genügt ein einziger Aufruf: chi2_contingency.</a:t>
             </a:r>
           </a:p>
         </p:txBody>
@@ -2870,7 +2870,7 @@
           <a:lstStyle/>
           <a:p>
             <a:r>
-              <a:t>[Filip Lazic (Sprecher/in 3)] Einsatz nach Folie 14 oder bei der Frage nach Kausalität. Hier sieht man die Struktur des Problems. Das Geschlecht hängt stark mit der Wahl des Fachbereichs zusammen, Chi-Quadrat 1 068.4. Und der Fachbereich hängt stark mit der Zulassung zusammen, Chi-Quadrat 778.9. Der direkte Effekt des Geschlechts auf die Zulassung ist innerhalb der Fachbereiche kaum vorhanden. Der Fachbereich ist also der Confounder, der den Zusammenhang insgesamt erzeugt. Korrelation ist nicht Kausalität.</a:t>
+              <a:t>[Filip Lazic (Sprecher/in 3)] Nur bei Rückfrage zu Folie 14 oder bei der Frage nach Kausalität. Hier sieht man die Struktur des Problems. Das Geschlecht hängt stark mit der Wahl des Fachbereichs zusammen, Chi-Quadrat 1 068.4. Und der Fachbereich hängt stark mit der Zulassung zusammen, Chi-Quadrat 778.9. Der direkte Effekt des Geschlechts auf die Zulassung ist innerhalb der Fachbereiche kaum vorhanden. Der Fachbereich ist also der Confounder, der den Zusammenhang insgesamt erzeugt. Korrelation ist nicht Kausalität.</a:t>
             </a:r>
           </a:p>
         </p:txBody>
@@ -2956,7 +2956,7 @@
           <a:lstStyle/>
           <a:p>
             <a:r>
-              <a:t>[Teoman-Doganay Lam (Sprecher/in 2)] Einsatz nach Folie 7, falls nach dem Aufbau des Codes gefragt wird. Hier sieht man den Ablauf unseres Programms in fünf Schritten. Erstens erfassen wir Tabelle 4 als Text und bereinigen sie mit einer Liste von Funktionen. Zweitens prüfen wir sie mit dem Satz der totalen Wahrscheinlichkeit. Drittens laden wir die Originalanzahlen in ein langes DataFrame und prüfen sie gegen Tabelle 4. Viertens analysieren wir mit denselben Funktionen gesamt und je Fachbereich. Fünftens zeichnen wir die Diagramme mit einer festen Farbe pro Geschlecht. Dahinter stehen drei Prinzipien: Jeder wiederholte Schritt ist eine Funktion, wir verwenden kein global, und Fehler werden durch try/except und zwei Gegenproben sofort sichtbar.</a:t>
+              <a:t>[Teoman-Doganay Lam (Sprecher/in 2)] Nur bei Rückfrage zu Folie 7, falls nach dem Aufbau des Codes gefragt wird. Hier sieht man den Ablauf unseres Programms in fünf Schritten. Erstens erfassen wir Tabelle 4 als Text und bereinigen sie mit einer Liste von Funktionen. Zweitens prüfen wir sie mit dem Satz der totalen Wahrscheinlichkeit. Drittens laden wir die Originalanzahlen in ein langes DataFrame und prüfen sie gegen Tabelle 4. Viertens analysieren wir mit denselben Funktionen gesamt und je Fachbereich. Fünftens zeichnen wir die Diagramme mit einer festen Farbe pro Geschlecht. Dahinter stehen drei Prinzipien: Jeder wiederholte Schritt ist eine Funktion, wir verwenden kein global, und Fehler werden durch try/except und zwei Gegenproben sofort sichtbar.</a:t>
             </a:r>
           </a:p>
         </p:txBody>
@@ -11874,7 +11874,7 @@
                 <a:ea typeface="Arial" pitchFamily="34" charset="-122"/>
                 <a:cs typeface="Arial" pitchFamily="34" charset="-120"/>
               </a:rPr>
-              <a:t>Zusatzfolien für die 20-Minuten-Variante und für Rückfragen</a:t>
+              <a:t>Zusatzfolien für Rückfragen</a:t>
             </a:r>
             <a:endParaRPr lang="en-US" sz="1900" dirty="0"/>
           </a:p>

</xml_diff>

<commit_message>
Vortrag 4: Teil (a) mit einfachen Alltagsbildern erklärt
Sprechtext, Stichworte und Notizen der Folien 4 und 5 neu formuliert
(Maschine, Küche, Fliessband, Pez-Spender, Sicherheitsnetz), Länge unverändert ca. 4.6 Minuten.

Co-Authored-By: Claude Opus 5.5 <noreply@anthropic.com>
Claude-Session: https://claude.ai/code/session_013YcN7q2EjK91BTrikonwXA
</commit_message>
<xml_diff>
--- a/vortrag4/Vortrag4_Praesentation.pptx
+++ b/vortrag4/Vortrag4_Praesentation.pptx
@@ -3128,7 +3128,7 @@
           <a:lstStyle/>
           <a:p>
             <a:r>
-              <a:t>[Leorat Krasniqi (Sprecher/in 1)] McKinney nennt eine einfache Faustregel: Code, den man mehr als einmal braucht, gehört in eine Funktion. Eine Funktion wird mit def deklariert und gibt ihr Ergebnis mit return zurück. Fehlt das return, gibt Python automatisch None zurück. Man unterscheidet Positionsargumente, die über ihre Reihenfolge zugeordnet werden, und Keyword-Argumente, die einen Namen und oft einen Standardwert haben. Keyword-Argumente müssen nach den Positionsargumenten stehen, untereinander ist ihre Reihenfolge aber egal. Rechts sehen Sie unsere Funktion vierfeldertafel: Ohne Angabe gilt fachbereich gleich None, dann wird die Tafel über alle Bewerbungen gebildet. Mit fachbereich gleich A nur für Fachbereich A. Variablen in einer Funktion leben in einem lokalen Namensraum, der beim Aufruf entsteht und danach wieder verschwindet. Globale Variablen vermeiden wir bewusst. Und eine Funktion kann scheinbar mehrere Werte zurückgeben. Tatsächlich ist es ein Tupel, das wir beim Aufruf entpacken, wie unten bei kennzahlen: quote, anteil gleich kennzahlen von 89, 19 und 1 835.</a:t>
+              <a:t>[Leorat Krasniqi (Sprecher/in 1)] Eine Funktion kann man sich wie eine Maschine vorstellen: Zutaten rein, Ergebnis raus. Man baut sie einmal und kann sie beliebig oft benutzen. Darum sagt McKinney: Was man mehr als einmal braucht, gehört in eine Funktion. Mit def bauen wir die Maschine, mit return kommt das Ergebnis heraus. Fehlt return, kommt None heraus, also nichts. Die Zutaten heissen Argumente. Positionsargumente muss man immer angeben. Keyword-Argumente haben eine Voreinstellung: Bei unserer Funktion vierfeldertafel steht fachbereich auf None. Ohne Angabe rechnet sie mit allen Bewerbungen, mit fachbereich gleich A nur mit Fachbereich A. Was in der Funktion passiert, bleibt dort, wie in einer geschlossenen Küche: Die Variable bewerbungen gibt es nur während des Aufrufs. Das ist der lokale Namensraum, darum vermeiden wir globale Variablen. Und unten: kennzahlen gibt scheinbar zwei Werte zurück. In Wahrheit ist es ein Paket, ein Tupel, das wir in quote und anteil auspacken. Für die Frauen in Fachbereich A ergibt das 82.4 und 5.9 Prozent.</a:t>
             </a:r>
           </a:p>
         </p:txBody>
@@ -3214,7 +3214,7 @@
           <a:lstStyle/>
           <a:p>
             <a:r>
-              <a:t>[Leorat Krasniqi (Sprecher/in 1)] Vier weitere Konzepte aus Abschnitt 3.2. Erstens: Funktionen sind Objekte. Wir speichern unsere Bereinigungsschritte in einer Liste und wenden sie nacheinander auf jeden Wert aus Tabelle 4 an. So wird aus dem Text «82.4%» die Zahl 0.824. Der Vorteil: Kommt ein weiterer Bereinigungsschritt dazu, fügen wir ihn nur in die Liste ein, die Funktion selbst bleibt gleich. Zweitens: Lambda-Funktionen sind anonyme Einzeiler, ideal, wenn man eine Funktion als Argument übergibt. Mit partial legen wir ein Argument fest, das nennt man Currying: pruefe_streng ist derselbe Test, nur mit einem Signifikanzniveau von 1 Prozent. Drittens: Ein Generator liefert mit yield die Ergebnisse erst dann, wenn sie angefordert werden, bei uns Fachbereich für Fachbereich. Viertens: Bei der Ausnahmebehandlung fangen wir nur den erwarteten Fehler ab, den ValueError bei einem Tippfehler in der Tabelle. Andere Fehler sollen sichtbar bleiben. Damit übergebe ich an Teoman.</a:t>
+              <a:t>[Leorat Krasniqi (Sprecher/in 1)] Vier weitere Konzepte. Erstens: Funktionen sind Objekte. Wir legen sie wie Stationen eines Fliessbands in eine Liste. Jeder Wert aus Tabelle 4 läuft durch: Leerzeichen weg, Prozentzeichen weg, in eine Zahl umwandeln. So wird aus dem Text «82.4%» die Zahl 0.824. Zweitens: Ein Lambda ist eine Mini-Funktion in einer Zeile, bei uns für die Prozentanzeige. Mit partial bauen wir eine vorprogrammierte Taste: derselbe Test, nur fest mit einem Signifikanzniveau von 1 Prozent. Das nennt man Currying. Drittens: Ein Generator funktioniert wie ein Pez-Spender. Mit yield gibt er ein Ergebnis nach dem anderen heraus, Fachbereich für Fachbereich, immer erst, wenn man es braucht. Viertens: try und except sind ein Sicherheitsnetz. Tippt man zum Beispiel 82,4 mit Komma, gibt es eine klare Fehlermeldung statt einer falschen Zahl. Andere Fehler fangen wir bewusst nicht ab, sie sollen sichtbar bleiben. Damit übergebe ich an Teoman.</a:t>
             </a:r>
           </a:p>
         </p:txBody>

</xml_diff>

<commit_message>
Vortrag 4: Sprechtext Teil (a) fachlicher formuliert
Fachbegriff zuerst, dann das Bild; Lazy Evaluation statt Pez-Spender.

Co-Authored-By: Claude Opus 5.5 <noreply@anthropic.com>
Claude-Session: https://claude.ai/code/session_013YcN7q2EjK91BTrikonwXA
</commit_message>
<xml_diff>
--- a/vortrag4/Vortrag4_Praesentation.pptx
+++ b/vortrag4/Vortrag4_Praesentation.pptx
@@ -3128,7 +3128,7 @@
           <a:lstStyle/>
           <a:p>
             <a:r>
-              <a:t>[Leorat Krasniqi (Sprecher/in 1)] Eine Funktion kann man sich wie eine Maschine vorstellen: Zutaten rein, Ergebnis raus. Man baut sie einmal und kann sie beliebig oft benutzen. Darum sagt McKinney: Was man mehr als einmal braucht, gehört in eine Funktion. Mit def bauen wir die Maschine, mit return kommt das Ergebnis heraus. Fehlt return, kommt None heraus, also nichts. Die Zutaten heissen Argumente. Positionsargumente muss man immer angeben. Keyword-Argumente haben eine Voreinstellung: Bei unserer Funktion vierfeldertafel steht fachbereich auf None. Ohne Angabe rechnet sie mit allen Bewerbungen, mit fachbereich gleich A nur mit Fachbereich A. Was in der Funktion passiert, bleibt dort, wie in einer geschlossenen Küche: Die Variable bewerbungen gibt es nur während des Aufrufs. Das ist der lokale Namensraum, darum vermeiden wir globale Variablen. Und unten: kennzahlen gibt scheinbar zwei Werte zurück. In Wahrheit ist es ein Paket, ein Tupel, das wir in quote und anteil auspacken. Für die Frauen in Fachbereich A ergibt das 82.4 und 5.9 Prozent.</a:t>
+              <a:t>[Leorat Krasniqi (Sprecher/in 1)] Eine Funktion ist ein wiederverwendbarer Codeblock. Man kann sie sich wie eine Maschine vorstellen: Zutaten rein, Ergebnis raus. Man baut sie einmal und kann sie beliebig oft benutzen. Darum sagt McKinney: Was man mehr als einmal braucht, gehört in eine Funktion. Mit def bauen wir die Maschine, mit return kommt das Ergebnis heraus. Fehlt return, kommt None heraus, also nichts. Die Zutaten heissen Argumente. Positionsargumente muss man immer angeben. Keyword-Argumente haben eine Voreinstellung: Bei unserer Funktion vierfeldertafel steht fachbereich auf None. Ohne Angabe rechnet sie mit allen Bewerbungen, mit fachbereich gleich A nur mit Fachbereich A. Was in der Funktion passiert, bleibt dort, wie in einer geschlossenen Küche: Die Variable bewerbungen gibt es nur während des Aufrufs. Das ist der lokale Namensraum, darum vermeiden wir globale Variablen. Und unten: kennzahlen gibt scheinbar zwei Werte zurück. In Wahrheit ist es ein Paket, ein Tupel, das wir in quote und anteil auspacken. Für die Frauen in Fachbereich A ergibt das 82.4 und 5.9 Prozent.</a:t>
             </a:r>
           </a:p>
         </p:txBody>
@@ -3214,7 +3214,7 @@
           <a:lstStyle/>
           <a:p>
             <a:r>
-              <a:t>[Leorat Krasniqi (Sprecher/in 1)] Vier weitere Konzepte. Erstens: Funktionen sind Objekte. Wir legen sie wie Stationen eines Fliessbands in eine Liste. Jeder Wert aus Tabelle 4 läuft durch: Leerzeichen weg, Prozentzeichen weg, in eine Zahl umwandeln. So wird aus dem Text «82.4%» die Zahl 0.824. Zweitens: Ein Lambda ist eine Mini-Funktion in einer Zeile, bei uns für die Prozentanzeige. Mit partial bauen wir eine vorprogrammierte Taste: derselbe Test, nur fest mit einem Signifikanzniveau von 1 Prozent. Das nennt man Currying. Drittens: Ein Generator funktioniert wie ein Pez-Spender. Mit yield gibt er ein Ergebnis nach dem anderen heraus, Fachbereich für Fachbereich, immer erst, wenn man es braucht. Viertens: try und except sind ein Sicherheitsnetz. Tippt man zum Beispiel 82,4 mit Komma, gibt es eine klare Fehlermeldung statt einer falschen Zahl. Andere Fehler fangen wir bewusst nicht ab, sie sollen sichtbar bleiben. Damit übergebe ich an Teoman.</a:t>
+              <a:t>[Leorat Krasniqi (Sprecher/in 1)] Vier weitere Konzepte. Erstens: Funktionen sind Objekte. Wir legen sie wie Stationen eines Fliessbands in eine Liste. Jeder Wert aus Tabelle 4 läuft durch: Leerzeichen weg, Prozentzeichen weg, in eine Zahl umwandeln. So wird aus dem Text «82.4%» die Zahl 0.824. Zweitens: Ein Lambda ist eine anonyme Funktion in einer Zeile, bei uns für die Prozentanzeige. Mit partial legen wir ein Argument fest, das nennt man Currying: pruefe_streng ist derselbe Test, nur fest mit einem Signifikanzniveau von 1 Prozent. Drittens: Ein Generator liefert mit yield ein Ergebnis nach dem anderen, Fachbereich für Fachbereich, immer erst, wenn es gebraucht wird. Das nennt man Lazy Evaluation. Viertens: try und except sind ein Sicherheitsnetz. Tippt man zum Beispiel 82,4 mit Komma, gibt es eine klare Fehlermeldung statt einer falschen Zahl. Andere Fehler fangen wir bewusst nicht ab, sie sollen sichtbar bleiben. Damit übergebe ich an Teoman.</a:t>
             </a:r>
           </a:p>
         </p:txBody>

</xml_diff>